<commit_message>
docs: pitch deck rebuilt on the reconstructed template (brand look, new UI screenshots, scalability and feasibility, verified claims, current benchmark)
Co-Authored-By: Claude Sonnet 5.5 <noreply@anthropic.com>
</commit_message>
<xml_diff>
--- a/docs/submission/Scam-Shield-deck.pptx
+++ b/docs/submission/Scam-Shield-deck.pptx
@@ -866,7 +866,7 @@
           <a:lstStyle/>
           <a:p>
             <a:r>
-              <a:t>Every figure on this slide is an ESTIMATE with stated assumptions, read from Google's published pages on 18 Oct 2026; none is a quote. Gemini: Vertex AI pricing page https://cloud.google.com/vertex-ai/generative-ai/pricing lists Gemini 3.7 Flash (global) at US$0.75 per 1M input tokens and US$3.75 per 1M output tokens through 31 Dec 2026, and US$1.50 / US$7.50 from 1 Jan 2027 (input includes text, image, video and audio; output includes reasoning). Assumption (ours, not measured): about 2,500 input and 500 output tokens per text check, up to 1,500 output tokens if reasoning tokens are counted. Low = 2,500 x 0.75/1M + 500 x 3.75/1M = US$0.0038; high = 2,500 x 0.75/1M + 1,500 x 3.75/1M = US$0.0075. Image and audio checks use more input tokens. At the 3,000 checks per day cap that is about US$11 to 23 per day. Cloud Run: https://cloud.google.com/run/pricing , asia-south1 (Mumbai) is Tier 1; idle minimum-instance time is US$0.0000025 per vCPU-second and per GiB-second (request-based billing). 1 vCPU + 1 GiB x 2,592,000 s (30 days) x US$0.0000025 x 2 = US$12.96 per month before any free tier; active request time is billed on top and is small. Deployed API settings (scripts/deploy.sh): 1 vCPU, 1 GiB, min 1, max 5 instances. Free tier claims for Firebase Hosting, Auth, Firestore and Storage are expectations at this volume, not measured bills. Budget alert (Rs 1,000 per month; 50/90/100%) is recorded in DETAILS.md. Currency: USD as listed by Google; no INR conversion is claimed.</a:t>
+              <a:t>Every figure on this slide is an ESTIMATE with stated assumptions, read from Google's published pages on 18 Oct 2026; none is a quote. Gemini: Vertex AI pricing page https://cloud.google.com/vertex-ai/generative-ai/pricing lists Gemini 3.7 Flash (global) at US$0.75 per 1M input tokens and US$3.75 per 1M output tokens through 31 Dec 2026, and US$1.50 / US$7.50 from 1 Jan 2027 (input includes text, image, video and audio; output includes reasoning). Assumption (ours, not measured): about 2,500 input and 500 output tokens per text check, up to 1,500 output tokens if reasoning tokens are counted. Low = 2,500 x 0.75/1M + 500 x 3.75/1M = US$0.0038; high = 2,500 x 0.75/1M + 1,500 x 3.75/1M = US$0.0075. Image and audio checks use more input tokens. At the 3,000 checks per day cap that is about US$11 to 23 per day. Cloud Run: https://cloud.google.com/run/pricing , asia-south1 (Mumbai) is Tier 1; idle minimum-instance time is US$0.0000025 per vCPU-second and per GiB-second (request-based billing). 1 vCPU + 1 GiB x 2,592,000 s (30 days) x US$0.0000025 x 2 = US$12.96 per month before any free tier; active request time is billed on top and is small. Deployed API settings (scripts/deploy.sh): 1 vCPU, 1 GiB, min 1, max 5 instances. Free tier claims for Firebase Hosting, Auth, Firestore and Storage are expectations at this volume, not measured bills. Budget alert (Rs 1,000 per month; 50/90/100%): OWNER TO CONFIRM it has been created in Google Cloud Billing, then change 'Planned:' on this slide to 'Set:' (command in docs/setup-notes.md). Currency: USD as listed by Google; no INR conversion is claimed.</a:t>
             </a:r>
           </a:p>
         </p:txBody>
@@ -1044,7 +1044,7 @@
           <a:lstStyle/>
           <a:p>
             <a:r>
-              <a:t>English run (2026-10-17): accuracy 100.0%, scam recall 100.0%, false-positive rate 0.0%, scam type correct 96.2%, errors 0 (eval/results/latest.md). Hindi run (2026-10-17): accuracy 100.0%, recall 100.0%, false positives 0.0%, type correct 100.0% (eval/results/run-hindi.md). Both runs were made against the live app with 50 synthetic cases in eval/cases.jsonl (45 text, 4 image, 1 audio; 26 scams over 13 scam types, 24 genuine), concurrency 1. Latency is wall-clock from request to response. The model for these runs was gemini-3.7-flash: eval/results/latest.md is identical to eval/results/run-gemini-3.7-flash-17oct.md, and gemini-3.7-flash is the API default (api/src/index.ts). Earlier comparison on gemini-3.8-flash (2026-10-16): accuracy 98.0%, false-positive rate 4.2%, image p95 33.8 s; it was slower and rate-limited on this project, so the default is gemini-3.7-flash. The first benchmark run exposed a real bug (the model did not know today's date and flagged 2026 dates as future); it was fixed and re-measured. This is a small synthetic sanity check, not a guarantee of real-world accuracy.</a:t>
+              <a:t>English run (2026-10-17): accuracy 100.0%, scam recall 100.0%, false-positive rate 0.0%, scam type correct 100.0%, errors 0 (eval/results/latest.md). Hindi run (2026-10-17): accuracy 100.0%, recall 100.0%, false positives 0.0%, type correct 100.0% (eval/results/run-hindi.md). Both runs were made against the live app with 50 synthetic cases in eval/cases.jsonl (45 text, 4 image, 1 audio; 26 scams over 13 scam types, 24 genuine), concurrency 1. Latency is wall-clock from request to response. The model for these runs was gemini-3.7-flash: eval/results/latest.md is identical to eval/results/run-gemini-3.7-flash-17oct.md, and gemini-3.7-flash is the API default (api/src/index.ts). Earlier comparison on gemini-3.8-flash (2026-10-16): accuracy 98.0%, false-positive rate 4.2%, image p95 33.8 s; it was slower and rate-limited on this project, so the default is gemini-3.7-flash. The first benchmark run exposed a real bug (the model did not know today's date and flagged 2026 dates as future); it was fixed and re-measured. This is a small synthetic sanity check, not a guarantee of real-world accuracy.</a:t>
             </a:r>
           </a:p>
         </p:txBody>
@@ -8416,7 +8416,7 @@
                 </a:solidFill>
                 <a:latin typeface="Avenir Next"/>
               </a:rPr>
-              <a:t>Rs 1,000 per month, with alerts at 50%, 90% and 100% of the budget.</a:t>
+              <a:t>Planned: Rs 1,000 per month, alerts at 50%, 90% and 100% of the budget. A hard daily cap already applies.</a:t>
             </a:r>
           </a:p>
         </p:txBody>
@@ -9780,7 +9780,7 @@
                 </a:solidFill>
                 <a:latin typeface="Avenir Next Demi Bold"/>
               </a:rPr>
-              <a:t>96.2%</a:t>
+              <a:t>100.0%</a:t>
             </a:r>
           </a:p>
         </p:txBody>
@@ -10124,7 +10124,7 @@
                           </a:solidFill>
                           <a:latin typeface="Avenir Next"/>
                         </a:rPr>
-                        <a:t>12.9 s</a:t>
+                        <a:t>20.8 s</a:t>
                       </a:r>
                     </a:p>
                   </a:txBody>
@@ -10241,7 +10241,7 @@
                           </a:solidFill>
                           <a:latin typeface="Avenir Next"/>
                         </a:rPr>
-                        <a:t>8.9 s</a:t>
+                        <a:t>7.3 s</a:t>
                       </a:r>
                     </a:p>
                   </a:txBody>
@@ -10264,7 +10264,7 @@
                           </a:solidFill>
                           <a:latin typeface="Avenir Next"/>
                         </a:rPr>
-                        <a:t>9.5 s</a:t>
+                        <a:t>8.7 s</a:t>
                       </a:r>
                     </a:p>
                   </a:txBody>
@@ -10381,7 +10381,7 @@
                           </a:solidFill>
                           <a:latin typeface="Avenir Next"/>
                         </a:rPr>
-                        <a:t>14.2 s</a:t>
+                        <a:t>10.3 s</a:t>
                       </a:r>
                     </a:p>
                   </a:txBody>
@@ -10404,7 +10404,7 @@
                           </a:solidFill>
                           <a:latin typeface="Avenir Next"/>
                         </a:rPr>
-                        <a:t>14.2 s</a:t>
+                        <a:t>10.3 s</a:t>
                       </a:r>
                     </a:p>
                   </a:txBody>

</xml_diff>

<commit_message>
docs: budget alert is set (deck slide 10, setup notes)
Co-Authored-By: Claude Sonnet 5.5 <noreply@anthropic.com>
</commit_message>
<xml_diff>
--- a/docs/submission/Scam-Shield-deck.pptx
+++ b/docs/submission/Scam-Shield-deck.pptx
@@ -866,7 +866,7 @@
           <a:lstStyle/>
           <a:p>
             <a:r>
-              <a:t>Every figure on this slide is an ESTIMATE with stated assumptions, read from Google's published pages on 18 Oct 2026; none is a quote. Gemini: Vertex AI pricing page https://cloud.google.com/vertex-ai/generative-ai/pricing lists Gemini 3.7 Flash (global) at US$0.75 per 1M input tokens and US$3.75 per 1M output tokens through 31 Dec 2026, and US$1.50 / US$7.50 from 1 Jan 2027 (input includes text, image, video and audio; output includes reasoning). Assumption (ours, not measured): about 2,500 input and 500 output tokens per text check, up to 1,500 output tokens if reasoning tokens are counted. Low = 2,500 x 0.75/1M + 500 x 3.75/1M = US$0.0038; high = 2,500 x 0.75/1M + 1,500 x 3.75/1M = US$0.0075. Image and audio checks use more input tokens. At the 3,000 checks per day cap that is about US$11 to 23 per day. Cloud Run: https://cloud.google.com/run/pricing , asia-south1 (Mumbai) is Tier 1; idle minimum-instance time is US$0.0000025 per vCPU-second and per GiB-second (request-based billing). 1 vCPU + 1 GiB x 2,592,000 s (30 days) x US$0.0000025 x 2 = US$12.96 per month before any free tier; active request time is billed on top and is small. Deployed API settings (scripts/deploy.sh): 1 vCPU, 1 GiB, min 1, max 5 instances. Free tier claims for Firebase Hosting, Auth, Firestore and Storage are expectations at this volume, not measured bills. Budget alert (Rs 1,000 per month; 50/90/100%): OWNER TO CONFIRM it has been created in Google Cloud Billing, then change 'Planned:' on this slide to 'Set:' (command in docs/setup-notes.md). Currency: USD as listed by Google; no INR conversion is claimed.</a:t>
+              <a:t>Every figure on this slide is an ESTIMATE with stated assumptions, read from Google's published pages on 18 Oct 2026; none is a quote. Gemini: Vertex AI pricing page https://cloud.google.com/vertex-ai/generative-ai/pricing lists Gemini 3.7 Flash (global) at US$0.75 per 1M input tokens and US$3.75 per 1M output tokens through 31 Dec 2026, and US$1.50 / US$7.50 from 1 Jan 2027 (input includes text, image, video and audio; output includes reasoning). Assumption (ours, not measured): about 2,500 input and 500 output tokens per text check, up to 1,500 output tokens if reasoning tokens are counted. Low = 2,500 x 0.75/1M + 500 x 3.75/1M = US$0.0038; high = 2,500 x 0.75/1M + 1,500 x 3.75/1M = US$0.0075. Image and audio checks use more input tokens. At the 3,000 checks per day cap that is about US$11 to 23 per day. Cloud Run: https://cloud.google.com/run/pricing , asia-south1 (Mumbai) is Tier 1; idle minimum-instance time is US$0.0000025 per vCPU-second and per GiB-second (request-based billing). 1 vCPU + 1 GiB x 2,592,000 s (30 days) x US$0.0000025 x 2 = US$12.96 per month before any free tier; active request time is billed on top and is small. Deployed API settings (scripts/deploy.sh): 1 vCPU, 1 GiB, min 1, max 5 instances. Free tier claims for Firebase Hosting, Auth, Firestore and Storage are expectations at this volume, not measured bills. Budget alert (Rs 1,000 per month; 50/90/100%) created by the owner in Google Cloud Billing on 18 Oct 2026 (budget name 'Scam Shield', applies to this project). Currency: USD as listed by Google; no INR conversion is claimed.</a:t>
             </a:r>
           </a:p>
         </p:txBody>
@@ -8416,7 +8416,7 @@
                 </a:solidFill>
                 <a:latin typeface="Avenir Next"/>
               </a:rPr>
-              <a:t>Planned: Rs 1,000 per month, alerts at 50%, 90% and 100% of the budget. A hard daily cap already applies.</a:t>
+              <a:t>Set: Rs 1,000 per month on this project, alerts at 50%, 90% and 100% of the budget. A hard daily cap also applies.</a:t>
             </a:r>
           </a:p>
         </p:txBody>

</xml_diff>

<commit_message>
feat: plain-text technology names and trademark note on the site; icons only in deck/video architecture with footnote
Co-Authored-By: Claude Sonnet 5.5 <noreply@anthropic.com>
</commit_message>
<xml_diff>
--- a/docs/submission/Scam-Shield-deck.pptx
+++ b/docs/submission/Scam-Shield-deck.pptx
@@ -2015,7 +2015,7 @@
           <a:lstStyle/>
           <a:p>
             <a:r>
-              <a:t>Architecture as deployed (scripts/deploy.sh, region asia-south1): Firebase Hosting serves the React PWA and forwards /api/** to the Cloud Run API. The API is stateless (1 vCPU, 1 GiB, concurrency 20, min 1 and max 5 instances) and calls Gemini on Vertex AI, Firestore and the private link scanner. The link scanner (2 vCPU, 2 GiB, min 0, max 3 instances, private, no unauthenticated access) runs under its own service account with no project roles and can be invoked only by the API's service account. Cloud Storage uploads are deleted after 7 days by a lifecycle rule (scripts/storage-lifecycle.json). Limits: 30 per user per day, 60 per IP per minute, 3,000 per day overall. Product logos are the official Google Cloud, Firebase, Gemini and Vertex AI marks (web/public/brand/third-party). Uploads go straight from the browser to Storage.</a:t>
+              <a:t>Architecture as deployed (scripts/deploy.sh, region asia-south1): Firebase Hosting serves the React PWA and forwards /api/** to the Cloud Run API. The API is stateless (1 vCPU, 1 GiB, concurrency 20, min 1 and max 5 instances) and calls Gemini on Vertex AI, Firestore and the private link scanner. The link scanner (2 vCPU, 2 GiB, min 0, max 3 instances, private, no unauthenticated access) runs under its own service account with no project roles and can be invoked only by the API's service account. Cloud Storage uploads are deleted after 7 days by a lifecycle rule (scripts/storage-lifecycle.json). Limits: 30 per user per day, 60 per IP per minute, 3,000 per day overall. Product icons are shown only to identify the technologies used; no endorsement by Google is implied (trademark footnote on the slide). The icon files are kept in docs/brand/third-party. Uploads go straight from the browser to Storage.</a:t>
             </a:r>
           </a:p>
         </p:txBody>
@@ -22853,6 +22853,51 @@
           </a:fontRef>
         </p:style>
       </p:cxnSp>
+      <p:sp>
+        <p:nvSpPr>
+          <p:cNvPr id="152" name="TextBox 151"/>
+          <p:cNvSpPr txBox="1"/>
+          <p:nvPr/>
+        </p:nvSpPr>
+        <p:spPr>
+          <a:xfrm>
+            <a:off x="365760" y="4937760"/>
+            <a:ext cx="8412480" cy="128016"/>
+          </a:xfrm>
+          <a:prstGeom prst="rect">
+            <a:avLst/>
+          </a:prstGeom>
+          <a:noFill/>
+        </p:spPr>
+        <p:txBody>
+          <a:bodyPr wrap="square" anchor="ctr" lIns="0" rIns="0" tIns="0" bIns="0">
+            <a:spAutoFit/>
+          </a:bodyPr>
+          <a:lstStyle/>
+          <a:p>
+            <a:pPr algn="l">
+              <a:lnSpc>
+                <a:spcPct val="100000"/>
+              </a:lnSpc>
+              <a:spcBef>
+                <a:spcPts val="0"/>
+              </a:spcBef>
+              <a:spcAft>
+                <a:spcPts val="0"/>
+              </a:spcAft>
+            </a:pPr>
+            <a:r>
+              <a:rPr sz="750" i="0">
+                <a:solidFill>
+                  <a:srgbClr val="5B6778"/>
+                </a:solidFill>
+                <a:latin typeface="Avenir Next"/>
+              </a:rPr>
+              <a:t>Product names and icons are trademarks of Google LLC, shown only to identify the technologies used. No endorsement or affiliation implied.</a:t>
+            </a:r>
+          </a:p>
+        </p:txBody>
+      </p:sp>
     </p:spTree>
   </p:cSld>
   <p:clrMapOvr>
@@ -24866,6 +24911,51 @@
                 <a:latin typeface="Avenir Next"/>
               </a:rPr>
               <a:t>, plus a 50-case live benchmark</a:t>
+            </a:r>
+          </a:p>
+        </p:txBody>
+      </p:sp>
+      <p:sp>
+        <p:nvSpPr>
+          <p:cNvPr id="156" name="TextBox 155"/>
+          <p:cNvSpPr txBox="1"/>
+          <p:nvPr/>
+        </p:nvSpPr>
+        <p:spPr>
+          <a:xfrm>
+            <a:off x="365760" y="4937760"/>
+            <a:ext cx="8412480" cy="128016"/>
+          </a:xfrm>
+          <a:prstGeom prst="rect">
+            <a:avLst/>
+          </a:prstGeom>
+          <a:noFill/>
+        </p:spPr>
+        <p:txBody>
+          <a:bodyPr wrap="square" anchor="ctr" lIns="0" rIns="0" tIns="0" bIns="0">
+            <a:spAutoFit/>
+          </a:bodyPr>
+          <a:lstStyle/>
+          <a:p>
+            <a:pPr algn="l">
+              <a:lnSpc>
+                <a:spcPct val="100000"/>
+              </a:lnSpc>
+              <a:spcBef>
+                <a:spcPts val="0"/>
+              </a:spcBef>
+              <a:spcAft>
+                <a:spcPts val="0"/>
+              </a:spcAft>
+            </a:pPr>
+            <a:r>
+              <a:rPr sz="750" i="0">
+                <a:solidFill>
+                  <a:srgbClr val="5B6778"/>
+                </a:solidFill>
+                <a:latin typeface="Avenir Next"/>
+              </a:rPr>
+              <a:t>Product names and icons are trademarks of Google LLC, shown only to identify the technologies used. No endorsement or affiliation implied.</a:t>
             </a:r>
           </a:p>
         </p:txBody>

</xml_diff>

<commit_message>
fix(deck): font/layout audit, budget Rs 2,000, India scam types, benchmark honesty, 595 tests
Co-Authored-By: Claude Sonnet 5.5 <noreply@anthropic.com>
</commit_message>
<xml_diff>
--- a/docs/submission/Scam-Shield-deck.pptx
+++ b/docs/submission/Scam-Shield-deck.pptx
@@ -866,7 +866,7 @@
           <a:lstStyle/>
           <a:p>
             <a:r>
-              <a:t>Every figure on this slide is an ESTIMATE with stated assumptions, read from Google's published pages on 18 Oct 2026; none is a quote. Gemini: Vertex AI pricing page https://cloud.google.com/vertex-ai/generative-ai/pricing lists Gemini 3.7 Flash (global) at US$0.75 per 1M input tokens and US$3.75 per 1M output tokens through 31 Dec 2026, and US$1.50 / US$7.50 from 1 Jan 2027 (input includes text, image, video and audio; output includes reasoning). Assumption (ours, not measured): about 2,500 input and 500 output tokens per text check, up to 1,500 output tokens if reasoning tokens are counted. Low = 2,500 x 0.75/1M + 500 x 3.75/1M = US$0.0038; high = 2,500 x 0.75/1M + 1,500 x 3.75/1M = US$0.0075. Image and audio checks use more input tokens. At the 3,000 checks per day cap that is about US$11 to 23 per day. Cloud Run: https://cloud.google.com/run/pricing , asia-south1 (Mumbai) is Tier 1; idle minimum-instance time is US$0.0000025 per vCPU-second and per GiB-second (request-based billing). 1 vCPU + 1 GiB x 2,592,000 s (30 days) x US$0.0000025 x 2 = US$12.96 per month before any free tier; active request time is billed on top and is small. Deployed API settings (scripts/deploy.sh): 1 vCPU, 1 GiB, min 1, max 5 instances. Free tier claims for Firebase Hosting, Auth, Firestore and Storage are expectations at this volume, not measured bills. Budget alert (Rs 1,000 per month; 50/90/100%) created by the owner in Google Cloud Billing on 18 Oct 2026 (budget name 'Scam Shield', applies to this project). Currency: USD as listed by Google; no INR conversion is claimed.</a:t>
+              <a:t>Every figure on this slide is an ESTIMATE with stated assumptions, read from Google's published pages on 18 Oct 2026; none is a quote. Gemini: Vertex AI pricing page https://cloud.google.com/vertex-ai/generative-ai/pricing lists Gemini 3.7 Flash (global) at US$0.75 per 1M input tokens and US$3.75 per 1M output tokens through 31 Dec 2026, and US$1.50 / US$7.50 from 1 Jan 2027 (input includes text, image, video and audio; output includes reasoning). Assumption (ours, not measured): about 2,500 input and 500 output tokens per text check, up to 1,500 output tokens if reasoning tokens are counted. Low = 2,500 x 0.75/1M + 500 x 3.75/1M = US$0.0038; high = 2,500 x 0.75/1M + 1,500 x 3.75/1M = US$0.0075. Image and audio checks use more input tokens. At the 3,000 checks per day cap that is about US$11 to 23 per day. Cloud Run: https://cloud.google.com/run/pricing , asia-south1 (Mumbai) is Tier 1; idle minimum-instance time is US$0.0000025 per vCPU-second and per GiB-second (request-based billing). 1 vCPU + 1 GiB x 2,592,000 s (30 days) x US$0.0000025 x 2 = US$12.96 per month before any free tier; active request time is billed on top and is small. Deployed API settings (scripts/deploy.sh): 1 vCPU, 1 GiB, min 1, max 5 instances. Free tier claims for Firebase Hosting, Auth, Firestore and Storage are expectations at this volume, not measured bills. Budget alert: Rs 2,000 per month, alerts at 50%, 90% and 100% (Rs 1,000, Rs 1,800, Rs 2,000), set by the owner in Google Cloud Billing (budget name 'Scam Shield', applies to this project). A budget alert only notifies; it does not cap or stop spending. The real cost control is the per-user (30 per day), per-IP (60 per minute) and global (3,000 per day) limits in the API. Currency: USD as listed by Google; no INR conversion is claimed.</a:t>
             </a:r>
           </a:p>
         </p:txBody>
@@ -1044,7 +1044,7 @@
           <a:lstStyle/>
           <a:p>
             <a:r>
-              <a:t>English run (2026-10-17): accuracy 100.0%, scam recall 100.0%, false-positive rate 0.0%, scam type correct 100.0%, errors 0 (eval/results/latest.md). Hindi run (2026-10-17): accuracy 100.0%, recall 100.0%, false positives 0.0%, type correct 100.0% (eval/results/run-hindi.md). Both runs were made against the live app with 50 synthetic cases in eval/cases.jsonl (45 text, 4 image, 1 audio; 26 scams over 13 scam types, 24 genuine), concurrency 1. Latency is wall-clock from request to response. The model for these runs was gemini-3.7-flash: eval/results/latest.md is identical to eval/results/run-gemini-3.7-flash-17oct.md, and gemini-3.7-flash is the API default (api/src/index.ts). Earlier comparison on gemini-3.8-flash (2026-10-16): accuracy 98.0%, false-positive rate 4.2%, image p95 33.8 s; it was slower and rate-limited on this project, so the default is gemini-3.7-flash. The first benchmark run exposed a real bug (the model did not know today's date and flagged 2026 dates as future); it was fixed and re-measured. This is a small synthetic sanity check, not a guarantee of real-world accuracy.</a:t>
+              <a:t>English run (2026-10-17): accuracy 100.0%, scam recall 100.0%, false-positive rate 0.0%, scam type correct 100.0%, errors 0 (eval/results/latest.md). Hindi run (2026-10-17): accuracy 100.0%, recall 100.0%, false positives 0.0%, type correct 100.0% (eval/results/run-hindi.md). Both runs were made against the live app with 50 synthetic cases in eval/cases.jsonl (45 text, 4 image, 1 audio; 26 scams over 13 scam types, 24 genuine), concurrency 1. Latency is wall-clock from request to response. The cases are few and were written by the authors, so real traffic will differ. The model for these runs was gemini-3.7-flash: eval/results/latest.md is identical to eval/results/run-gemini-3.7-flash-17oct.md, and gemini-3.7-flash is the API default (api/src/index.ts). Earlier comparison on gemini-3.8-flash (2026-10-16): accuracy 98.0%, false-positive rate 4.2%, image p95 33.8 s; that is why the default is gemini-3.7-flash, with gemini-2.5-flash as fallback. The first benchmark run exposed a real bug (the model did not know today's date and flagged 2026 dates as future); it was fixed and re-measured. This is a small synthetic sanity check, not a guarantee of real-world accuracy.</a:t>
             </a:r>
           </a:p>
         </p:txBody>
@@ -1133,7 +1133,7 @@
           <a:lstStyle/>
           <a:p>
             <a:r>
-              <a:t>Roadmap items are plans, not shipped features. Scale story, from what is deployed today (scripts/deploy.sh): API on Cloud Run, stateless, concurrency 20, min 1 and max 5 instances; link scanner scales to zero (max 3); Firestore for the shared scam list; Firebase Hosting, Auth and Storage; per-user (30 per day), per-IP (60 per minute) and global (3,000 per day) limits; uploads auto-delete after 7 days. Raising the cap or max instances is a configuration change. Hardening ideas: Firebase App Check and a stricter per-device limit (DETAILS.md). Google Search grounding is implemented but off by default because of quota errors on this project.</a:t>
+              <a:t>Roadmap items are plans, not shipped features. Scale story, from what is deployed today (scripts/deploy.sh): API on Cloud Run, stateless, concurrency 20, min 1 and max 5 instances; link scanner scales to zero (max 3); Firestore for the shared scam list; Firebase Hosting, Auth and Storage; per-user (30 per day), per-IP (60 per minute) and global (3,000 per day) limits; uploads auto-delete after 7 days. Misinformation mode ('is this forward real?') is an idea for the same engine, not built. Raising the cap or max instances is a configuration change. Hardening ideas: Firebase App Check and a stricter per-device limit (DETAILS.md). Google Search grounding is implemented but off by default because of quota errors on this project.</a:t>
             </a:r>
           </a:p>
         </p:txBody>
@@ -1222,7 +1222,7 @@
           <a:lstStyle/>
           <a:p>
             <a:r>
-              <a:t>GitHub (public): https://github.com/Namans12/scam-shield . Live product: https://project-91260b43-6705-4176-b71.web.app (the QR code points here). The demo video link is a deliberate placeholder, highlighted in amber; the owner must replace the text '[add the public video link here]' in the PPTX and re-run scripts/build-deck.sh before submitting.</a:t>
+              <a:t>GitHub (public): https://github.com/Namans12/scam-shield . Live product: https://project-91260b43-6705-4176-b71.web.app (the QR code points here). The demo video link is a deliberate placeholder, highlighted in amber; before submitting, re-run the build with DECK_VIDEO_URL=https://... (DECK_VIDEO_URL=https://... bash scripts/build-deck.sh) or replace the text '[add the public video link here]' in the PPTX.</a:t>
             </a:r>
           </a:p>
         </p:txBody>
@@ -1311,7 +1311,7 @@
           <a:lstStyle/>
           <a:p>
             <a:r>
-              <a:t>Closing slide. The template's final 'Thank you' slide follows.</a:t>
+              <a:t>Closing slide: Scam Shield, 'Pause. Check. Then act.' The live app address is at the bottom. The template's final 'Thank you' slide follows.</a:t>
             </a:r>
           </a:p>
         </p:txBody>
@@ -1398,7 +1398,11 @@
             <a:noAutofit/>
           </a:bodyPr>
           <a:lstStyle/>
-          <a:p/>
+          <a:p>
+            <a:r>
+              <a:t>Thank you. Team Scam Shield: Naman Shrimal. Live app: https://project-91260b43-6705-4176-b71.web.app ; code: https://github.com/Namans12/scam-shield .</a:t>
+            </a:r>
+          </a:p>
         </p:txBody>
       </p:sp>
     </p:spTree>
@@ -1483,7 +1487,11 @@
             <a:noAutofit/>
           </a:bodyPr>
           <a:lstStyle/>
-          <a:p/>
+          <a:p>
+            <a:r>
+              <a:t>Organisers' instruction slide, kept exactly as in the template. Nothing to present here; the next slide starts the pitch.</a:t>
+            </a:r>
+          </a:p>
         </p:txBody>
       </p:sp>
     </p:spTree>
@@ -1570,7 +1578,7 @@
           <a:lstStyle/>
           <a:p>
             <a:r>
-              <a:t>Gen AI (the heart of the idea): one multimodal call to Gemini on Vertex AI reads the text, a screenshot or an audio clip together (Hinglish voice notes are transcribed and judged in the same call). The answer is schema-validated structured output, every red flag quotes evidence from the input, and the answer comes back in English or Hindi. Deterministic checks (scam-list hits, a QR that asks you to pay while the text says receive) can only RAISE a verdict. What Gemini does that rules cannot: judge scams nobody has reported yet, and read images and voice. Verdicts are Scam, Suspicious or No scam signs found; the app never says 'safe'. Screenshots are from the live production app, captured by scripts/screenshots.ts.</a:t>
+              <a:t>Gen AI (the heart of the idea): one multimodal call to Gemini on Vertex AI reads the text, a screenshot or an audio clip together (Hinglish voice notes are transcribed and judged in the same call). The answer is schema-validated structured output, every red flag quotes evidence from the input, and the answer comes back in English or Hindi. Deterministic checks (scam-list hits, a QR that asks you to pay while the text says receive) can only RAISE a verdict. What Gemini does that rules cannot: judge scams nobody has reported yet, and read images and voice. India-specific scam types covered by the benchmark and the examples: fake payment receipts, 'digital arrest' calls, fake KYC messages, UPI QR tricks. Careful by design: links are opened only in an isolated scanner (a private Cloud Run service), never on the person's phone; verdicts are Scam, Suspicious or No scam signs found, the app never says 'safe', and it gives guidance only. Screenshots are from the live production app, captured by scripts/screenshots.ts.</a:t>
             </a:r>
           </a:p>
         </p:txBody>
@@ -1659,7 +1667,7 @@
           <a:lstStyle/>
           <a:p>
             <a:r>
-              <a:t>Sources (all checked 18 Oct 2026, see docs/submission/sources.md): Rs 19,813 crore and about 21.78 lakh complaints reported for 2025, I4C / National Cyber Crime Reporting Portal (https://ianslive.in/indians-lose-over-rs-52976-crore-to-cyber-frauds-over-six-years-report--20260103154943; a separate Home Ministry reply is quoted as about Rs 22,495 crore, so the figure is labelled I4C data). Truecaller Scam Checker launched in India on 28 Sep 2026: checks links, numbers and messages against community reports; screenshot upload is planned, not available (https://www.techrepublic.com/article/news-truecaller-scam-checker-apac-india/). Google scam detection: Messages on Pixel 6 and newer reached India in Sep 2026; on-device call scam detection in India is limited to Pixel 9 and newer (https://androidauthority.com/pixel-scam-detection-google-messages-global-3711361, https://techcrunch.com/2025/11/20/google-steps-up-ai-scam-protection-in-india-but-gaps-remain). Chakshu (Sanchar Saathi) is a reporting facility (https://sancharsaathi.gov.in; wording to be re-verified). No recovery percentage is quoted: no national recovery rate is published. The three card headings are the organisers' standard prompts for this slide (the original prompt text was lost from the template file).</a:t>
+              <a:t>Sources (all checked 18 Oct 2026, see docs/submission/sources.md): Rs 19,813 crore and about 21.78 lakh complaints reported for 2025, I4C / National Cyber Crime Reporting Portal (https://ianslive.in/indians-lose-over-rs-52976-crore-to-cyber-frauds-over-six-years-report--20260103154943; a separate Home Ministry reply is quoted as about Rs 22,495 crore, so the figure is labelled I4C data). Truecaller Scam Checker launched in India on 28 Sep 2026: checks links, numbers and messages against community reports; screenshot upload is planned, not available (https://www.techrepublic.com/article/news-truecaller-scam-checker-apac-india/). Google scam detection: Messages on Pixel 6 and newer reached India in Sep 2026; on-device call scam detection in India is limited to Pixel 9 and newer (https://androidauthority.com/pixel-scam-detection-google-messages-global-3711361, https://techcrunch.com/2025/11/20/google-steps-up-ai-scam-protection-in-india-but-gaps-remain). Chakshu (Sanchar Saathi) is a reporting facility (https://sancharsaathi.gov.in; wording to be re-verified). No recovery percentage is quoted: no national recovery rate is published. USP wording: fake payment receipts and 'digital arrest' calls are scam types in the benchmark and the examples; UPI QR pay-vs-receive is a hard check. The three card headings are the organisers' standard prompts for this slide (the original prompt text was lost from the template file).</a:t>
             </a:r>
           </a:p>
         </p:txBody>
@@ -2104,7 +2112,7 @@
           <a:lstStyle/>
           <a:p>
             <a:r>
-              <a:t>Meaningful Gen AI: a single multimodal Gemini call on Vertex AI (api/src/gemini.ts; default model gemini-3.7-flash, automatic fallback gemini-2.5-flash, location global) reads text, image or audio. Output is schema-validated (zod schemas in shared/), every red flag quotes evidence, answers come in English or Hindi. Deterministic checks can only raise the verdict. WebMCP tools: check_message and report_scam (web/src/webmcp/registerTools.ts). Scalability: the API is a stateless Cloud Run service (concurrency 20, min 1, max 5 instances); the link scanner scales to zero (max 3) under its own service account with no roles; Firestore holds the shared scam list; Firebase Hosting, Auth and Storage in front. Test count: npm test on 18 Oct 2026 passed 592 tests (14 + 256 + 94 + 223 + 5; a further 18 live-API tests are skipped by default). Also used: Cloud Build and Artifact Registry for deploys, Cloud Text-to-Speech to generate the voice example.</a:t>
+              <a:t>Meaningful Gen AI: a single multimodal Gemini call on Vertex AI (api/src/gemini.ts; default model gemini-3.7-flash, automatic fallback gemini-2.5-flash, location global) reads text, image or audio. Output is schema-validated (zod schemas in shared/), every red flag quotes evidence, answers come in English or Hindi. Deterministic checks can only raise the verdict. WebMCP tools: check_message and report_scam (web/src/webmcp/registerTools.ts). Scalability: the API is a stateless Cloud Run service (concurrency 20, min 1, max 5 instances); the link scanner scales to zero (max 3) under its own service account with no roles; Firestore holds the shared scam list; Firebase Hosting, Auth and Storage in front. Test count: on 18 Oct 2026 the suites passed 595 tests (shared 14, web 226, linkscan 94, eval 5, api 256); a further 18 api tests need the Firestore emulator (Java) and were not run. Also used: Cloud Build and Artifact Registry for deploys, Cloud Text-to-Speech to generate the voice example.</a:t>
             </a:r>
           </a:p>
         </p:txBody>
@@ -6872,7 +6880,7 @@
             <a:r>
               <a:rPr lang="en-GB" sz="1300" i="0">
                 <a:solidFill>
-                  <a:srgbClr val="5B6778"/>
+                  <a:srgbClr val="3F4B5B"/>
                 </a:solidFill>
                 <a:latin typeface="Avenir Next"/>
                 <a:ea typeface="Google Sans Flex"/>
@@ -6912,7 +6920,7 @@
             <a:r>
               <a:rPr lang="en-GB" sz="1300" i="0">
                 <a:solidFill>
-                  <a:srgbClr val="5B6778"/>
+                  <a:srgbClr val="3F4B5B"/>
                 </a:solidFill>
                 <a:latin typeface="Avenir Next"/>
                 <a:ea typeface="Google Sans Flex"/>
@@ -6952,7 +6960,7 @@
             <a:r>
               <a:rPr lang="en-GB" sz="1300" i="0">
                 <a:solidFill>
-                  <a:srgbClr val="5B6778"/>
+                  <a:srgbClr val="3F4B5B"/>
                 </a:solidFill>
                 <a:latin typeface="Avenir Next"/>
                 <a:ea typeface="Google Sans Flex"/>
@@ -7256,11 +7264,11 @@
         <p:spPr>
           <a:xfrm>
             <a:off x="365760" y="1207008"/>
-            <a:ext cx="2679192" cy="2560320"/>
+            <a:ext cx="2679192" cy="2286000"/>
           </a:xfrm>
           <a:prstGeom prst="roundRect">
             <a:avLst>
-              <a:gd name="adj" fmla="val 2500"/>
+              <a:gd name="adj" fmla="val 2800"/>
             </a:avLst>
           </a:prstGeom>
           <a:solidFill>
@@ -7303,7 +7311,7 @@
         </p:nvSpPr>
         <p:spPr>
           <a:xfrm>
-            <a:off x="548640" y="1371600"/>
+            <a:off x="548640" y="1353312"/>
             <a:ext cx="914400" cy="237744"/>
           </a:xfrm>
           <a:prstGeom prst="roundRect">
@@ -7349,7 +7357,7 @@
         </p:nvSpPr>
         <p:spPr>
           <a:xfrm>
-            <a:off x="548640" y="1371600"/>
+            <a:off x="548640" y="1353312"/>
             <a:ext cx="914400" cy="237744"/>
           </a:xfrm>
           <a:prstGeom prst="rect">
@@ -7375,7 +7383,7 @@
               </a:spcAft>
             </a:pPr>
             <a:r>
-              <a:rPr sz="950" i="0">
+              <a:rPr sz="1000" i="0">
                 <a:solidFill>
                   <a:srgbClr val="1764E8"/>
                 </a:solidFill>
@@ -7394,7 +7402,7 @@
         </p:nvSpPr>
         <p:spPr>
           <a:xfrm>
-            <a:off x="548640" y="1709928"/>
+            <a:off x="548640" y="1664208"/>
             <a:ext cx="2313432" cy="411480"/>
           </a:xfrm>
           <a:prstGeom prst="rect">
@@ -7439,7 +7447,7 @@
         </p:nvSpPr>
         <p:spPr>
           <a:xfrm>
-            <a:off x="548640" y="2121408"/>
+            <a:off x="548640" y="2075688"/>
             <a:ext cx="2313432" cy="228600"/>
           </a:xfrm>
           <a:prstGeom prst="rect">
@@ -7465,9 +7473,9 @@
               </a:spcAft>
             </a:pPr>
             <a:r>
-              <a:rPr sz="1100" i="0">
-                <a:solidFill>
-                  <a:srgbClr val="5B6778"/>
+              <a:rPr sz="1150" i="0">
+                <a:solidFill>
+                  <a:srgbClr val="3F4B5B"/>
                 </a:solidFill>
                 <a:latin typeface="Avenir Next"/>
               </a:rPr>
@@ -7484,7 +7492,7 @@
         </p:nvCxnSpPr>
         <p:spPr>
           <a:xfrm>
-            <a:off x="548640" y="2414016"/>
+            <a:off x="548640" y="2359152"/>
             <a:ext cx="2313432" cy="0"/>
           </a:xfrm>
           <a:prstGeom prst="line">
@@ -7519,8 +7527,8 @@
         </p:nvSpPr>
         <p:spPr>
           <a:xfrm>
-            <a:off x="548640" y="2505456"/>
-            <a:ext cx="2313432" cy="1188719"/>
+            <a:off x="548640" y="2432304"/>
+            <a:ext cx="2313432" cy="1005840"/>
           </a:xfrm>
           <a:prstGeom prst="rect">
             <a:avLst/>
@@ -7545,13 +7553,13 @@
               </a:spcAft>
             </a:pPr>
             <a:r>
-              <a:rPr sz="1150" i="0">
+              <a:rPr sz="1200" i="0">
                 <a:solidFill>
                   <a:srgbClr val="0B1F33"/>
                 </a:solidFill>
                 <a:latin typeface="Avenir Next"/>
               </a:rPr>
-              <a:t>One Cloud Run API instance kept warm: 1 vCPU, 1 GiB, Mumbai. Idle rate US$0.0000025 per vCPU-second and per GiB-second, before any free tier.</a:t>
+              <a:t>One Cloud Run API instance kept warm (1 vCPU, 1 GiB, Mumbai) at US$0.0000025 per vCPU-second and per GiB-second, before any free tier.</a:t>
             </a:r>
           </a:p>
         </p:txBody>
@@ -7565,11 +7573,11 @@
         <p:spPr>
           <a:xfrm>
             <a:off x="3227832" y="1207008"/>
-            <a:ext cx="2679192" cy="2560320"/>
+            <a:ext cx="2679192" cy="2286000"/>
           </a:xfrm>
           <a:prstGeom prst="roundRect">
             <a:avLst>
-              <a:gd name="adj" fmla="val 2500"/>
+              <a:gd name="adj" fmla="val 2800"/>
             </a:avLst>
           </a:prstGeom>
           <a:solidFill>
@@ -7612,7 +7620,7 @@
         </p:nvSpPr>
         <p:spPr>
           <a:xfrm>
-            <a:off x="3410712" y="1371600"/>
+            <a:off x="3410712" y="1353312"/>
             <a:ext cx="1078992" cy="237744"/>
           </a:xfrm>
           <a:prstGeom prst="roundRect">
@@ -7658,7 +7666,7 @@
         </p:nvSpPr>
         <p:spPr>
           <a:xfrm>
-            <a:off x="3410712" y="1371600"/>
+            <a:off x="3410712" y="1353312"/>
             <a:ext cx="1078992" cy="237744"/>
           </a:xfrm>
           <a:prstGeom prst="rect">
@@ -7684,7 +7692,7 @@
               </a:spcAft>
             </a:pPr>
             <a:r>
-              <a:rPr sz="950" i="0">
+              <a:rPr sz="1000" i="0">
                 <a:solidFill>
                   <a:srgbClr val="1764E8"/>
                 </a:solidFill>
@@ -7703,7 +7711,7 @@
         </p:nvSpPr>
         <p:spPr>
           <a:xfrm>
-            <a:off x="3410712" y="1709928"/>
+            <a:off x="3410712" y="1664208"/>
             <a:ext cx="2313432" cy="411480"/>
           </a:xfrm>
           <a:prstGeom prst="rect">
@@ -7748,7 +7756,7 @@
         </p:nvSpPr>
         <p:spPr>
           <a:xfrm>
-            <a:off x="3410712" y="2121408"/>
+            <a:off x="3410712" y="2075688"/>
             <a:ext cx="2313432" cy="228600"/>
           </a:xfrm>
           <a:prstGeom prst="rect">
@@ -7774,9 +7782,9 @@
               </a:spcAft>
             </a:pPr>
             <a:r>
-              <a:rPr sz="1100" i="0">
-                <a:solidFill>
-                  <a:srgbClr val="5B6778"/>
+              <a:rPr sz="1150" i="0">
+                <a:solidFill>
+                  <a:srgbClr val="3F4B5B"/>
                 </a:solidFill>
                 <a:latin typeface="Avenir Next"/>
               </a:rPr>
@@ -7793,7 +7801,7 @@
         </p:nvCxnSpPr>
         <p:spPr>
           <a:xfrm>
-            <a:off x="3410712" y="2414016"/>
+            <a:off x="3410712" y="2359152"/>
             <a:ext cx="2313432" cy="0"/>
           </a:xfrm>
           <a:prstGeom prst="line">
@@ -7828,8 +7836,8 @@
         </p:nvSpPr>
         <p:spPr>
           <a:xfrm>
-            <a:off x="3410712" y="2505456"/>
-            <a:ext cx="2313432" cy="1188719"/>
+            <a:off x="3410712" y="2432304"/>
+            <a:ext cx="2313432" cy="1005840"/>
           </a:xfrm>
           <a:prstGeom prst="rect">
             <a:avLst/>
@@ -7854,13 +7862,13 @@
               </a:spcAft>
             </a:pPr>
             <a:r>
-              <a:rPr sz="1150" i="0">
+              <a:rPr sz="1200" i="0">
                 <a:solidFill>
                   <a:srgbClr val="0B1F33"/>
                 </a:solidFill>
                 <a:latin typeface="Avenir Next"/>
               </a:rPr>
-              <a:t>Gemini 3.7 Flash, assuming about 2,500 input and 500 to 1,500 output tokens. US$0.75 in, US$3.75 out per 1M tokens until 31 Dec 2026; double from 1 Jan 2027.</a:t>
+              <a:t>Gemini 3.7 Flash at about 2,500 input and 500 to 1,500 output tokens. US$0.75 in, US$3.75 out per 1M tokens to 31 Dec 2026; double after.</a:t>
             </a:r>
           </a:p>
         </p:txBody>
@@ -7874,11 +7882,11 @@
         <p:spPr>
           <a:xfrm>
             <a:off x="6089904" y="1207008"/>
-            <a:ext cx="2679192" cy="2560320"/>
+            <a:ext cx="2679192" cy="2286000"/>
           </a:xfrm>
           <a:prstGeom prst="roundRect">
             <a:avLst>
-              <a:gd name="adj" fmla="val 2500"/>
+              <a:gd name="adj" fmla="val 2800"/>
             </a:avLst>
           </a:prstGeom>
           <a:solidFill>
@@ -7921,7 +7929,7 @@
         </p:nvSpPr>
         <p:spPr>
           <a:xfrm>
-            <a:off x="6272784" y="1371600"/>
+            <a:off x="6272784" y="1353312"/>
             <a:ext cx="1078992" cy="237744"/>
           </a:xfrm>
           <a:prstGeom prst="roundRect">
@@ -7967,7 +7975,7 @@
         </p:nvSpPr>
         <p:spPr>
           <a:xfrm>
-            <a:off x="6272784" y="1371600"/>
+            <a:off x="6272784" y="1353312"/>
             <a:ext cx="1078992" cy="237744"/>
           </a:xfrm>
           <a:prstGeom prst="rect">
@@ -7993,7 +8001,7 @@
               </a:spcAft>
             </a:pPr>
             <a:r>
-              <a:rPr sz="950" i="0">
+              <a:rPr sz="1000" i="0">
                 <a:solidFill>
                   <a:srgbClr val="1764E8"/>
                 </a:solidFill>
@@ -8012,7 +8020,7 @@
         </p:nvSpPr>
         <p:spPr>
           <a:xfrm>
-            <a:off x="6272784" y="1709928"/>
+            <a:off x="6272784" y="1664208"/>
             <a:ext cx="2313432" cy="411480"/>
           </a:xfrm>
           <a:prstGeom prst="rect">
@@ -8057,7 +8065,7 @@
         </p:nvSpPr>
         <p:spPr>
           <a:xfrm>
-            <a:off x="6272784" y="2121408"/>
+            <a:off x="6272784" y="2075688"/>
             <a:ext cx="2313432" cy="228600"/>
           </a:xfrm>
           <a:prstGeom prst="rect">
@@ -8083,9 +8091,9 @@
               </a:spcAft>
             </a:pPr>
             <a:r>
-              <a:rPr sz="1100" i="0">
-                <a:solidFill>
-                  <a:srgbClr val="5B6778"/>
+              <a:rPr sz="1150" i="0">
+                <a:solidFill>
+                  <a:srgbClr val="3F4B5B"/>
                 </a:solidFill>
                 <a:latin typeface="Avenir Next"/>
               </a:rPr>
@@ -8102,7 +8110,7 @@
         </p:nvCxnSpPr>
         <p:spPr>
           <a:xfrm>
-            <a:off x="6272784" y="2414016"/>
+            <a:off x="6272784" y="2359152"/>
             <a:ext cx="2313432" cy="0"/>
           </a:xfrm>
           <a:prstGeom prst="line">
@@ -8137,8 +8145,8 @@
         </p:nvSpPr>
         <p:spPr>
           <a:xfrm>
-            <a:off x="6272784" y="2505456"/>
-            <a:ext cx="2313432" cy="1188719"/>
+            <a:off x="6272784" y="2432304"/>
+            <a:ext cx="2313432" cy="1005840"/>
           </a:xfrm>
           <a:prstGeom prst="rect">
             <a:avLst/>
@@ -8163,13 +8171,13 @@
               </a:spcAft>
             </a:pPr>
             <a:r>
-              <a:rPr sz="1150" i="0">
+              <a:rPr sz="1200" i="0">
                 <a:solidFill>
                   <a:srgbClr val="0B1F33"/>
                 </a:solidFill>
                 <a:latin typeface="Avenir Next"/>
               </a:rPr>
-              <a:t>Firebase Hosting, Auth, Firestore and Storage are expected to stay inside free tiers. The link scanner bills only while it scans and scales to zero.</a:t>
+              <a:t>Firebase Hosting, Auth, Firestore and Storage are expected to stay inside free tiers. The link scanner bills only while it scans.</a:t>
             </a:r>
           </a:p>
         </p:txBody>
@@ -8182,12 +8190,12 @@
         </p:nvSpPr>
         <p:spPr>
           <a:xfrm>
-            <a:off x="365760" y="3895344"/>
-            <a:ext cx="8412480" cy="1024128"/>
+            <a:off x="365760" y="3602736"/>
+            <a:ext cx="8412480" cy="1316735"/>
           </a:xfrm>
           <a:prstGeom prst="roundRect">
             <a:avLst>
-              <a:gd name="adj" fmla="val 7142"/>
+              <a:gd name="adj" fmla="val 5555"/>
             </a:avLst>
           </a:prstGeom>
           <a:solidFill>
@@ -8228,8 +8236,8 @@
         </p:nvSpPr>
         <p:spPr>
           <a:xfrm>
-            <a:off x="548640" y="4005072"/>
-            <a:ext cx="2499359" cy="841248"/>
+            <a:off x="548640" y="3785616"/>
+            <a:ext cx="2499359" cy="1088135"/>
           </a:xfrm>
           <a:prstGeom prst="rect">
             <a:avLst/>
@@ -8250,17 +8258,17 @@
                 <a:spcPts val="0"/>
               </a:spcBef>
               <a:spcAft>
-                <a:spcPts val="200"/>
+                <a:spcPts val="300"/>
               </a:spcAft>
             </a:pPr>
             <a:r>
-              <a:rPr sz="1200" i="0">
+              <a:rPr sz="1250" i="0">
                 <a:solidFill>
                   <a:srgbClr val="34C9E8"/>
                 </a:solidFill>
                 <a:latin typeface="Avenir Next Demi Bold"/>
               </a:rPr>
-              <a:t>Limits bound the bill</a:t>
+              <a:t>Limits are the real control</a:t>
             </a:r>
           </a:p>
           <a:p>
@@ -8276,13 +8284,13 @@
               </a:spcAft>
             </a:pPr>
             <a:r>
-              <a:rPr sz="1150" i="0">
+              <a:rPr sz="1200" i="0">
                 <a:solidFill>
                   <a:srgbClr val="FFFFFF"/>
                 </a:solidFill>
                 <a:latin typeface="Avenir Next"/>
               </a:rPr>
-              <a:t>30 checks per user per day, 60 per IP per minute, 3,000 per day overall.</a:t>
+              <a:t>30 checks per user per day, 60 per IP per minute, 3,000 per day overall. These cap spending.</a:t>
             </a:r>
           </a:p>
         </p:txBody>
@@ -8295,8 +8303,8 @@
         </p:nvSpPr>
         <p:spPr>
           <a:xfrm>
-            <a:off x="3230880" y="4005072"/>
-            <a:ext cx="2499359" cy="841248"/>
+            <a:off x="3230880" y="3785616"/>
+            <a:ext cx="2499359" cy="1088135"/>
           </a:xfrm>
           <a:prstGeom prst="rect">
             <a:avLst/>
@@ -8317,11 +8325,11 @@
                 <a:spcPts val="0"/>
               </a:spcBef>
               <a:spcAft>
-                <a:spcPts val="200"/>
+                <a:spcPts val="300"/>
               </a:spcAft>
             </a:pPr>
             <a:r>
-              <a:rPr sz="1200" i="0">
+              <a:rPr sz="1250" i="0">
                 <a:solidFill>
                   <a:srgbClr val="34C9E8"/>
                 </a:solidFill>
@@ -8343,7 +8351,7 @@
               </a:spcAft>
             </a:pPr>
             <a:r>
-              <a:rPr sz="1150" i="0">
+              <a:rPr sz="1200" i="0">
                 <a:solidFill>
                   <a:srgbClr val="FFFFFF"/>
                 </a:solidFill>
@@ -8362,8 +8370,8 @@
         </p:nvSpPr>
         <p:spPr>
           <a:xfrm>
-            <a:off x="5913120" y="4005072"/>
-            <a:ext cx="2499359" cy="841248"/>
+            <a:off x="5913120" y="3785616"/>
+            <a:ext cx="2499359" cy="1088135"/>
           </a:xfrm>
           <a:prstGeom prst="rect">
             <a:avLst/>
@@ -8384,17 +8392,17 @@
                 <a:spcPts val="0"/>
               </a:spcBef>
               <a:spcAft>
-                <a:spcPts val="200"/>
+                <a:spcPts val="300"/>
               </a:spcAft>
             </a:pPr>
             <a:r>
-              <a:rPr sz="1200" i="0">
+              <a:rPr sz="1250" i="0">
                 <a:solidFill>
                   <a:srgbClr val="34C9E8"/>
                 </a:solidFill>
                 <a:latin typeface="Avenir Next Demi Bold"/>
               </a:rPr>
-              <a:t>Budget alert</a:t>
+              <a:t>Budget alert: Rs 2,000 a month</a:t>
             </a:r>
           </a:p>
           <a:p>
@@ -8410,13 +8418,13 @@
               </a:spcAft>
             </a:pPr>
             <a:r>
-              <a:rPr sz="1150" i="0">
+              <a:rPr sz="1200" i="0">
                 <a:solidFill>
                   <a:srgbClr val="FFFFFF"/>
                 </a:solidFill>
                 <a:latin typeface="Avenir Next"/>
               </a:rPr>
-              <a:t>Set: Rs 1,000 per month on this project, alerts at 50%, 90% and 100% of the budget. A hard daily cap also applies.</a:t>
+              <a:t>Alerts at 50%, 90% and 100% (Rs 1,000, Rs 1,800, Rs 2,000). An alert notifies; it does not stop spending.</a:t>
             </a:r>
           </a:p>
         </p:txBody>
@@ -8823,7 +8831,7 @@
             <a:r>
               <a:rPr sz="1100" i="0">
                 <a:solidFill>
-                  <a:srgbClr val="5B6778"/>
+                  <a:srgbClr val="3F4B5B"/>
                 </a:solidFill>
                 <a:latin typeface="Avenir Next"/>
               </a:rPr>
@@ -8890,7 +8898,7 @@
             <a:r>
               <a:rPr sz="1100" i="0">
                 <a:solidFill>
-                  <a:srgbClr val="5B6778"/>
+                  <a:srgbClr val="3F4B5B"/>
                 </a:solidFill>
                 <a:latin typeface="Avenir Next"/>
               </a:rPr>
@@ -8957,7 +8965,7 @@
             <a:r>
               <a:rPr sz="1100" i="0">
                 <a:solidFill>
-                  <a:srgbClr val="5B6778"/>
+                  <a:srgbClr val="3F4B5B"/>
                 </a:solidFill>
                 <a:latin typeface="Avenir Next"/>
               </a:rPr>
@@ -9024,7 +9032,7 @@
             <a:r>
               <a:rPr sz="1100" i="0">
                 <a:solidFill>
-                  <a:srgbClr val="5B6778"/>
+                  <a:srgbClr val="3F4B5B"/>
                 </a:solidFill>
                 <a:latin typeface="Avenir Next"/>
               </a:rPr>
@@ -9091,7 +9099,7 @@
             <a:r>
               <a:rPr sz="1100" i="0">
                 <a:solidFill>
-                  <a:srgbClr val="5B6778"/>
+                  <a:srgbClr val="3F4B5B"/>
                 </a:solidFill>
                 <a:latin typeface="Avenir Next"/>
               </a:rPr>
@@ -9287,11 +9295,11 @@
         <p:spPr>
           <a:xfrm>
             <a:off x="365760" y="1207008"/>
-            <a:ext cx="1965960" cy="914400"/>
+            <a:ext cx="1965960" cy="768096"/>
           </a:xfrm>
           <a:prstGeom prst="roundRect">
             <a:avLst>
-              <a:gd name="adj" fmla="val 7000"/>
+              <a:gd name="adj" fmla="val 8333"/>
             </a:avLst>
           </a:prstGeom>
           <a:solidFill>
@@ -9334,8 +9342,8 @@
         </p:nvSpPr>
         <p:spPr>
           <a:xfrm>
-            <a:off x="365760" y="1298448"/>
-            <a:ext cx="1965960" cy="457200"/>
+            <a:off x="365760" y="1271016"/>
+            <a:ext cx="1965960" cy="384048"/>
           </a:xfrm>
           <a:prstGeom prst="rect">
             <a:avLst/>
@@ -9360,7 +9368,7 @@
               </a:spcAft>
             </a:pPr>
             <a:r>
-              <a:rPr sz="2600" i="0">
+              <a:rPr sz="2400" i="0">
                 <a:solidFill>
                   <a:srgbClr val="1764E8"/>
                 </a:solidFill>
@@ -9379,8 +9387,8 @@
         </p:nvSpPr>
         <p:spPr>
           <a:xfrm>
-            <a:off x="365760" y="1792224"/>
-            <a:ext cx="1965960" cy="256032"/>
+            <a:off x="365760" y="1664208"/>
+            <a:ext cx="1965960" cy="237744"/>
           </a:xfrm>
           <a:prstGeom prst="rect">
             <a:avLst/>
@@ -9407,7 +9415,7 @@
             <a:r>
               <a:rPr sz="1150" i="0">
                 <a:solidFill>
-                  <a:srgbClr val="5B6778"/>
+                  <a:srgbClr val="3F4B5B"/>
                 </a:solidFill>
                 <a:latin typeface="Avenir Next"/>
               </a:rPr>
@@ -9425,11 +9433,11 @@
         <p:spPr>
           <a:xfrm>
             <a:off x="2514600" y="1207008"/>
-            <a:ext cx="1965960" cy="914400"/>
+            <a:ext cx="1965960" cy="768096"/>
           </a:xfrm>
           <a:prstGeom prst="roundRect">
             <a:avLst>
-              <a:gd name="adj" fmla="val 7000"/>
+              <a:gd name="adj" fmla="val 8333"/>
             </a:avLst>
           </a:prstGeom>
           <a:solidFill>
@@ -9472,8 +9480,8 @@
         </p:nvSpPr>
         <p:spPr>
           <a:xfrm>
-            <a:off x="2514600" y="1298448"/>
-            <a:ext cx="1965960" cy="457200"/>
+            <a:off x="2514600" y="1271016"/>
+            <a:ext cx="1965960" cy="384048"/>
           </a:xfrm>
           <a:prstGeom prst="rect">
             <a:avLst/>
@@ -9498,7 +9506,7 @@
               </a:spcAft>
             </a:pPr>
             <a:r>
-              <a:rPr sz="2600" i="0">
+              <a:rPr sz="2400" i="0">
                 <a:solidFill>
                   <a:srgbClr val="1764E8"/>
                 </a:solidFill>
@@ -9517,8 +9525,8 @@
         </p:nvSpPr>
         <p:spPr>
           <a:xfrm>
-            <a:off x="2514600" y="1792224"/>
-            <a:ext cx="1965960" cy="256032"/>
+            <a:off x="2514600" y="1664208"/>
+            <a:ext cx="1965960" cy="237744"/>
           </a:xfrm>
           <a:prstGeom prst="rect">
             <a:avLst/>
@@ -9545,7 +9553,7 @@
             <a:r>
               <a:rPr sz="1150" i="0">
                 <a:solidFill>
-                  <a:srgbClr val="5B6778"/>
+                  <a:srgbClr val="3F4B5B"/>
                 </a:solidFill>
                 <a:latin typeface="Avenir Next"/>
               </a:rPr>
@@ -9563,11 +9571,11 @@
         <p:spPr>
           <a:xfrm>
             <a:off x="4663440" y="1207008"/>
-            <a:ext cx="1965960" cy="914400"/>
+            <a:ext cx="1965960" cy="768096"/>
           </a:xfrm>
           <a:prstGeom prst="roundRect">
             <a:avLst>
-              <a:gd name="adj" fmla="val 7000"/>
+              <a:gd name="adj" fmla="val 8333"/>
             </a:avLst>
           </a:prstGeom>
           <a:solidFill>
@@ -9610,8 +9618,8 @@
         </p:nvSpPr>
         <p:spPr>
           <a:xfrm>
-            <a:off x="4663440" y="1298448"/>
-            <a:ext cx="1965960" cy="457200"/>
+            <a:off x="4663440" y="1271016"/>
+            <a:ext cx="1965960" cy="384048"/>
           </a:xfrm>
           <a:prstGeom prst="rect">
             <a:avLst/>
@@ -9636,7 +9644,7 @@
               </a:spcAft>
             </a:pPr>
             <a:r>
-              <a:rPr sz="2600" i="0">
+              <a:rPr sz="2400" i="0">
                 <a:solidFill>
                   <a:srgbClr val="1764E8"/>
                 </a:solidFill>
@@ -9655,8 +9663,8 @@
         </p:nvSpPr>
         <p:spPr>
           <a:xfrm>
-            <a:off x="4663440" y="1792224"/>
-            <a:ext cx="1965960" cy="256032"/>
+            <a:off x="4663440" y="1664208"/>
+            <a:ext cx="1965960" cy="237744"/>
           </a:xfrm>
           <a:prstGeom prst="rect">
             <a:avLst/>
@@ -9683,7 +9691,7 @@
             <a:r>
               <a:rPr sz="1150" i="0">
                 <a:solidFill>
-                  <a:srgbClr val="5B6778"/>
+                  <a:srgbClr val="3F4B5B"/>
                 </a:solidFill>
                 <a:latin typeface="Avenir Next"/>
               </a:rPr>
@@ -9701,11 +9709,11 @@
         <p:spPr>
           <a:xfrm>
             <a:off x="6812280" y="1207008"/>
-            <a:ext cx="1965960" cy="914400"/>
+            <a:ext cx="1965960" cy="768096"/>
           </a:xfrm>
           <a:prstGeom prst="roundRect">
             <a:avLst>
-              <a:gd name="adj" fmla="val 7000"/>
+              <a:gd name="adj" fmla="val 8333"/>
             </a:avLst>
           </a:prstGeom>
           <a:solidFill>
@@ -9748,8 +9756,8 @@
         </p:nvSpPr>
         <p:spPr>
           <a:xfrm>
-            <a:off x="6812280" y="1298448"/>
-            <a:ext cx="1965960" cy="457200"/>
+            <a:off x="6812280" y="1271016"/>
+            <a:ext cx="1965960" cy="384048"/>
           </a:xfrm>
           <a:prstGeom prst="rect">
             <a:avLst/>
@@ -9774,7 +9782,7 @@
               </a:spcAft>
             </a:pPr>
             <a:r>
-              <a:rPr sz="2600" i="0">
+              <a:rPr sz="2400" i="0">
                 <a:solidFill>
                   <a:srgbClr val="1764E8"/>
                 </a:solidFill>
@@ -9793,8 +9801,8 @@
         </p:nvSpPr>
         <p:spPr>
           <a:xfrm>
-            <a:off x="6812280" y="1792224"/>
-            <a:ext cx="1965960" cy="256032"/>
+            <a:off x="6812280" y="1664208"/>
+            <a:ext cx="1965960" cy="237744"/>
           </a:xfrm>
           <a:prstGeom prst="rect">
             <a:avLst/>
@@ -9821,7 +9829,7 @@
             <a:r>
               <a:rPr sz="1150" i="0">
                 <a:solidFill>
-                  <a:srgbClr val="5B6778"/>
+                  <a:srgbClr val="3F4B5B"/>
                 </a:solidFill>
                 <a:latin typeface="Avenir Next"/>
               </a:rPr>
@@ -9838,7 +9846,7 @@
         </p:nvSpPr>
         <p:spPr>
           <a:xfrm>
-            <a:off x="365760" y="2176272"/>
+            <a:off x="365760" y="2039112"/>
             <a:ext cx="8412480" cy="201168"/>
           </a:xfrm>
           <a:prstGeom prst="rect">
@@ -9864,9 +9872,9 @@
               </a:spcAft>
             </a:pPr>
             <a:r>
-              <a:rPr sz="1100" i="1">
-                <a:solidFill>
-                  <a:srgbClr val="5B6778"/>
+              <a:rPr sz="1150" i="0">
+                <a:solidFill>
+                  <a:srgbClr val="3F4B5B"/>
                 </a:solidFill>
                 <a:latin typeface="Avenir Next"/>
               </a:rPr>
@@ -9884,8 +9892,8 @@
           <p:nvPr/>
         </p:nvGraphicFramePr>
         <p:xfrm>
-          <a:off x="365760" y="2505456"/>
-          <a:ext cx="5074920" cy="1316736"/>
+          <a:off x="365760" y="2304288"/>
+          <a:ext cx="5074920" cy="1097280"/>
         </p:xfrm>
         <a:graphic>
           <a:graphicData uri="http://schemas.openxmlformats.org/drawingml/2006/table">
@@ -9901,7 +9909,7 @@
                 <a:gridCol w="948690"/>
                 <a:gridCol w="948690"/>
               </a:tblGrid>
-              <a:tr h="329184">
+              <a:tr h="274320">
                 <a:tc>
                   <a:txBody>
                     <a:bodyPr/>
@@ -9909,7 +9917,7 @@
                     <a:p>
                       <a:pPr algn="l"/>
                       <a:r>
-                        <a:rPr sz="1050" i="0">
+                        <a:rPr sz="1150" i="0">
                           <a:solidFill>
                             <a:srgbClr val="FFFFFF"/>
                           </a:solidFill>
@@ -9919,7 +9927,7 @@
                       </a:r>
                     </a:p>
                   </a:txBody>
-                  <a:tcPr marL="54864" marR="54864" marT="27432" marB="27432" anchor="ctr">
+                  <a:tcPr marL="54864" marR="54864" marT="18288" marB="18288" anchor="ctr">
                     <a:solidFill>
                       <a:srgbClr val="081B32"/>
                     </a:solidFill>
@@ -9932,7 +9940,7 @@
                     <a:p>
                       <a:pPr algn="ctr"/>
                       <a:r>
-                        <a:rPr sz="1050" i="0">
+                        <a:rPr sz="1150" i="0">
                           <a:solidFill>
                             <a:srgbClr val="FFFFFF"/>
                           </a:solidFill>
@@ -9942,7 +9950,7 @@
                       </a:r>
                     </a:p>
                   </a:txBody>
-                  <a:tcPr marL="54864" marR="54864" marT="27432" marB="27432" anchor="ctr">
+                  <a:tcPr marL="54864" marR="54864" marT="18288" marB="18288" anchor="ctr">
                     <a:solidFill>
                       <a:srgbClr val="081B32"/>
                     </a:solidFill>
@@ -9955,7 +9963,7 @@
                     <a:p>
                       <a:pPr algn="ctr"/>
                       <a:r>
-                        <a:rPr sz="1050" i="0">
+                        <a:rPr sz="1150" i="0">
                           <a:solidFill>
                             <a:srgbClr val="FFFFFF"/>
                           </a:solidFill>
@@ -9965,7 +9973,7 @@
                       </a:r>
                     </a:p>
                   </a:txBody>
-                  <a:tcPr marL="54864" marR="54864" marT="27432" marB="27432" anchor="ctr">
+                  <a:tcPr marL="54864" marR="54864" marT="18288" marB="18288" anchor="ctr">
                     <a:solidFill>
                       <a:srgbClr val="081B32"/>
                     </a:solidFill>
@@ -9978,7 +9986,7 @@
                     <a:p>
                       <a:pPr algn="ctr"/>
                       <a:r>
-                        <a:rPr sz="1050" i="0">
+                        <a:rPr sz="1150" i="0">
                           <a:solidFill>
                             <a:srgbClr val="FFFFFF"/>
                           </a:solidFill>
@@ -9988,7 +9996,7 @@
                       </a:r>
                     </a:p>
                   </a:txBody>
-                  <a:tcPr marL="54864" marR="54864" marT="27432" marB="27432" anchor="ctr">
+                  <a:tcPr marL="54864" marR="54864" marT="18288" marB="18288" anchor="ctr">
                     <a:solidFill>
                       <a:srgbClr val="081B32"/>
                     </a:solidFill>
@@ -10001,7 +10009,7 @@
                     <a:p>
                       <a:pPr algn="ctr"/>
                       <a:r>
-                        <a:rPr sz="1050" i="0">
+                        <a:rPr sz="1150" i="0">
                           <a:solidFill>
                             <a:srgbClr val="FFFFFF"/>
                           </a:solidFill>
@@ -10011,7 +10019,7 @@
                       </a:r>
                     </a:p>
                   </a:txBody>
-                  <a:tcPr marL="54864" marR="54864" marT="27432" marB="27432" anchor="ctr">
+                  <a:tcPr marL="54864" marR="54864" marT="18288" marB="18288" anchor="ctr">
                     <a:solidFill>
                       <a:srgbClr val="081B32"/>
                     </a:solidFill>
@@ -10024,7 +10032,7 @@
                     <a:p>
                       <a:pPr algn="ctr"/>
                       <a:r>
-                        <a:rPr sz="1050" i="0">
+                        <a:rPr sz="1150" i="0">
                           <a:solidFill>
                             <a:srgbClr val="FFFFFF"/>
                           </a:solidFill>
@@ -10034,14 +10042,14 @@
                       </a:r>
                     </a:p>
                   </a:txBody>
-                  <a:tcPr marL="54864" marR="54864" marT="27432" marB="27432" anchor="ctr">
+                  <a:tcPr marL="54864" marR="54864" marT="18288" marB="18288" anchor="ctr">
                     <a:solidFill>
                       <a:srgbClr val="081B32"/>
                     </a:solidFill>
                   </a:tcPr>
                 </a:tc>
               </a:tr>
-              <a:tr h="329184">
+              <a:tr h="274320">
                 <a:tc>
                   <a:txBody>
                     <a:bodyPr/>
@@ -10059,7 +10067,7 @@
                       </a:r>
                     </a:p>
                   </a:txBody>
-                  <a:tcPr marL="54864" marR="54864" marT="27432" marB="27432" anchor="ctr">
+                  <a:tcPr marL="54864" marR="54864" marT="18288" marB="18288" anchor="ctr">
                     <a:solidFill>
                       <a:srgbClr val="F1F5FB"/>
                     </a:solidFill>
@@ -10082,7 +10090,7 @@
                       </a:r>
                     </a:p>
                   </a:txBody>
-                  <a:tcPr marL="54864" marR="54864" marT="27432" marB="27432" anchor="ctr">
+                  <a:tcPr marL="54864" marR="54864" marT="18288" marB="18288" anchor="ctr">
                     <a:solidFill>
                       <a:srgbClr val="F1F5FB"/>
                     </a:solidFill>
@@ -10105,7 +10113,7 @@
                       </a:r>
                     </a:p>
                   </a:txBody>
-                  <a:tcPr marL="54864" marR="54864" marT="27432" marB="27432" anchor="ctr">
+                  <a:tcPr marL="54864" marR="54864" marT="18288" marB="18288" anchor="ctr">
                     <a:solidFill>
                       <a:srgbClr val="F1F5FB"/>
                     </a:solidFill>
@@ -10128,7 +10136,7 @@
                       </a:r>
                     </a:p>
                   </a:txBody>
-                  <a:tcPr marL="54864" marR="54864" marT="27432" marB="27432" anchor="ctr">
+                  <a:tcPr marL="54864" marR="54864" marT="18288" marB="18288" anchor="ctr">
                     <a:solidFill>
                       <a:srgbClr val="F1F5FB"/>
                     </a:solidFill>
@@ -10151,7 +10159,7 @@
                       </a:r>
                     </a:p>
                   </a:txBody>
-                  <a:tcPr marL="54864" marR="54864" marT="27432" marB="27432" anchor="ctr">
+                  <a:tcPr marL="54864" marR="54864" marT="18288" marB="18288" anchor="ctr">
                     <a:solidFill>
                       <a:srgbClr val="F1F5FB"/>
                     </a:solidFill>
@@ -10174,14 +10182,14 @@
                       </a:r>
                     </a:p>
                   </a:txBody>
-                  <a:tcPr marL="54864" marR="54864" marT="27432" marB="27432" anchor="ctr">
+                  <a:tcPr marL="54864" marR="54864" marT="18288" marB="18288" anchor="ctr">
                     <a:solidFill>
                       <a:srgbClr val="F1F5FB"/>
                     </a:solidFill>
                   </a:tcPr>
                 </a:tc>
               </a:tr>
-              <a:tr h="329184">
+              <a:tr h="274320">
                 <a:tc>
                   <a:txBody>
                     <a:bodyPr/>
@@ -10199,7 +10207,7 @@
                       </a:r>
                     </a:p>
                   </a:txBody>
-                  <a:tcPr marL="54864" marR="54864" marT="27432" marB="27432" anchor="ctr">
+                  <a:tcPr marL="54864" marR="54864" marT="18288" marB="18288" anchor="ctr">
                     <a:solidFill>
                       <a:srgbClr val="FFFFFF"/>
                     </a:solidFill>
@@ -10222,7 +10230,7 @@
                       </a:r>
                     </a:p>
                   </a:txBody>
-                  <a:tcPr marL="54864" marR="54864" marT="27432" marB="27432" anchor="ctr">
+                  <a:tcPr marL="54864" marR="54864" marT="18288" marB="18288" anchor="ctr">
                     <a:solidFill>
                       <a:srgbClr val="FFFFFF"/>
                     </a:solidFill>
@@ -10245,7 +10253,7 @@
                       </a:r>
                     </a:p>
                   </a:txBody>
-                  <a:tcPr marL="54864" marR="54864" marT="27432" marB="27432" anchor="ctr">
+                  <a:tcPr marL="54864" marR="54864" marT="18288" marB="18288" anchor="ctr">
                     <a:solidFill>
                       <a:srgbClr val="FFFFFF"/>
                     </a:solidFill>
@@ -10268,7 +10276,7 @@
                       </a:r>
                     </a:p>
                   </a:txBody>
-                  <a:tcPr marL="54864" marR="54864" marT="27432" marB="27432" anchor="ctr">
+                  <a:tcPr marL="54864" marR="54864" marT="18288" marB="18288" anchor="ctr">
                     <a:solidFill>
                       <a:srgbClr val="FFFFFF"/>
                     </a:solidFill>
@@ -10291,7 +10299,7 @@
                       </a:r>
                     </a:p>
                   </a:txBody>
-                  <a:tcPr marL="54864" marR="54864" marT="27432" marB="27432" anchor="ctr">
+                  <a:tcPr marL="54864" marR="54864" marT="18288" marB="18288" anchor="ctr">
                     <a:solidFill>
                       <a:srgbClr val="FFFFFF"/>
                     </a:solidFill>
@@ -10314,14 +10322,14 @@
                       </a:r>
                     </a:p>
                   </a:txBody>
-                  <a:tcPr marL="54864" marR="54864" marT="27432" marB="27432" anchor="ctr">
+                  <a:tcPr marL="54864" marR="54864" marT="18288" marB="18288" anchor="ctr">
                     <a:solidFill>
                       <a:srgbClr val="FFFFFF"/>
                     </a:solidFill>
                   </a:tcPr>
                 </a:tc>
               </a:tr>
-              <a:tr h="329184">
+              <a:tr h="274320">
                 <a:tc>
                   <a:txBody>
                     <a:bodyPr/>
@@ -10339,7 +10347,7 @@
                       </a:r>
                     </a:p>
                   </a:txBody>
-                  <a:tcPr marL="54864" marR="54864" marT="27432" marB="27432" anchor="ctr">
+                  <a:tcPr marL="54864" marR="54864" marT="18288" marB="18288" anchor="ctr">
                     <a:solidFill>
                       <a:srgbClr val="F1F5FB"/>
                     </a:solidFill>
@@ -10362,7 +10370,7 @@
                       </a:r>
                     </a:p>
                   </a:txBody>
-                  <a:tcPr marL="54864" marR="54864" marT="27432" marB="27432" anchor="ctr">
+                  <a:tcPr marL="54864" marR="54864" marT="18288" marB="18288" anchor="ctr">
                     <a:solidFill>
                       <a:srgbClr val="F1F5FB"/>
                     </a:solidFill>
@@ -10385,7 +10393,7 @@
                       </a:r>
                     </a:p>
                   </a:txBody>
-                  <a:tcPr marL="54864" marR="54864" marT="27432" marB="27432" anchor="ctr">
+                  <a:tcPr marL="54864" marR="54864" marT="18288" marB="18288" anchor="ctr">
                     <a:solidFill>
                       <a:srgbClr val="F1F5FB"/>
                     </a:solidFill>
@@ -10408,7 +10416,7 @@
                       </a:r>
                     </a:p>
                   </a:txBody>
-                  <a:tcPr marL="54864" marR="54864" marT="27432" marB="27432" anchor="ctr">
+                  <a:tcPr marL="54864" marR="54864" marT="18288" marB="18288" anchor="ctr">
                     <a:solidFill>
                       <a:srgbClr val="F1F5FB"/>
                     </a:solidFill>
@@ -10431,7 +10439,7 @@
                       </a:r>
                     </a:p>
                   </a:txBody>
-                  <a:tcPr marL="54864" marR="54864" marT="27432" marB="27432" anchor="ctr">
+                  <a:tcPr marL="54864" marR="54864" marT="18288" marB="18288" anchor="ctr">
                     <a:solidFill>
                       <a:srgbClr val="F1F5FB"/>
                     </a:solidFill>
@@ -10454,7 +10462,7 @@
                       </a:r>
                     </a:p>
                   </a:txBody>
-                  <a:tcPr marL="54864" marR="54864" marT="27432" marB="27432" anchor="ctr">
+                  <a:tcPr marL="54864" marR="54864" marT="18288" marB="18288" anchor="ctr">
                     <a:solidFill>
                       <a:srgbClr val="F1F5FB"/>
                     </a:solidFill>
@@ -10473,12 +10481,12 @@
         </p:nvSpPr>
         <p:spPr>
           <a:xfrm>
-            <a:off x="365760" y="3931920"/>
-            <a:ext cx="5074920" cy="566928"/>
+            <a:off x="365760" y="3493008"/>
+            <a:ext cx="5074920" cy="457200"/>
           </a:xfrm>
           <a:prstGeom prst="roundRect">
             <a:avLst>
-              <a:gd name="adj" fmla="val 11290"/>
+              <a:gd name="adj" fmla="val 14000"/>
             </a:avLst>
           </a:prstGeom>
           <a:solidFill>
@@ -10519,8 +10527,8 @@
         </p:nvSpPr>
         <p:spPr>
           <a:xfrm>
-            <a:off x="512064" y="3931920"/>
-            <a:ext cx="4800600" cy="566928"/>
+            <a:off x="512064" y="3493008"/>
+            <a:ext cx="4800600" cy="457200"/>
           </a:xfrm>
           <a:prstGeom prst="rect">
             <a:avLst/>
@@ -10560,7 +10568,7 @@
                 </a:solidFill>
                 <a:latin typeface="Avenir Next"/>
               </a:rPr>
-              <a:t>accuracy 100.0%, scam recall 100.0%, false positives 0.0%, scam type correct 100.0%; answers returned in Hindi.</a:t>
+              <a:t>accuracy 100.0%, scam recall 100.0%, false positives 0.0%, scam type correct 100.0%.</a:t>
             </a:r>
           </a:p>
         </p:txBody>
@@ -10573,8 +10581,8 @@
         </p:nvSpPr>
         <p:spPr>
           <a:xfrm>
-            <a:off x="365760" y="4608576"/>
-            <a:ext cx="5074920" cy="310895"/>
+            <a:off x="365760" y="4041648"/>
+            <a:ext cx="5074920" cy="877824"/>
           </a:xfrm>
           <a:prstGeom prst="rect">
             <a:avLst/>
@@ -10595,17 +10603,66 @@
                 <a:spcPts val="0"/>
               </a:spcBef>
               <a:spcAft>
-                <a:spcPts val="0"/>
+                <a:spcPts val="300"/>
               </a:spcAft>
             </a:pPr>
             <a:r>
-              <a:rPr sz="1100" i="1">
-                <a:solidFill>
-                  <a:srgbClr val="5B6778"/>
+              <a:rPr sz="1150" i="0">
+                <a:solidFill>
+                  <a:srgbClr val="081B32"/>
+                </a:solidFill>
+                <a:latin typeface="Avenir Next Demi Bold"/>
+              </a:rPr>
+              <a:t>Errors: </a:t>
+            </a:r>
+            <a:r>
+              <a:rPr sz="1150" i="0">
+                <a:solidFill>
+                  <a:srgbClr val="0B1F33"/>
                 </a:solidFill>
                 <a:latin typeface="Avenir Next"/>
               </a:rPr>
-              <a:t>p50 is the median time, p95 the slowest 5%, in seconds from request to answer on the live app. The image and voice samples are very small (4 and 1 cases).</a:t>
+              <a:t>0. </a:t>
+            </a:r>
+            <a:r>
+              <a:rPr sz="1150" i="0">
+                <a:solidFill>
+                  <a:srgbClr val="081B32"/>
+                </a:solidFill>
+                <a:latin typeface="Avenir Next Demi Bold"/>
+              </a:rPr>
+              <a:t>False positives: </a:t>
+            </a:r>
+            <a:r>
+              <a:rPr sz="1150" i="0">
+                <a:solidFill>
+                  <a:srgbClr val="0B1F33"/>
+                </a:solidFill>
+                <a:latin typeface="Avenir Next"/>
+              </a:rPr>
+              <a:t>none.</a:t>
+            </a:r>
+          </a:p>
+          <a:p>
+            <a:pPr algn="l">
+              <a:lnSpc>
+                <a:spcPct val="100000"/>
+              </a:lnSpc>
+              <a:spcBef>
+                <a:spcPts val="0"/>
+              </a:spcBef>
+              <a:spcAft>
+                <a:spcPts val="0"/>
+              </a:spcAft>
+            </a:pPr>
+            <a:r>
+              <a:rPr sz="1200" i="0">
+                <a:solidFill>
+                  <a:srgbClr val="3F4B5B"/>
+                </a:solidFill>
+                <a:latin typeface="Avenir Next"/>
+              </a:rPr>
+              <a:t>p50 is the median time, p95 the slowest 5%, in seconds on the live app. The image and voice rows have only 4 and 1 cases.</a:t>
             </a:r>
           </a:p>
         </p:txBody>
@@ -10618,12 +10675,12 @@
         </p:nvSpPr>
         <p:spPr>
           <a:xfrm>
-            <a:off x="5623560" y="2505456"/>
-            <a:ext cx="3154679" cy="2414015"/>
+            <a:off x="5623560" y="2304288"/>
+            <a:ext cx="3154679" cy="2615184"/>
           </a:xfrm>
           <a:prstGeom prst="roundRect">
             <a:avLst>
-              <a:gd name="adj" fmla="val 2651"/>
+              <a:gd name="adj" fmla="val 2447"/>
             </a:avLst>
           </a:prstGeom>
           <a:solidFill>
@@ -10666,7 +10723,7 @@
         </p:nvSpPr>
         <p:spPr>
           <a:xfrm>
-            <a:off x="5788152" y="2633472"/>
+            <a:off x="5788152" y="2414016"/>
             <a:ext cx="2825495" cy="237744"/>
           </a:xfrm>
           <a:prstGeom prst="rect">
@@ -10711,8 +10768,8 @@
         </p:nvSpPr>
         <p:spPr>
           <a:xfrm>
-            <a:off x="5788152" y="2962656"/>
-            <a:ext cx="2825495" cy="1911095"/>
+            <a:off x="5788152" y="2715768"/>
+            <a:ext cx="2825495" cy="2157984"/>
           </a:xfrm>
           <a:prstGeom prst="rect">
             <a:avLst/>
@@ -10748,7 +10805,7 @@
                 </a:solidFill>
                 <a:latin typeface="Avenir Next Demi Bold"/>
               </a:rPr>
-              <a:t>50 synthetic test cases, a small test, not a guarantee. </a:t>
+              <a:t>50 cases, written by the authors: </a:t>
             </a:r>
             <a:r>
               <a:rPr sz="1150" i="0">
@@ -10757,7 +10814,7 @@
                 </a:solidFill>
                 <a:latin typeface="Avenir Next"/>
               </a:rPr>
-              <a:t>26 scams across 13 types and 24 genuine messages.</a:t>
+              <a:t>a small test, not a guarantee; real traffic will differ. 26 scams over 13 types, 24 genuine.</a:t>
             </a:r>
           </a:p>
           <a:p>
@@ -10784,7 +10841,7 @@
                 </a:solidFill>
                 <a:latin typeface="Avenir Next Demi Bold"/>
               </a:rPr>
-              <a:t>Model: </a:t>
+              <a:t>Why gemini-3.7-flash: </a:t>
             </a:r>
             <a:r>
               <a:rPr sz="1150" i="0">
@@ -10793,7 +10850,7 @@
                 </a:solidFill>
                 <a:latin typeface="Avenir Next"/>
               </a:rPr>
-              <a:t>gemini-3.7-flash, with gemini-2.5-flash as fallback.</a:t>
+              <a:t>an earlier run on gemini-3.8-flash scored 98.0% accuracy with 4.2% false positives and image checks up to 34 s. Fallback: 2.5-flash.</a:t>
             </a:r>
           </a:p>
           <a:p>
@@ -10805,7 +10862,7 @@
                 <a:spcPts val="0"/>
               </a:spcBef>
               <a:spcAft>
-                <a:spcPts val="400"/>
+                <a:spcPts val="0"/>
               </a:spcAft>
               <a:buClr>
                 <a:srgbClr val="1764E8"/>
@@ -10816,33 +10873,6 @@
             <a:r>
               <a:rPr sz="1150" i="0">
                 <a:solidFill>
-                  <a:srgbClr val="0B1F33"/>
-                </a:solidFill>
-                <a:latin typeface="Avenir Next"/>
-              </a:rPr>
-              <a:t>Errors: 0. False positives: none.</a:t>
-            </a:r>
-          </a:p>
-          <a:p>
-            <a:pPr algn="l" marL="155448" indent="-155448">
-              <a:lnSpc>
-                <a:spcPct val="100000"/>
-              </a:lnSpc>
-              <a:spcBef>
-                <a:spcPts val="0"/>
-              </a:spcBef>
-              <a:spcAft>
-                <a:spcPts val="0"/>
-              </a:spcAft>
-              <a:buClr>
-                <a:srgbClr val="1764E8"/>
-              </a:buClr>
-              <a:buFont typeface="Arial"/>
-              <a:buChar char="•"/>
-            </a:pPr>
-            <a:r>
-              <a:rPr sz="1150" i="0">
-                <a:solidFill>
                   <a:srgbClr val="081B32"/>
                 </a:solidFill>
                 <a:latin typeface="Avenir Next Demi Bold"/>
@@ -10856,7 +10886,7 @@
                 </a:solidFill>
                 <a:latin typeface="Avenir Next"/>
               </a:rPr>
-              <a:t>(the model did not know today's date); it was fixed and re-measured.</a:t>
+              <a:t>(the model did not know today's date); fixed and re-measured.</a:t>
             </a:r>
           </a:p>
         </p:txBody>
@@ -11048,7 +11078,7 @@
         <p:spPr>
           <a:xfrm>
             <a:off x="365760" y="1207008"/>
-            <a:ext cx="2679192" cy="1097280"/>
+            <a:ext cx="1965960" cy="1097280"/>
           </a:xfrm>
           <a:prstGeom prst="roundRect">
             <a:avLst>
@@ -11095,7 +11125,7 @@
         </p:nvSpPr>
         <p:spPr>
           <a:xfrm>
-            <a:off x="512064" y="1335024"/>
+            <a:off x="493776" y="1335024"/>
             <a:ext cx="347472" cy="347472"/>
           </a:xfrm>
           <a:prstGeom prst="roundRect">
@@ -11149,7 +11179,7 @@
         </p:blipFill>
         <p:spPr>
           <a:xfrm>
-            <a:off x="595457" y="1418417"/>
+            <a:off x="577169" y="1418417"/>
             <a:ext cx="180685" cy="180685"/>
           </a:xfrm>
           <a:prstGeom prst="rect">
@@ -11165,8 +11195,8 @@
         </p:nvSpPr>
         <p:spPr>
           <a:xfrm>
-            <a:off x="969264" y="1335024"/>
-            <a:ext cx="1965960" cy="347472"/>
+            <a:off x="932688" y="1316736"/>
+            <a:ext cx="1307592" cy="384048"/>
           </a:xfrm>
           <a:prstGeom prst="rect">
             <a:avLst/>
@@ -11191,7 +11221,7 @@
               </a:spcAft>
             </a:pPr>
             <a:r>
-              <a:rPr sz="1250" i="0">
+              <a:rPr sz="1200" i="0">
                 <a:solidFill>
                   <a:srgbClr val="081B32"/>
                 </a:solidFill>
@@ -11210,8 +11240,8 @@
         </p:nvSpPr>
         <p:spPr>
           <a:xfrm>
-            <a:off x="512064" y="1828800"/>
-            <a:ext cx="2386584" cy="438912"/>
+            <a:off x="512064" y="1773936"/>
+            <a:ext cx="1691639" cy="493775"/>
           </a:xfrm>
           <a:prstGeom prst="rect">
             <a:avLst/>
@@ -11236,7 +11266,7 @@
               </a:spcAft>
             </a:pPr>
             <a:r>
-              <a:rPr sz="1200" i="0">
+              <a:rPr sz="1150" i="0">
                 <a:solidFill>
                   <a:srgbClr val="0B1F33"/>
                 </a:solidFill>
@@ -11255,8 +11285,8 @@
         </p:nvSpPr>
         <p:spPr>
           <a:xfrm>
-            <a:off x="3227832" y="1207008"/>
-            <a:ext cx="2679192" cy="1097280"/>
+            <a:off x="2514600" y="1207008"/>
+            <a:ext cx="1965960" cy="1097280"/>
           </a:xfrm>
           <a:prstGeom prst="roundRect">
             <a:avLst>
@@ -11303,7 +11333,7 @@
         </p:nvSpPr>
         <p:spPr>
           <a:xfrm>
-            <a:off x="3374136" y="1335024"/>
+            <a:off x="2642616" y="1335024"/>
             <a:ext cx="347472" cy="347472"/>
           </a:xfrm>
           <a:prstGeom prst="roundRect">
@@ -11357,7 +11387,7 @@
         </p:blipFill>
         <p:spPr>
           <a:xfrm>
-            <a:off x="3457529" y="1418417"/>
+            <a:off x="2726009" y="1418417"/>
             <a:ext cx="180685" cy="180685"/>
           </a:xfrm>
           <a:prstGeom prst="rect">
@@ -11373,8 +11403,8 @@
         </p:nvSpPr>
         <p:spPr>
           <a:xfrm>
-            <a:off x="3831336" y="1335024"/>
-            <a:ext cx="1965960" cy="347472"/>
+            <a:off x="3081528" y="1316736"/>
+            <a:ext cx="1307592" cy="384048"/>
           </a:xfrm>
           <a:prstGeom prst="rect">
             <a:avLst/>
@@ -11399,7 +11429,7 @@
               </a:spcAft>
             </a:pPr>
             <a:r>
-              <a:rPr sz="1250" i="0">
+              <a:rPr sz="1200" i="0">
                 <a:solidFill>
                   <a:srgbClr val="081B32"/>
                 </a:solidFill>
@@ -11418,8 +11448,8 @@
         </p:nvSpPr>
         <p:spPr>
           <a:xfrm>
-            <a:off x="3374136" y="1828800"/>
-            <a:ext cx="2386584" cy="438912"/>
+            <a:off x="2660904" y="1773936"/>
+            <a:ext cx="1691639" cy="493775"/>
           </a:xfrm>
           <a:prstGeom prst="rect">
             <a:avLst/>
@@ -11444,7 +11474,7 @@
               </a:spcAft>
             </a:pPr>
             <a:r>
-              <a:rPr sz="1200" i="0">
+              <a:rPr sz="1150" i="0">
                 <a:solidFill>
                   <a:srgbClr val="0B1F33"/>
                 </a:solidFill>
@@ -11463,8 +11493,8 @@
         </p:nvSpPr>
         <p:spPr>
           <a:xfrm>
-            <a:off x="6089904" y="1207008"/>
-            <a:ext cx="2679192" cy="1097280"/>
+            <a:off x="4663440" y="1207008"/>
+            <a:ext cx="1965960" cy="1097280"/>
           </a:xfrm>
           <a:prstGeom prst="roundRect">
             <a:avLst>
@@ -11511,7 +11541,7 @@
         </p:nvSpPr>
         <p:spPr>
           <a:xfrm>
-            <a:off x="6236208" y="1335024"/>
+            <a:off x="4791456" y="1335024"/>
             <a:ext cx="347472" cy="347472"/>
           </a:xfrm>
           <a:prstGeom prst="roundRect">
@@ -11565,7 +11595,7 @@
         </p:blipFill>
         <p:spPr>
           <a:xfrm>
-            <a:off x="6319601" y="1418417"/>
+            <a:off x="4874849" y="1418417"/>
             <a:ext cx="180685" cy="180685"/>
           </a:xfrm>
           <a:prstGeom prst="rect">
@@ -11581,8 +11611,8 @@
         </p:nvSpPr>
         <p:spPr>
           <a:xfrm>
-            <a:off x="6693408" y="1335024"/>
-            <a:ext cx="1965960" cy="347472"/>
+            <a:off x="5230368" y="1316736"/>
+            <a:ext cx="1307592" cy="384048"/>
           </a:xfrm>
           <a:prstGeom prst="rect">
             <a:avLst/>
@@ -11607,7 +11637,7 @@
               </a:spcAft>
             </a:pPr>
             <a:r>
-              <a:rPr sz="1250" i="0">
+              <a:rPr sz="1200" i="0">
                 <a:solidFill>
                   <a:srgbClr val="081B32"/>
                 </a:solidFill>
@@ -11626,8 +11656,8 @@
         </p:nvSpPr>
         <p:spPr>
           <a:xfrm>
-            <a:off x="6236208" y="1828800"/>
-            <a:ext cx="2386584" cy="438912"/>
+            <a:off x="4809744" y="1773936"/>
+            <a:ext cx="1691639" cy="493775"/>
           </a:xfrm>
           <a:prstGeom prst="rect">
             <a:avLst/>
@@ -11652,7 +11682,7 @@
               </a:spcAft>
             </a:pPr>
             <a:r>
-              <a:rPr sz="1200" i="0">
+              <a:rPr sz="1150" i="0">
                 <a:solidFill>
                   <a:srgbClr val="0B1F33"/>
                 </a:solidFill>
@@ -11671,8 +11701,8 @@
         </p:nvSpPr>
         <p:spPr>
           <a:xfrm>
-            <a:off x="365760" y="2414015"/>
-            <a:ext cx="2679192" cy="1097280"/>
+            <a:off x="6812280" y="1207008"/>
+            <a:ext cx="1965960" cy="1097280"/>
           </a:xfrm>
           <a:prstGeom prst="roundRect">
             <a:avLst>
@@ -11719,7 +11749,7 @@
         </p:nvSpPr>
         <p:spPr>
           <a:xfrm>
-            <a:off x="512064" y="2542032"/>
+            <a:off x="6940296" y="1335024"/>
             <a:ext cx="347472" cy="347472"/>
           </a:xfrm>
           <a:prstGeom prst="roundRect">
@@ -11773,7 +11803,7 @@
         </p:blipFill>
         <p:spPr>
           <a:xfrm>
-            <a:off x="595457" y="2625425"/>
+            <a:off x="7023689" y="1418417"/>
             <a:ext cx="180685" cy="180685"/>
           </a:xfrm>
           <a:prstGeom prst="rect">
@@ -11789,8 +11819,8 @@
         </p:nvSpPr>
         <p:spPr>
           <a:xfrm>
-            <a:off x="969264" y="2542032"/>
-            <a:ext cx="1965960" cy="347472"/>
+            <a:off x="7379208" y="1316736"/>
+            <a:ext cx="1307592" cy="384048"/>
           </a:xfrm>
           <a:prstGeom prst="rect">
             <a:avLst/>
@@ -11815,7 +11845,7 @@
               </a:spcAft>
             </a:pPr>
             <a:r>
-              <a:rPr sz="1250" i="0">
+              <a:rPr sz="1200" i="0">
                 <a:solidFill>
                   <a:srgbClr val="081B32"/>
                 </a:solidFill>
@@ -11834,8 +11864,8 @@
         </p:nvSpPr>
         <p:spPr>
           <a:xfrm>
-            <a:off x="512064" y="3035808"/>
-            <a:ext cx="2386584" cy="438912"/>
+            <a:off x="6958584" y="1773936"/>
+            <a:ext cx="1691639" cy="493775"/>
           </a:xfrm>
           <a:prstGeom prst="rect">
             <a:avLst/>
@@ -11860,13 +11890,13 @@
               </a:spcAft>
             </a:pPr>
             <a:r>
-              <a:rPr sz="1200" i="0">
+              <a:rPr sz="1150" i="0">
                 <a:solidFill>
                   <a:srgbClr val="0B1F33"/>
                 </a:solidFill>
                 <a:latin typeface="Avenir Next"/>
               </a:rPr>
-              <a:t>Share SMS and notifications straight to a check.</a:t>
+              <a:t>Share SMS and notifications to a check.</a:t>
             </a:r>
           </a:p>
         </p:txBody>
@@ -11879,8 +11909,8 @@
         </p:nvSpPr>
         <p:spPr>
           <a:xfrm>
-            <a:off x="3227832" y="2414015"/>
-            <a:ext cx="2679192" cy="1097280"/>
+            <a:off x="365760" y="2414015"/>
+            <a:ext cx="1965960" cy="1097280"/>
           </a:xfrm>
           <a:prstGeom prst="roundRect">
             <a:avLst>
@@ -11927,7 +11957,7 @@
         </p:nvSpPr>
         <p:spPr>
           <a:xfrm>
-            <a:off x="3374136" y="2542032"/>
+            <a:off x="493776" y="2542032"/>
             <a:ext cx="347472" cy="347472"/>
           </a:xfrm>
           <a:prstGeom prst="roundRect">
@@ -11981,7 +12011,7 @@
         </p:blipFill>
         <p:spPr>
           <a:xfrm>
-            <a:off x="3457529" y="2625425"/>
+            <a:off x="577169" y="2625425"/>
             <a:ext cx="180685" cy="180685"/>
           </a:xfrm>
           <a:prstGeom prst="rect">
@@ -11997,8 +12027,8 @@
         </p:nvSpPr>
         <p:spPr>
           <a:xfrm>
-            <a:off x="3831336" y="2542032"/>
-            <a:ext cx="1965960" cy="347472"/>
+            <a:off x="932688" y="2523744"/>
+            <a:ext cx="1307592" cy="384048"/>
           </a:xfrm>
           <a:prstGeom prst="rect">
             <a:avLst/>
@@ -12023,7 +12053,7 @@
               </a:spcAft>
             </a:pPr>
             <a:r>
-              <a:rPr sz="1250" i="0">
+              <a:rPr sz="1200" i="0">
                 <a:solidFill>
                   <a:srgbClr val="081B32"/>
                 </a:solidFill>
@@ -12042,8 +12072,8 @@
         </p:nvSpPr>
         <p:spPr>
           <a:xfrm>
-            <a:off x="3374136" y="3035808"/>
-            <a:ext cx="2386584" cy="438912"/>
+            <a:off x="512064" y="2980944"/>
+            <a:ext cx="1691639" cy="493775"/>
           </a:xfrm>
           <a:prstGeom prst="rect">
             <a:avLst/>
@@ -12068,7 +12098,7 @@
               </a:spcAft>
             </a:pPr>
             <a:r>
-              <a:rPr sz="1200" i="0">
+              <a:rPr sz="1150" i="0">
                 <a:solidFill>
                   <a:srgbClr val="0B1F33"/>
                 </a:solidFill>
@@ -12087,8 +12117,8 @@
         </p:nvSpPr>
         <p:spPr>
           <a:xfrm>
-            <a:off x="6089904" y="2414015"/>
-            <a:ext cx="2679192" cy="1097280"/>
+            <a:off x="2514600" y="2414015"/>
+            <a:ext cx="1965960" cy="1097280"/>
           </a:xfrm>
           <a:prstGeom prst="roundRect">
             <a:avLst>
@@ -12135,7 +12165,7 @@
         </p:nvSpPr>
         <p:spPr>
           <a:xfrm>
-            <a:off x="6236208" y="2542032"/>
+            <a:off x="2642616" y="2542032"/>
             <a:ext cx="347472" cy="347472"/>
           </a:xfrm>
           <a:prstGeom prst="roundRect">
@@ -12189,7 +12219,7 @@
         </p:blipFill>
         <p:spPr>
           <a:xfrm>
-            <a:off x="6319601" y="2625425"/>
+            <a:off x="2726009" y="2625425"/>
             <a:ext cx="180685" cy="180685"/>
           </a:xfrm>
           <a:prstGeom prst="rect">
@@ -12205,8 +12235,8 @@
         </p:nvSpPr>
         <p:spPr>
           <a:xfrm>
-            <a:off x="6693408" y="2542032"/>
-            <a:ext cx="1965960" cy="347472"/>
+            <a:off x="3081528" y="2523744"/>
+            <a:ext cx="1307592" cy="384048"/>
           </a:xfrm>
           <a:prstGeom prst="rect">
             <a:avLst/>
@@ -12231,7 +12261,7 @@
               </a:spcAft>
             </a:pPr>
             <a:r>
-              <a:rPr sz="1250" i="0">
+              <a:rPr sz="1200" i="0">
                 <a:solidFill>
                   <a:srgbClr val="081B32"/>
                 </a:solidFill>
@@ -12250,8 +12280,8 @@
         </p:nvSpPr>
         <p:spPr>
           <a:xfrm>
-            <a:off x="6236208" y="3035808"/>
-            <a:ext cx="2386584" cy="438912"/>
+            <a:off x="2660904" y="2980944"/>
+            <a:ext cx="1691639" cy="493775"/>
           </a:xfrm>
           <a:prstGeom prst="rect">
             <a:avLst/>
@@ -12276,13 +12306,13 @@
               </a:spcAft>
             </a:pPr>
             <a:r>
-              <a:rPr sz="1200" i="0">
+              <a:rPr sz="1150" i="0">
                 <a:solidFill>
                   <a:srgbClr val="0B1F33"/>
                 </a:solidFill>
                 <a:latin typeface="Avenir Next"/>
               </a:rPr>
-              <a:t>Extend today's voice-note check to recorded calls.</a:t>
+              <a:t>Check recorded calls, not just voice notes.</a:t>
             </a:r>
           </a:p>
         </p:txBody>
@@ -12295,12 +12325,320 @@
         </p:nvSpPr>
         <p:spPr>
           <a:xfrm>
-            <a:off x="365760" y="3657600"/>
-            <a:ext cx="8412480" cy="1261872"/>
+            <a:off x="4663440" y="2414015"/>
+            <a:ext cx="1965960" cy="1097280"/>
           </a:xfrm>
           <a:prstGeom prst="roundRect">
             <a:avLst>
-              <a:gd name="adj" fmla="val 6521"/>
+              <a:gd name="adj" fmla="val 5833"/>
+            </a:avLst>
+          </a:prstGeom>
+          <a:solidFill>
+            <a:srgbClr val="FFFFFF"/>
+          </a:solidFill>
+          <a:ln w="9525">
+            <a:solidFill>
+              <a:srgbClr val="D5DEEB"/>
+            </a:solidFill>
+          </a:ln>
+          <a:effectLst/>
+        </p:spPr>
+        <p:style>
+          <a:lnRef idx="1">
+            <a:schemeClr val="accent1"/>
+          </a:lnRef>
+          <a:fillRef idx="3">
+            <a:schemeClr val="accent1"/>
+          </a:fillRef>
+          <a:effectRef idx="2">
+            <a:schemeClr val="accent1"/>
+          </a:effectRef>
+          <a:fontRef idx="minor">
+            <a:schemeClr val="lt1"/>
+          </a:fontRef>
+        </p:style>
+        <p:txBody>
+          <a:bodyPr rtlCol="0" anchor="ctr"/>
+          <a:lstStyle/>
+          <a:p>
+            <a:pPr algn="ctr"/>
+          </a:p>
+        </p:txBody>
+      </p:sp>
+      <p:sp>
+        <p:nvSpPr>
+          <p:cNvPr id="183" name="Rounded Rectangle 182"/>
+          <p:cNvSpPr/>
+          <p:nvPr/>
+        </p:nvSpPr>
+        <p:spPr>
+          <a:xfrm>
+            <a:off x="4791456" y="2542032"/>
+            <a:ext cx="347472" cy="347472"/>
+          </a:xfrm>
+          <a:prstGeom prst="roundRect">
+            <a:avLst>
+              <a:gd name="adj" fmla="val 28000"/>
+            </a:avLst>
+          </a:prstGeom>
+          <a:solidFill>
+            <a:srgbClr val="E8F0FE"/>
+          </a:solidFill>
+          <a:ln>
+            <a:noFill/>
+          </a:ln>
+          <a:effectLst/>
+        </p:spPr>
+        <p:style>
+          <a:lnRef idx="1">
+            <a:schemeClr val="accent1"/>
+          </a:lnRef>
+          <a:fillRef idx="3">
+            <a:schemeClr val="accent1"/>
+          </a:fillRef>
+          <a:effectRef idx="2">
+            <a:schemeClr val="accent1"/>
+          </a:effectRef>
+          <a:fontRef idx="minor">
+            <a:schemeClr val="lt1"/>
+          </a:fontRef>
+        </p:style>
+        <p:txBody>
+          <a:bodyPr rtlCol="0" anchor="ctr"/>
+          <a:lstStyle/>
+          <a:p>
+            <a:pPr algn="ctr"/>
+          </a:p>
+        </p:txBody>
+      </p:sp>
+      <p:pic>
+        <p:nvPicPr>
+          <p:cNvPr id="184" name="Picture 183" descr="i-brain-blue.png"/>
+          <p:cNvPicPr>
+            <a:picLocks noChangeAspect="1"/>
+          </p:cNvPicPr>
+          <p:nvPr/>
+        </p:nvPicPr>
+        <p:blipFill>
+          <a:blip r:embed="rId11"/>
+          <a:stretch>
+            <a:fillRect/>
+          </a:stretch>
+        </p:blipFill>
+        <p:spPr>
+          <a:xfrm>
+            <a:off x="4874849" y="2625425"/>
+            <a:ext cx="180685" cy="180685"/>
+          </a:xfrm>
+          <a:prstGeom prst="rect">
+            <a:avLst/>
+          </a:prstGeom>
+        </p:spPr>
+      </p:pic>
+      <p:sp>
+        <p:nvSpPr>
+          <p:cNvPr id="185" name="TextBox 184"/>
+          <p:cNvSpPr txBox="1"/>
+          <p:nvPr/>
+        </p:nvSpPr>
+        <p:spPr>
+          <a:xfrm>
+            <a:off x="5230368" y="2523744"/>
+            <a:ext cx="1307592" cy="384048"/>
+          </a:xfrm>
+          <a:prstGeom prst="rect">
+            <a:avLst/>
+          </a:prstGeom>
+          <a:noFill/>
+        </p:spPr>
+        <p:txBody>
+          <a:bodyPr wrap="square" anchor="ctr" lIns="0" rIns="0" tIns="0" bIns="0">
+            <a:spAutoFit/>
+          </a:bodyPr>
+          <a:lstStyle/>
+          <a:p>
+            <a:pPr algn="l">
+              <a:lnSpc>
+                <a:spcPct val="100000"/>
+              </a:lnSpc>
+              <a:spcBef>
+                <a:spcPts val="0"/>
+              </a:spcBef>
+              <a:spcAft>
+                <a:spcPts val="0"/>
+              </a:spcAft>
+            </a:pPr>
+            <a:r>
+              <a:rPr sz="1200" i="0">
+                <a:solidFill>
+                  <a:srgbClr val="081B32"/>
+                </a:solidFill>
+                <a:latin typeface="Avenir Next Demi Bold"/>
+              </a:rPr>
+              <a:t>Misinformation mode</a:t>
+            </a:r>
+          </a:p>
+        </p:txBody>
+      </p:sp>
+      <p:sp>
+        <p:nvSpPr>
+          <p:cNvPr id="186" name="TextBox 185"/>
+          <p:cNvSpPr txBox="1"/>
+          <p:nvPr/>
+        </p:nvSpPr>
+        <p:spPr>
+          <a:xfrm>
+            <a:off x="4809744" y="2980944"/>
+            <a:ext cx="1691639" cy="493775"/>
+          </a:xfrm>
+          <a:prstGeom prst="rect">
+            <a:avLst/>
+          </a:prstGeom>
+          <a:noFill/>
+        </p:spPr>
+        <p:txBody>
+          <a:bodyPr wrap="square" anchor="t" lIns="0" rIns="0" tIns="0" bIns="0">
+            <a:spAutoFit/>
+          </a:bodyPr>
+          <a:lstStyle/>
+          <a:p>
+            <a:pPr algn="l">
+              <a:lnSpc>
+                <a:spcPct val="100000"/>
+              </a:lnSpc>
+              <a:spcBef>
+                <a:spcPts val="0"/>
+              </a:spcBef>
+              <a:spcAft>
+                <a:spcPts val="0"/>
+              </a:spcAft>
+            </a:pPr>
+            <a:r>
+              <a:rPr sz="1150" i="0">
+                <a:solidFill>
+                  <a:srgbClr val="0B1F33"/>
+                </a:solidFill>
+                <a:latin typeface="Avenir Next"/>
+              </a:rPr>
+              <a:t>The same engine for "is this forward real?"</a:t>
+            </a:r>
+          </a:p>
+        </p:txBody>
+      </p:sp>
+      <p:sp>
+        <p:nvSpPr>
+          <p:cNvPr id="187" name="Rounded Rectangle 186"/>
+          <p:cNvSpPr/>
+          <p:nvPr/>
+        </p:nvSpPr>
+        <p:spPr>
+          <a:xfrm>
+            <a:off x="6812280" y="2414015"/>
+            <a:ext cx="1965960" cy="1097280"/>
+          </a:xfrm>
+          <a:prstGeom prst="roundRect">
+            <a:avLst>
+              <a:gd name="adj" fmla="val 5833"/>
+            </a:avLst>
+          </a:prstGeom>
+          <a:solidFill>
+            <a:srgbClr val="F1F5FB"/>
+          </a:solidFill>
+          <a:ln>
+            <a:noFill/>
+          </a:ln>
+          <a:effectLst/>
+        </p:spPr>
+        <p:style>
+          <a:lnRef idx="1">
+            <a:schemeClr val="accent1"/>
+          </a:lnRef>
+          <a:fillRef idx="3">
+            <a:schemeClr val="accent1"/>
+          </a:fillRef>
+          <a:effectRef idx="2">
+            <a:schemeClr val="accent1"/>
+          </a:effectRef>
+          <a:fontRef idx="minor">
+            <a:schemeClr val="lt1"/>
+          </a:fontRef>
+        </p:style>
+        <p:txBody>
+          <a:bodyPr rtlCol="0" anchor="ctr"/>
+          <a:lstStyle/>
+          <a:p>
+            <a:pPr algn="ctr"/>
+          </a:p>
+        </p:txBody>
+      </p:sp>
+      <p:sp>
+        <p:nvSpPr>
+          <p:cNvPr id="188" name="TextBox 187"/>
+          <p:cNvSpPr txBox="1"/>
+          <p:nvPr/>
+        </p:nvSpPr>
+        <p:spPr>
+          <a:xfrm>
+            <a:off x="6958584" y="2414015"/>
+            <a:ext cx="1691639" cy="1097280"/>
+          </a:xfrm>
+          <a:prstGeom prst="rect">
+            <a:avLst/>
+          </a:prstGeom>
+          <a:noFill/>
+        </p:spPr>
+        <p:txBody>
+          <a:bodyPr wrap="square" anchor="ctr" lIns="0" rIns="0" tIns="0" bIns="0">
+            <a:spAutoFit/>
+          </a:bodyPr>
+          <a:lstStyle/>
+          <a:p>
+            <a:pPr algn="l">
+              <a:lnSpc>
+                <a:spcPct val="100000"/>
+              </a:lnSpc>
+              <a:spcBef>
+                <a:spcPts val="0"/>
+              </a:spcBef>
+              <a:spcAft>
+                <a:spcPts val="0"/>
+              </a:spcAft>
+            </a:pPr>
+            <a:r>
+              <a:rPr sz="1150" i="0">
+                <a:solidFill>
+                  <a:srgbClr val="1764E8"/>
+                </a:solidFill>
+                <a:latin typeface="Avenir Next Demi Bold"/>
+              </a:rPr>
+              <a:t>Plans, not shipped. </a:t>
+            </a:r>
+            <a:r>
+              <a:rPr sz="1150" i="0">
+                <a:solidFill>
+                  <a:srgbClr val="0B1F33"/>
+                </a:solidFill>
+                <a:latin typeface="Avenir Next"/>
+              </a:rPr>
+              <a:t>Search grounding is built but off by default.</a:t>
+            </a:r>
+          </a:p>
+        </p:txBody>
+      </p:sp>
+      <p:sp>
+        <p:nvSpPr>
+          <p:cNvPr id="189" name="Rounded Rectangle 188"/>
+          <p:cNvSpPr/>
+          <p:nvPr/>
+        </p:nvSpPr>
+        <p:spPr>
+          <a:xfrm>
+            <a:off x="365760" y="3639312"/>
+            <a:ext cx="8412480" cy="1280160"/>
+          </a:xfrm>
+          <a:prstGeom prst="roundRect">
+            <a:avLst>
+              <a:gd name="adj" fmla="val 6428"/>
             </a:avLst>
           </a:prstGeom>
           <a:solidFill>
@@ -12335,13 +12673,13 @@
       </p:sp>
       <p:sp>
         <p:nvSpPr>
-          <p:cNvPr id="183" name="TextBox 182"/>
+          <p:cNvPr id="190" name="TextBox 189"/>
           <p:cNvSpPr txBox="1"/>
           <p:nvPr/>
         </p:nvSpPr>
         <p:spPr>
           <a:xfrm>
-            <a:off x="566928" y="3767328"/>
+            <a:off x="566928" y="3749039"/>
             <a:ext cx="8010144" cy="256032"/>
           </a:xfrm>
           <a:prstGeom prst="rect">
@@ -12380,14 +12718,14 @@
       </p:sp>
       <p:sp>
         <p:nvSpPr>
-          <p:cNvPr id="184" name="TextBox 183"/>
+          <p:cNvPr id="191" name="TextBox 190"/>
           <p:cNvSpPr txBox="1"/>
           <p:nvPr/>
         </p:nvSpPr>
         <p:spPr>
           <a:xfrm>
-            <a:off x="566928" y="4078224"/>
-            <a:ext cx="2505456" cy="804671"/>
+            <a:off x="566928" y="4023360"/>
+            <a:ext cx="2505456" cy="859536"/>
           </a:xfrm>
           <a:prstGeom prst="rect">
             <a:avLst/>
@@ -12434,7 +12772,7 @@
               </a:spcAft>
             </a:pPr>
             <a:r>
-              <a:rPr sz="1150" i="0">
+              <a:rPr sz="1200" i="0">
                 <a:solidFill>
                   <a:srgbClr val="C9D6EA"/>
                 </a:solidFill>
@@ -12447,14 +12785,14 @@
       </p:sp>
       <p:sp>
         <p:nvSpPr>
-          <p:cNvPr id="185" name="TextBox 184"/>
+          <p:cNvPr id="192" name="TextBox 191"/>
           <p:cNvSpPr txBox="1"/>
           <p:nvPr/>
         </p:nvSpPr>
         <p:spPr>
           <a:xfrm>
-            <a:off x="3236976" y="4078224"/>
-            <a:ext cx="2505456" cy="804671"/>
+            <a:off x="3236976" y="4023360"/>
+            <a:ext cx="2505456" cy="859536"/>
           </a:xfrm>
           <a:prstGeom prst="rect">
             <a:avLst/>
@@ -12501,7 +12839,7 @@
               </a:spcAft>
             </a:pPr>
             <a:r>
-              <a:rPr sz="1150" i="0">
+              <a:rPr sz="1200" i="0">
                 <a:solidFill>
                   <a:srgbClr val="C9D6EA"/>
                 </a:solidFill>
@@ -12514,14 +12852,14 @@
       </p:sp>
       <p:sp>
         <p:nvSpPr>
-          <p:cNvPr id="186" name="TextBox 185"/>
+          <p:cNvPr id="193" name="TextBox 192"/>
           <p:cNvSpPr txBox="1"/>
           <p:nvPr/>
         </p:nvSpPr>
         <p:spPr>
           <a:xfrm>
-            <a:off x="5907024" y="4078224"/>
-            <a:ext cx="2505456" cy="804671"/>
+            <a:off x="5907024" y="4023360"/>
+            <a:ext cx="2505456" cy="859536"/>
           </a:xfrm>
           <a:prstGeom prst="rect">
             <a:avLst/>
@@ -12568,7 +12906,7 @@
               </a:spcAft>
             </a:pPr>
             <a:r>
-              <a:rPr sz="1150" i="0">
+              <a:rPr sz="1200" i="0">
                 <a:solidFill>
                   <a:srgbClr val="C9D6EA"/>
                 </a:solidFill>
@@ -12855,13 +13193,13 @@
               <a:t>[add the public video link here]</a:t>
             </a:r>
             <a:r>
-              <a:rPr sz="1100" i="1">
+              <a:rPr sz="1150" i="0">
                 <a:solidFill>
                   <a:srgbClr val="9A5B00"/>
                 </a:solidFill>
-                <a:latin typeface="Avenir Next"/>
+                <a:latin typeface="Avenir Next Demi Bold"/>
               </a:rPr>
-              <a:t>  (owner to fill in)</a:t>
+              <a:t>  PLACEHOLDER: owner to fill in</a:t>
             </a:r>
             <a:endParaRPr>
               <a:latin typeface="Google Sans Flex Medium"/>
@@ -13062,9 +13400,9 @@
               </a:spcAft>
             </a:pPr>
             <a:r>
-              <a:rPr sz="1100" i="0">
-                <a:solidFill>
-                  <a:srgbClr val="5B6778"/>
+              <a:rPr sz="1200" i="0">
+                <a:solidFill>
+                  <a:srgbClr val="3F4B5B"/>
                 </a:solidFill>
                 <a:latin typeface="Avenir Next"/>
               </a:rPr>
@@ -13434,7 +13772,7 @@
             <a:r>
               <a:rPr sz="1300" i="0">
                 <a:solidFill>
-                  <a:srgbClr val="5B6778"/>
+                  <a:srgbClr val="3F4B5B"/>
                 </a:solidFill>
                 <a:latin typeface="Avenir Next"/>
               </a:rPr>
@@ -13824,7 +14162,7 @@
             <a:r>
               <a:rPr sz="1100" i="0">
                 <a:solidFill>
-                  <a:srgbClr val="5B6778"/>
+                  <a:srgbClr val="3F4B5B"/>
                 </a:solidFill>
                 <a:latin typeface="Avenir Next"/>
               </a:rPr>
@@ -14330,7 +14668,7 @@
         <p:spPr>
           <a:xfrm>
             <a:off x="365760" y="1207008"/>
-            <a:ext cx="5074920" cy="749808"/>
+            <a:ext cx="5074920" cy="713232"/>
           </a:xfrm>
           <a:prstGeom prst="rect">
             <a:avLst/>
@@ -14351,7 +14689,7 @@
                 <a:spcPts val="0"/>
               </a:spcBef>
               <a:spcAft>
-                <a:spcPts val="400"/>
+                <a:spcPts val="300"/>
               </a:spcAft>
             </a:pPr>
             <a:r>
@@ -14379,11 +14717,11 @@
             <a:r>
               <a:rPr sz="1200" i="0">
                 <a:solidFill>
-                  <a:srgbClr val="5B6778"/>
+                  <a:srgbClr val="0B1F33"/>
                 </a:solidFill>
                 <a:latin typeface="Avenir Next"/>
               </a:rPr>
-              <a:t>Free for anyone in India; every report warns the next person.</a:t>
+              <a:t>Free for anyone in India, and built for the scams people meet here: fake payment receipts, "digital arrest" calls and UPI QR tricks.</a:t>
             </a:r>
           </a:p>
         </p:txBody>
@@ -14396,12 +14734,12 @@
         </p:nvSpPr>
         <p:spPr>
           <a:xfrm>
-            <a:off x="365760" y="2011680"/>
-            <a:ext cx="5074920" cy="914400"/>
+            <a:off x="365760" y="1984248"/>
+            <a:ext cx="5074920" cy="731520"/>
           </a:xfrm>
           <a:prstGeom prst="roundRect">
             <a:avLst>
-              <a:gd name="adj" fmla="val 7000"/>
+              <a:gd name="adj" fmla="val 8750"/>
             </a:avLst>
           </a:prstGeom>
           <a:solidFill>
@@ -14444,7 +14782,7 @@
         </p:nvSpPr>
         <p:spPr>
           <a:xfrm>
-            <a:off x="512064" y="2167128"/>
+            <a:off x="512064" y="2157984"/>
             <a:ext cx="384048" cy="384048"/>
           </a:xfrm>
           <a:prstGeom prst="roundRect">
@@ -14498,7 +14836,7 @@
         </p:blipFill>
         <p:spPr>
           <a:xfrm>
-            <a:off x="604235" y="2259299"/>
+            <a:off x="604235" y="2250155"/>
             <a:ext cx="199704" cy="199704"/>
           </a:xfrm>
           <a:prstGeom prst="rect">
@@ -14514,8 +14852,8 @@
         </p:nvSpPr>
         <p:spPr>
           <a:xfrm>
-            <a:off x="1078992" y="2139696"/>
-            <a:ext cx="4206240" cy="731520"/>
+            <a:off x="1078992" y="1984248"/>
+            <a:ext cx="4233672" cy="731520"/>
           </a:xfrm>
           <a:prstGeom prst="rect">
             <a:avLst/>
@@ -14523,7 +14861,7 @@
           <a:noFill/>
         </p:spPr>
         <p:txBody>
-          <a:bodyPr wrap="square" anchor="t" lIns="0" rIns="0" tIns="0" bIns="0">
+          <a:bodyPr wrap="square" anchor="ctr" lIns="0" rIns="0" tIns="0" bIns="0">
             <a:spAutoFit/>
           </a:bodyPr>
           <a:lstStyle/>
@@ -14536,11 +14874,11 @@
                 <a:spcPts val="0"/>
               </a:spcBef>
               <a:spcAft>
-                <a:spcPts val="200"/>
+                <a:spcPts val="100"/>
               </a:spcAft>
             </a:pPr>
             <a:r>
-              <a:rPr sz="1300" i="0">
+              <a:rPr sz="1250" i="0">
                 <a:solidFill>
                   <a:srgbClr val="081B32"/>
                 </a:solidFill>
@@ -14562,7 +14900,7 @@
               </a:spcAft>
             </a:pPr>
             <a:r>
-              <a:rPr sz="1200" i="0">
+              <a:rPr sz="1150" i="0">
                 <a:solidFill>
                   <a:srgbClr val="0B1F33"/>
                 </a:solidFill>
@@ -14581,12 +14919,12 @@
         </p:nvSpPr>
         <p:spPr>
           <a:xfrm>
-            <a:off x="365760" y="3008376"/>
-            <a:ext cx="5074920" cy="914400"/>
+            <a:off x="365760" y="2779776"/>
+            <a:ext cx="5074920" cy="731520"/>
           </a:xfrm>
           <a:prstGeom prst="roundRect">
             <a:avLst>
-              <a:gd name="adj" fmla="val 7000"/>
+              <a:gd name="adj" fmla="val 8750"/>
             </a:avLst>
           </a:prstGeom>
           <a:solidFill>
@@ -14629,7 +14967,7 @@
         </p:nvSpPr>
         <p:spPr>
           <a:xfrm>
-            <a:off x="512064" y="3163824"/>
+            <a:off x="512064" y="2953512"/>
             <a:ext cx="384048" cy="384048"/>
           </a:xfrm>
           <a:prstGeom prst="roundRect">
@@ -14683,7 +15021,7 @@
         </p:blipFill>
         <p:spPr>
           <a:xfrm>
-            <a:off x="604235" y="3255995"/>
+            <a:off x="604235" y="3045683"/>
             <a:ext cx="199704" cy="199704"/>
           </a:xfrm>
           <a:prstGeom prst="rect">
@@ -14699,8 +15037,8 @@
         </p:nvSpPr>
         <p:spPr>
           <a:xfrm>
-            <a:off x="1078992" y="3136392"/>
-            <a:ext cx="4206240" cy="731520"/>
+            <a:off x="1078992" y="2779776"/>
+            <a:ext cx="4233672" cy="731520"/>
           </a:xfrm>
           <a:prstGeom prst="rect">
             <a:avLst/>
@@ -14708,7 +15046,7 @@
           <a:noFill/>
         </p:spPr>
         <p:txBody>
-          <a:bodyPr wrap="square" anchor="t" lIns="0" rIns="0" tIns="0" bIns="0">
+          <a:bodyPr wrap="square" anchor="ctr" lIns="0" rIns="0" tIns="0" bIns="0">
             <a:spAutoFit/>
           </a:bodyPr>
           <a:lstStyle/>
@@ -14721,11 +15059,11 @@
                 <a:spcPts val="0"/>
               </a:spcBef>
               <a:spcAft>
-                <a:spcPts val="200"/>
+                <a:spcPts val="100"/>
               </a:spcAft>
             </a:pPr>
             <a:r>
-              <a:rPr sz="1300" i="0">
+              <a:rPr sz="1250" i="0">
                 <a:solidFill>
                   <a:srgbClr val="081B32"/>
                 </a:solidFill>
@@ -14747,7 +15085,7 @@
               </a:spcAft>
             </a:pPr>
             <a:r>
-              <a:rPr sz="1200" i="0">
+              <a:rPr sz="1150" i="0">
                 <a:solidFill>
                   <a:srgbClr val="0B1F33"/>
                 </a:solidFill>
@@ -14766,12 +15104,12 @@
         </p:nvSpPr>
         <p:spPr>
           <a:xfrm>
-            <a:off x="365760" y="4005072"/>
-            <a:ext cx="5074920" cy="914400"/>
+            <a:off x="365760" y="3575304"/>
+            <a:ext cx="5074920" cy="731520"/>
           </a:xfrm>
           <a:prstGeom prst="roundRect">
             <a:avLst>
-              <a:gd name="adj" fmla="val 7000"/>
+              <a:gd name="adj" fmla="val 8750"/>
             </a:avLst>
           </a:prstGeom>
           <a:solidFill>
@@ -14814,7 +15152,7 @@
         </p:nvSpPr>
         <p:spPr>
           <a:xfrm>
-            <a:off x="512064" y="4160520"/>
+            <a:off x="512064" y="3749040"/>
             <a:ext cx="384048" cy="384048"/>
           </a:xfrm>
           <a:prstGeom prst="roundRect">
@@ -14868,7 +15206,7 @@
         </p:blipFill>
         <p:spPr>
           <a:xfrm>
-            <a:off x="604235" y="4252691"/>
+            <a:off x="604235" y="3841211"/>
             <a:ext cx="199704" cy="199704"/>
           </a:xfrm>
           <a:prstGeom prst="rect">
@@ -14884,8 +15222,8 @@
         </p:nvSpPr>
         <p:spPr>
           <a:xfrm>
-            <a:off x="1078992" y="4133087"/>
-            <a:ext cx="4206240" cy="731520"/>
+            <a:off x="1078992" y="3575304"/>
+            <a:ext cx="4233672" cy="731520"/>
           </a:xfrm>
           <a:prstGeom prst="rect">
             <a:avLst/>
@@ -14893,7 +15231,7 @@
           <a:noFill/>
         </p:spPr>
         <p:txBody>
-          <a:bodyPr wrap="square" anchor="t" lIns="0" rIns="0" tIns="0" bIns="0">
+          <a:bodyPr wrap="square" anchor="ctr" lIns="0" rIns="0" tIns="0" bIns="0">
             <a:spAutoFit/>
           </a:bodyPr>
           <a:lstStyle/>
@@ -14906,11 +15244,11 @@
                 <a:spcPts val="0"/>
               </a:spcBef>
               <a:spcAft>
-                <a:spcPts val="200"/>
+                <a:spcPts val="100"/>
               </a:spcAft>
             </a:pPr>
             <a:r>
-              <a:rPr sz="1300" i="0">
+              <a:rPr sz="1250" i="0">
                 <a:solidFill>
                   <a:srgbClr val="081B32"/>
                 </a:solidFill>
@@ -14932,7 +15270,7 @@
               </a:spcAft>
             </a:pPr>
             <a:r>
-              <a:rPr sz="1200" i="0">
+              <a:rPr sz="1150" i="0">
                 <a:solidFill>
                   <a:srgbClr val="0B1F33"/>
                 </a:solidFill>
@@ -14946,6 +15284,106 @@
       <p:sp>
         <p:nvSpPr>
           <p:cNvPr id="85" name="Rounded Rectangle 84"/>
+          <p:cNvSpPr/>
+          <p:nvPr/>
+        </p:nvSpPr>
+        <p:spPr>
+          <a:xfrm>
+            <a:off x="365760" y="4370832"/>
+            <a:ext cx="5074920" cy="548639"/>
+          </a:xfrm>
+          <a:prstGeom prst="roundRect">
+            <a:avLst>
+              <a:gd name="adj" fmla="val 13333"/>
+            </a:avLst>
+          </a:prstGeom>
+          <a:solidFill>
+            <a:srgbClr val="081B32"/>
+          </a:solidFill>
+          <a:ln>
+            <a:noFill/>
+          </a:ln>
+          <a:effectLst/>
+        </p:spPr>
+        <p:style>
+          <a:lnRef idx="1">
+            <a:schemeClr val="accent1"/>
+          </a:lnRef>
+          <a:fillRef idx="3">
+            <a:schemeClr val="accent1"/>
+          </a:fillRef>
+          <a:effectRef idx="2">
+            <a:schemeClr val="accent1"/>
+          </a:effectRef>
+          <a:fontRef idx="minor">
+            <a:schemeClr val="lt1"/>
+          </a:fontRef>
+        </p:style>
+        <p:txBody>
+          <a:bodyPr rtlCol="0" anchor="ctr"/>
+          <a:lstStyle/>
+          <a:p>
+            <a:pPr algn="ctr"/>
+          </a:p>
+        </p:txBody>
+      </p:sp>
+      <p:sp>
+        <p:nvSpPr>
+          <p:cNvPr id="86" name="TextBox 85"/>
+          <p:cNvSpPr txBox="1"/>
+          <p:nvPr/>
+        </p:nvSpPr>
+        <p:spPr>
+          <a:xfrm>
+            <a:off x="548640" y="4370832"/>
+            <a:ext cx="4709159" cy="548639"/>
+          </a:xfrm>
+          <a:prstGeom prst="rect">
+            <a:avLst/>
+          </a:prstGeom>
+          <a:noFill/>
+        </p:spPr>
+        <p:txBody>
+          <a:bodyPr wrap="square" anchor="ctr" lIns="0" rIns="0" tIns="0" bIns="0">
+            <a:spAutoFit/>
+          </a:bodyPr>
+          <a:lstStyle/>
+          <a:p>
+            <a:pPr algn="l">
+              <a:lnSpc>
+                <a:spcPct val="100000"/>
+              </a:lnSpc>
+              <a:spcBef>
+                <a:spcPts val="0"/>
+              </a:spcBef>
+              <a:spcAft>
+                <a:spcPts val="0"/>
+              </a:spcAft>
+            </a:pPr>
+            <a:r>
+              <a:rPr sz="1200" i="0">
+                <a:solidFill>
+                  <a:srgbClr val="34C9E8"/>
+                </a:solidFill>
+                <a:latin typeface="Avenir Next Demi Bold"/>
+              </a:rPr>
+              <a:t>Careful by design: </a:t>
+            </a:r>
+            <a:r>
+              <a:rPr sz="1200" i="0">
+                <a:solidFill>
+                  <a:srgbClr val="FFFFFF"/>
+                </a:solidFill>
+                <a:latin typeface="Avenir Next"/>
+              </a:rPr>
+              <a:t>links open in an isolated browser, never on your phone. It never says "safe": it gives guidance and you decide.</a:t>
+            </a:r>
+          </a:p>
+        </p:txBody>
+      </p:sp>
+      <p:sp>
+        <p:nvSpPr>
+          <p:cNvPr id="87" name="Rounded Rectangle 86"/>
           <p:cNvSpPr/>
           <p:nvPr/>
         </p:nvSpPr>
@@ -14991,7 +15429,7 @@
       </p:sp>
       <p:pic>
         <p:nvPicPr>
-          <p:cNvPr id="86" name="Picture 85" descr="phone-landing-f1f5fb.jpg"/>
+          <p:cNvPr id="88" name="Picture 87" descr="phone-landing-f1f5fb.jpg"/>
           <p:cNvPicPr>
             <a:picLocks noChangeAspect="1"/>
           </p:cNvPicPr>
@@ -15015,7 +15453,7 @@
       </p:pic>
       <p:pic>
         <p:nvPicPr>
-          <p:cNvPr id="87" name="Picture 86" descr="phone-scam-f1f5fb.jpg"/>
+          <p:cNvPr id="89" name="Picture 88" descr="phone-scam-f1f5fb.jpg"/>
           <p:cNvPicPr>
             <a:picLocks noChangeAspect="1"/>
           </p:cNvPicPr>
@@ -15039,14 +15477,14 @@
       </p:pic>
       <p:sp>
         <p:nvSpPr>
-          <p:cNvPr id="88" name="TextBox 87"/>
+          <p:cNvPr id="90" name="TextBox 89"/>
           <p:cNvSpPr txBox="1"/>
           <p:nvPr/>
         </p:nvSpPr>
         <p:spPr>
           <a:xfrm>
             <a:off x="5623560" y="4590288"/>
-            <a:ext cx="3154680" cy="329184"/>
+            <a:ext cx="3154680" cy="274320"/>
           </a:xfrm>
           <a:prstGeom prst="rect">
             <a:avLst/>
@@ -15054,7 +15492,7 @@
           <a:noFill/>
         </p:spPr>
         <p:txBody>
-          <a:bodyPr wrap="square" anchor="t" lIns="0" rIns="0" tIns="0" bIns="0">
+          <a:bodyPr wrap="square" anchor="ctr" lIns="0" rIns="0" tIns="0" bIns="0">
             <a:spAutoFit/>
           </a:bodyPr>
           <a:lstStyle/>
@@ -15071,13 +15509,13 @@
               </a:spcAft>
             </a:pPr>
             <a:r>
-              <a:rPr sz="1100" i="0">
-                <a:solidFill>
-                  <a:srgbClr val="5B6778"/>
+              <a:rPr sz="1150" i="0">
+                <a:solidFill>
+                  <a:srgbClr val="3F4B5B"/>
                 </a:solidFill>
                 <a:latin typeface="Avenir Next"/>
               </a:rPr>
-              <a:t>The live app. Links are opened in an isolated browser, never on your phone.</a:t>
+              <a:t>The live app, as seen on a phone.</a:t>
             </a:r>
           </a:p>
         </p:txBody>
@@ -15269,11 +15707,11 @@
         <p:spPr>
           <a:xfrm>
             <a:off x="365760" y="1207008"/>
-            <a:ext cx="8412480" cy="566928"/>
+            <a:ext cx="8412480" cy="530352"/>
           </a:xfrm>
           <a:prstGeom prst="roundRect">
             <a:avLst>
-              <a:gd name="adj" fmla="val 11290"/>
+              <a:gd name="adj" fmla="val 12068"/>
             </a:avLst>
           </a:prstGeom>
           <a:solidFill>
@@ -15315,7 +15753,7 @@
         <p:spPr>
           <a:xfrm>
             <a:off x="566928" y="1207008"/>
-            <a:ext cx="2514600" cy="566928"/>
+            <a:ext cx="2514600" cy="530352"/>
           </a:xfrm>
           <a:prstGeom prst="rect">
             <a:avLst/>
@@ -15360,7 +15798,7 @@
         <p:spPr>
           <a:xfrm>
             <a:off x="3154679" y="1207008"/>
-            <a:ext cx="5440679" cy="566928"/>
+            <a:ext cx="5440679" cy="530352"/>
           </a:xfrm>
           <a:prstGeom prst="rect">
             <a:avLst/>
@@ -15404,12 +15842,12 @@
         </p:nvSpPr>
         <p:spPr>
           <a:xfrm>
-            <a:off x="365760" y="1938528"/>
-            <a:ext cx="4892040" cy="2980944"/>
+            <a:off x="365760" y="1828800"/>
+            <a:ext cx="4892040" cy="3090672"/>
           </a:xfrm>
           <a:prstGeom prst="roundRect">
             <a:avLst>
-              <a:gd name="adj" fmla="val 2147"/>
+              <a:gd name="adj" fmla="val 2071"/>
             </a:avLst>
           </a:prstGeom>
           <a:solidFill>
@@ -15452,7 +15890,7 @@
         </p:nvSpPr>
         <p:spPr>
           <a:xfrm>
-            <a:off x="548640" y="2066544"/>
+            <a:off x="548640" y="1956816"/>
             <a:ext cx="4526279" cy="237744"/>
           </a:xfrm>
           <a:prstGeom prst="rect">
@@ -15497,7 +15935,7 @@
         </p:nvSpPr>
         <p:spPr>
           <a:xfrm>
-            <a:off x="548640" y="2395728"/>
+            <a:off x="548640" y="2286000"/>
             <a:ext cx="4526279" cy="585216"/>
           </a:xfrm>
           <a:prstGeom prst="rect">
@@ -15551,7 +15989,7 @@
         </p:nvCxnSpPr>
         <p:spPr>
           <a:xfrm>
-            <a:off x="548640" y="3017520"/>
+            <a:off x="548640" y="2907792"/>
             <a:ext cx="4526280" cy="0"/>
           </a:xfrm>
           <a:prstGeom prst="line">
@@ -15586,7 +16024,7 @@
         </p:nvSpPr>
         <p:spPr>
           <a:xfrm>
-            <a:off x="548640" y="3090672"/>
+            <a:off x="548640" y="2980944"/>
             <a:ext cx="4526279" cy="402336"/>
           </a:xfrm>
           <a:prstGeom prst="rect">
@@ -15640,7 +16078,7 @@
         </p:nvCxnSpPr>
         <p:spPr>
           <a:xfrm>
-            <a:off x="548640" y="3529584"/>
+            <a:off x="548640" y="3419856"/>
             <a:ext cx="4526280" cy="0"/>
           </a:xfrm>
           <a:prstGeom prst="line">
@@ -15675,7 +16113,7 @@
         </p:nvSpPr>
         <p:spPr>
           <a:xfrm>
-            <a:off x="548640" y="3602736"/>
+            <a:off x="548640" y="3493008"/>
             <a:ext cx="4526279" cy="402336"/>
           </a:xfrm>
           <a:prstGeom prst="rect">
@@ -15729,7 +16167,7 @@
         </p:nvCxnSpPr>
         <p:spPr>
           <a:xfrm>
-            <a:off x="548640" y="4041648"/>
+            <a:off x="548640" y="3931920"/>
             <a:ext cx="4526280" cy="0"/>
           </a:xfrm>
           <a:prstGeom prst="line">
@@ -15764,12 +16202,12 @@
         </p:nvSpPr>
         <p:spPr>
           <a:xfrm>
-            <a:off x="493776" y="4133087"/>
-            <a:ext cx="4636007" cy="658368"/>
+            <a:off x="493776" y="4023360"/>
+            <a:ext cx="4636007" cy="768095"/>
           </a:xfrm>
           <a:prstGeom prst="roundRect">
             <a:avLst>
-              <a:gd name="adj" fmla="val 8333"/>
+              <a:gd name="adj" fmla="val 7142"/>
             </a:avLst>
           </a:prstGeom>
           <a:solidFill>
@@ -15810,8 +16248,8 @@
         </p:nvSpPr>
         <p:spPr>
           <a:xfrm>
-            <a:off x="621792" y="4133087"/>
-            <a:ext cx="4379975" cy="658368"/>
+            <a:off x="621792" y="4023360"/>
+            <a:ext cx="4379975" cy="768095"/>
           </a:xfrm>
           <a:prstGeom prst="rect">
             <a:avLst/>
@@ -15864,12 +16302,12 @@
         </p:nvSpPr>
         <p:spPr>
           <a:xfrm>
-            <a:off x="5440680" y="1938528"/>
-            <a:ext cx="3337559" cy="1481328"/>
+            <a:off x="5440680" y="1828800"/>
+            <a:ext cx="3337559" cy="1316736"/>
           </a:xfrm>
           <a:prstGeom prst="roundRect">
             <a:avLst>
-              <a:gd name="adj" fmla="val 4320"/>
+              <a:gd name="adj" fmla="val 4861"/>
             </a:avLst>
           </a:prstGeom>
           <a:solidFill>
@@ -15912,7 +16350,7 @@
         </p:nvSpPr>
         <p:spPr>
           <a:xfrm>
-            <a:off x="5623560" y="2066544"/>
+            <a:off x="5623560" y="1956816"/>
             <a:ext cx="2971799" cy="237744"/>
           </a:xfrm>
           <a:prstGeom prst="rect">
@@ -15957,8 +16395,8 @@
         </p:nvSpPr>
         <p:spPr>
           <a:xfrm>
-            <a:off x="5623560" y="2377440"/>
-            <a:ext cx="2971799" cy="978408"/>
+            <a:off x="5623560" y="2267712"/>
+            <a:ext cx="2971799" cy="813815"/>
           </a:xfrm>
           <a:prstGeom prst="rect">
             <a:avLst/>
@@ -16061,12 +16499,12 @@
         </p:nvSpPr>
         <p:spPr>
           <a:xfrm>
-            <a:off x="5440680" y="3529584"/>
-            <a:ext cx="3337559" cy="1389887"/>
+            <a:off x="5440680" y="3255264"/>
+            <a:ext cx="3337559" cy="1664207"/>
           </a:xfrm>
           <a:prstGeom prst="roundRect">
             <a:avLst>
-              <a:gd name="adj" fmla="val 4605"/>
+              <a:gd name="adj" fmla="val 3846"/>
             </a:avLst>
           </a:prstGeom>
           <a:solidFill>
@@ -16109,7 +16547,7 @@
         </p:nvSpPr>
         <p:spPr>
           <a:xfrm>
-            <a:off x="5623560" y="3657600"/>
+            <a:off x="5623560" y="3383280"/>
             <a:ext cx="2971799" cy="237744"/>
           </a:xfrm>
           <a:prstGeom prst="rect">
@@ -16154,8 +16592,8 @@
         </p:nvSpPr>
         <p:spPr>
           <a:xfrm>
-            <a:off x="5623560" y="3968496"/>
-            <a:ext cx="2971799" cy="886967"/>
+            <a:off x="5623560" y="3694176"/>
+            <a:ext cx="2971799" cy="1161287"/>
           </a:xfrm>
           <a:prstGeom prst="rect">
             <a:avLst/>
@@ -16218,7 +16656,7 @@
                 </a:solidFill>
                 <a:latin typeface="Avenir Next"/>
               </a:rPr>
-              <a:t>UPI-aware: a QR that asks you to pay while the text says receive</a:t>
+              <a:t>Made for India: fake payment receipts, "digital arrest" calls, UPI QR tricks</a:t>
             </a:r>
           </a:p>
           <a:p>
@@ -18195,11 +18633,11 @@
         <p:spPr>
           <a:xfrm>
             <a:off x="365760" y="1207008"/>
-            <a:ext cx="1965960" cy="1298448"/>
+            <a:ext cx="1965960" cy="1280160"/>
           </a:xfrm>
           <a:prstGeom prst="roundRect">
             <a:avLst>
-              <a:gd name="adj" fmla="val 4929"/>
+              <a:gd name="adj" fmla="val 5000"/>
             </a:avLst>
           </a:prstGeom>
           <a:solidFill>
@@ -18333,8 +18771,8 @@
         </p:nvSpPr>
         <p:spPr>
           <a:xfrm>
-            <a:off x="502920" y="1664208"/>
-            <a:ext cx="1709928" cy="795527"/>
+            <a:off x="502920" y="1636776"/>
+            <a:ext cx="1709928" cy="804671"/>
           </a:xfrm>
           <a:prstGeom prst="rect">
             <a:avLst/>
@@ -18400,7 +18838,7 @@
         </p:nvCxnSpPr>
         <p:spPr>
           <a:xfrm>
-            <a:off x="2359151" y="1856232"/>
+            <a:off x="2359151" y="1847088"/>
             <a:ext cx="128017" cy="0"/>
           </a:xfrm>
           <a:prstGeom prst="line">
@@ -18437,11 +18875,11 @@
         <p:spPr>
           <a:xfrm>
             <a:off x="2514600" y="1207008"/>
-            <a:ext cx="1965960" cy="1298448"/>
+            <a:ext cx="1965960" cy="1280160"/>
           </a:xfrm>
           <a:prstGeom prst="roundRect">
             <a:avLst>
-              <a:gd name="adj" fmla="val 4929"/>
+              <a:gd name="adj" fmla="val 5000"/>
             </a:avLst>
           </a:prstGeom>
           <a:solidFill>
@@ -18575,8 +19013,8 @@
         </p:nvSpPr>
         <p:spPr>
           <a:xfrm>
-            <a:off x="2651760" y="1664208"/>
-            <a:ext cx="1709928" cy="795527"/>
+            <a:off x="2651760" y="1636776"/>
+            <a:ext cx="1709928" cy="804671"/>
           </a:xfrm>
           <a:prstGeom prst="rect">
             <a:avLst/>
@@ -18642,7 +19080,7 @@
         </p:nvCxnSpPr>
         <p:spPr>
           <a:xfrm>
-            <a:off x="4507992" y="1856232"/>
+            <a:off x="4507992" y="1847088"/>
             <a:ext cx="128016" cy="0"/>
           </a:xfrm>
           <a:prstGeom prst="line">
@@ -18679,11 +19117,11 @@
         <p:spPr>
           <a:xfrm>
             <a:off x="4663440" y="1207008"/>
-            <a:ext cx="1965960" cy="1298448"/>
+            <a:ext cx="1965960" cy="1280160"/>
           </a:xfrm>
           <a:prstGeom prst="roundRect">
             <a:avLst>
-              <a:gd name="adj" fmla="val 4929"/>
+              <a:gd name="adj" fmla="val 5000"/>
             </a:avLst>
           </a:prstGeom>
           <a:solidFill>
@@ -18817,8 +19255,8 @@
         </p:nvSpPr>
         <p:spPr>
           <a:xfrm>
-            <a:off x="4800600" y="1664208"/>
-            <a:ext cx="1709928" cy="795527"/>
+            <a:off x="4800600" y="1636776"/>
+            <a:ext cx="1709928" cy="804671"/>
           </a:xfrm>
           <a:prstGeom prst="rect">
             <a:avLst/>
@@ -18884,7 +19322,7 @@
         </p:nvCxnSpPr>
         <p:spPr>
           <a:xfrm>
-            <a:off x="6656832" y="1856232"/>
+            <a:off x="6656832" y="1847088"/>
             <a:ext cx="128016" cy="0"/>
           </a:xfrm>
           <a:prstGeom prst="line">
@@ -18921,11 +19359,11 @@
         <p:spPr>
           <a:xfrm>
             <a:off x="6812280" y="1207008"/>
-            <a:ext cx="1965960" cy="1298448"/>
+            <a:ext cx="1965960" cy="1280160"/>
           </a:xfrm>
           <a:prstGeom prst="roundRect">
             <a:avLst>
-              <a:gd name="adj" fmla="val 4929"/>
+              <a:gd name="adj" fmla="val 5000"/>
             </a:avLst>
           </a:prstGeom>
           <a:solidFill>
@@ -19059,8 +19497,8 @@
         </p:nvSpPr>
         <p:spPr>
           <a:xfrm>
-            <a:off x="6949440" y="1664208"/>
-            <a:ext cx="1709928" cy="795527"/>
+            <a:off x="6949440" y="1636776"/>
+            <a:ext cx="1709928" cy="804671"/>
           </a:xfrm>
           <a:prstGeom prst="rect">
             <a:avLst/>
@@ -19126,12 +19564,12 @@
         </p:nvSpPr>
         <p:spPr>
           <a:xfrm>
-            <a:off x="365760" y="2779776"/>
-            <a:ext cx="1965960" cy="1298448"/>
+            <a:off x="365760" y="2688336"/>
+            <a:ext cx="1965960" cy="1280160"/>
           </a:xfrm>
           <a:prstGeom prst="roundRect">
             <a:avLst>
-              <a:gd name="adj" fmla="val 4929"/>
+              <a:gd name="adj" fmla="val 5000"/>
             </a:avLst>
           </a:prstGeom>
           <a:solidFill>
@@ -19174,7 +19612,7 @@
         </p:nvSpPr>
         <p:spPr>
           <a:xfrm>
-            <a:off x="502920" y="2907792"/>
+            <a:off x="502920" y="2816352"/>
             <a:ext cx="256032" cy="256032"/>
           </a:xfrm>
           <a:prstGeom prst="roundRect">
@@ -19220,7 +19658,7 @@
         </p:nvSpPr>
         <p:spPr>
           <a:xfrm>
-            <a:off x="502920" y="2907792"/>
+            <a:off x="502920" y="2816352"/>
             <a:ext cx="256032" cy="256032"/>
           </a:xfrm>
           <a:prstGeom prst="rect">
@@ -19265,8 +19703,8 @@
         </p:nvSpPr>
         <p:spPr>
           <a:xfrm>
-            <a:off x="502920" y="3236976"/>
-            <a:ext cx="1709928" cy="795527"/>
+            <a:off x="502920" y="3118104"/>
+            <a:ext cx="1709928" cy="804671"/>
           </a:xfrm>
           <a:prstGeom prst="rect">
             <a:avLst/>
@@ -19332,7 +19770,7 @@
         </p:nvCxnSpPr>
         <p:spPr>
           <a:xfrm>
-            <a:off x="2359151" y="3429000"/>
+            <a:off x="2359151" y="3328415"/>
             <a:ext cx="128017" cy="0"/>
           </a:xfrm>
           <a:prstGeom prst="line">
@@ -19368,12 +19806,12 @@
         </p:nvSpPr>
         <p:spPr>
           <a:xfrm>
-            <a:off x="2514600" y="2779776"/>
-            <a:ext cx="1965960" cy="1298448"/>
+            <a:off x="2514600" y="2688336"/>
+            <a:ext cx="1965960" cy="1280160"/>
           </a:xfrm>
           <a:prstGeom prst="roundRect">
             <a:avLst>
-              <a:gd name="adj" fmla="val 4929"/>
+              <a:gd name="adj" fmla="val 5000"/>
             </a:avLst>
           </a:prstGeom>
           <a:solidFill>
@@ -19414,7 +19852,7 @@
         </p:nvSpPr>
         <p:spPr>
           <a:xfrm>
-            <a:off x="2651760" y="2907792"/>
+            <a:off x="2651760" y="2816352"/>
             <a:ext cx="256032" cy="256032"/>
           </a:xfrm>
           <a:prstGeom prst="roundRect">
@@ -19460,7 +19898,7 @@
         </p:nvSpPr>
         <p:spPr>
           <a:xfrm>
-            <a:off x="2651760" y="2907792"/>
+            <a:off x="2651760" y="2816352"/>
             <a:ext cx="256032" cy="256032"/>
           </a:xfrm>
           <a:prstGeom prst="rect">
@@ -19505,7 +19943,7 @@
         </p:nvSpPr>
         <p:spPr>
           <a:xfrm>
-            <a:off x="3767328" y="2916936"/>
+            <a:off x="3767328" y="2825496"/>
             <a:ext cx="576072" cy="237744"/>
           </a:xfrm>
           <a:prstGeom prst="roundRect">
@@ -19551,7 +19989,7 @@
         </p:nvSpPr>
         <p:spPr>
           <a:xfrm>
-            <a:off x="3767328" y="2916936"/>
+            <a:off x="3767328" y="2825496"/>
             <a:ext cx="576072" cy="237744"/>
           </a:xfrm>
           <a:prstGeom prst="rect">
@@ -19596,8 +20034,8 @@
         </p:nvSpPr>
         <p:spPr>
           <a:xfrm>
-            <a:off x="2651760" y="3236976"/>
-            <a:ext cx="1709928" cy="795527"/>
+            <a:off x="2651760" y="3118104"/>
+            <a:ext cx="1709928" cy="804671"/>
           </a:xfrm>
           <a:prstGeom prst="rect">
             <a:avLst/>
@@ -19663,7 +20101,7 @@
         </p:nvCxnSpPr>
         <p:spPr>
           <a:xfrm>
-            <a:off x="4507992" y="3429000"/>
+            <a:off x="4507992" y="3328415"/>
             <a:ext cx="128016" cy="0"/>
           </a:xfrm>
           <a:prstGeom prst="line">
@@ -19699,12 +20137,12 @@
         </p:nvSpPr>
         <p:spPr>
           <a:xfrm>
-            <a:off x="4663440" y="2779776"/>
-            <a:ext cx="1965960" cy="1298448"/>
+            <a:off x="4663440" y="2688336"/>
+            <a:ext cx="1965960" cy="1280160"/>
           </a:xfrm>
           <a:prstGeom prst="roundRect">
             <a:avLst>
-              <a:gd name="adj" fmla="val 4929"/>
+              <a:gd name="adj" fmla="val 5000"/>
             </a:avLst>
           </a:prstGeom>
           <a:solidFill>
@@ -19747,7 +20185,7 @@
         </p:nvSpPr>
         <p:spPr>
           <a:xfrm>
-            <a:off x="4800600" y="2907792"/>
+            <a:off x="4800600" y="2816352"/>
             <a:ext cx="256032" cy="256032"/>
           </a:xfrm>
           <a:prstGeom prst="roundRect">
@@ -19793,7 +20231,7 @@
         </p:nvSpPr>
         <p:spPr>
           <a:xfrm>
-            <a:off x="4800600" y="2907792"/>
+            <a:off x="4800600" y="2816352"/>
             <a:ext cx="256032" cy="256032"/>
           </a:xfrm>
           <a:prstGeom prst="rect">
@@ -19838,8 +20276,8 @@
         </p:nvSpPr>
         <p:spPr>
           <a:xfrm>
-            <a:off x="4800600" y="3236976"/>
-            <a:ext cx="1709928" cy="795527"/>
+            <a:off x="4800600" y="3118104"/>
+            <a:ext cx="1709928" cy="804671"/>
           </a:xfrm>
           <a:prstGeom prst="rect">
             <a:avLst/>
@@ -19905,7 +20343,7 @@
         </p:nvCxnSpPr>
         <p:spPr>
           <a:xfrm>
-            <a:off x="6656832" y="3429000"/>
+            <a:off x="6656832" y="3328415"/>
             <a:ext cx="128016" cy="0"/>
           </a:xfrm>
           <a:prstGeom prst="line">
@@ -19941,12 +20379,12 @@
         </p:nvSpPr>
         <p:spPr>
           <a:xfrm>
-            <a:off x="6812280" y="2779776"/>
-            <a:ext cx="1965960" cy="1298448"/>
+            <a:off x="6812280" y="2688336"/>
+            <a:ext cx="1965960" cy="1280160"/>
           </a:xfrm>
           <a:prstGeom prst="roundRect">
             <a:avLst>
-              <a:gd name="adj" fmla="val 4929"/>
+              <a:gd name="adj" fmla="val 5000"/>
             </a:avLst>
           </a:prstGeom>
           <a:solidFill>
@@ -19989,7 +20427,7 @@
         </p:nvSpPr>
         <p:spPr>
           <a:xfrm>
-            <a:off x="6949440" y="2907792"/>
+            <a:off x="6949440" y="2816352"/>
             <a:ext cx="256032" cy="256032"/>
           </a:xfrm>
           <a:prstGeom prst="roundRect">
@@ -20035,7 +20473,7 @@
         </p:nvSpPr>
         <p:spPr>
           <a:xfrm>
-            <a:off x="6949440" y="2907792"/>
+            <a:off x="6949440" y="2816352"/>
             <a:ext cx="256032" cy="256032"/>
           </a:xfrm>
           <a:prstGeom prst="rect">
@@ -20080,8 +20518,8 @@
         </p:nvSpPr>
         <p:spPr>
           <a:xfrm>
-            <a:off x="6949440" y="3236976"/>
-            <a:ext cx="1709928" cy="795527"/>
+            <a:off x="6949440" y="3118104"/>
+            <a:ext cx="1709928" cy="804671"/>
           </a:xfrm>
           <a:prstGeom prst="rect">
             <a:avLst/>
@@ -20147,8 +20585,8 @@
         </p:nvCxnSpPr>
         <p:spPr>
           <a:xfrm>
-            <a:off x="7795260" y="2505456"/>
-            <a:ext cx="0" cy="137160"/>
+            <a:off x="7795260" y="2487168"/>
+            <a:ext cx="0" cy="100583"/>
           </a:xfrm>
           <a:prstGeom prst="line">
             <a:avLst/>
@@ -20182,7 +20620,7 @@
         </p:nvCxnSpPr>
         <p:spPr>
           <a:xfrm flipH="1">
-            <a:off x="1348740" y="2642616"/>
+            <a:off x="1348740" y="2587751"/>
             <a:ext cx="6446520" cy="0"/>
           </a:xfrm>
           <a:prstGeom prst="line">
@@ -20217,8 +20655,8 @@
         </p:nvCxnSpPr>
         <p:spPr>
           <a:xfrm>
-            <a:off x="1348740" y="2642616"/>
-            <a:ext cx="0" cy="137160"/>
+            <a:off x="1348740" y="2587751"/>
+            <a:ext cx="0" cy="100585"/>
           </a:xfrm>
           <a:prstGeom prst="line">
             <a:avLst/>
@@ -20253,12 +20691,12 @@
         </p:nvSpPr>
         <p:spPr>
           <a:xfrm>
-            <a:off x="365760" y="4206240"/>
-            <a:ext cx="8412480" cy="713232"/>
+            <a:off x="365760" y="4078224"/>
+            <a:ext cx="8412480" cy="841247"/>
           </a:xfrm>
           <a:prstGeom prst="roundRect">
             <a:avLst>
-              <a:gd name="adj" fmla="val 8974"/>
+              <a:gd name="adj" fmla="val 7608"/>
             </a:avLst>
           </a:prstGeom>
           <a:solidFill>
@@ -20307,7 +20745,7 @@
         </p:blipFill>
         <p:spPr>
           <a:xfrm>
-            <a:off x="548640" y="4407408"/>
+            <a:off x="548640" y="4343400"/>
             <a:ext cx="310896" cy="310896"/>
           </a:xfrm>
           <a:prstGeom prst="rect">
@@ -20323,8 +20761,8 @@
         </p:nvSpPr>
         <p:spPr>
           <a:xfrm>
-            <a:off x="1005840" y="4206240"/>
-            <a:ext cx="7589519" cy="713232"/>
+            <a:off x="1005840" y="4078224"/>
+            <a:ext cx="7589519" cy="841247"/>
           </a:xfrm>
           <a:prstGeom prst="rect">
             <a:avLst/>
@@ -20345,7 +20783,7 @@
                 <a:spcPts val="0"/>
               </a:spcBef>
               <a:spcAft>
-                <a:spcPts val="0"/>
+                <a:spcPts val="300"/>
               </a:spcAft>
             </a:pPr>
             <a:r>
@@ -20365,6 +20803,28 @@
                 <a:latin typeface="Avenir Next"/>
               </a:rPr>
               <a:t>rules cannot read a screenshot or a Hinglish voice note, or judge a scam nobody has reported. Gemini does. The hard checks can only raise its verdict, never lower it.</a:t>
+            </a:r>
+          </a:p>
+          <a:p>
+            <a:pPr algn="l">
+              <a:lnSpc>
+                <a:spcPct val="100000"/>
+              </a:lnSpc>
+              <a:spcBef>
+                <a:spcPts val="0"/>
+              </a:spcBef>
+              <a:spcAft>
+                <a:spcPts val="0"/>
+              </a:spcAft>
+            </a:pPr>
+            <a:r>
+              <a:rPr sz="1150" i="0">
+                <a:solidFill>
+                  <a:srgbClr val="0B1F33"/>
+                </a:solidFill>
+                <a:latin typeface="Avenir Next"/>
+              </a:rPr>
+              <a:t>If Gemini fails or times out, the person sees a clear retry message; no verdict is invented and nothing is stored.</a:t>
             </a:r>
           </a:p>
         </p:txBody>
@@ -20701,7 +21161,7 @@
             <a:r>
               <a:rPr sz="1100" i="0">
                 <a:solidFill>
-                  <a:srgbClr val="5B6778"/>
+                  <a:srgbClr val="3F4B5B"/>
                 </a:solidFill>
                 <a:latin typeface="Avenir Next"/>
               </a:rPr>
@@ -20768,7 +21228,7 @@
             <a:r>
               <a:rPr sz="1100" i="0">
                 <a:solidFill>
-                  <a:srgbClr val="5B6778"/>
+                  <a:srgbClr val="3F4B5B"/>
                 </a:solidFill>
                 <a:latin typeface="Avenir Next"/>
               </a:rPr>
@@ -20835,7 +21295,7 @@
             <a:r>
               <a:rPr sz="1100" i="0">
                 <a:solidFill>
-                  <a:srgbClr val="5B6778"/>
+                  <a:srgbClr val="3F4B5B"/>
                 </a:solidFill>
                 <a:latin typeface="Avenir Next"/>
               </a:rPr>
@@ -20902,7 +21362,7 @@
             <a:r>
               <a:rPr sz="1100" i="0">
                 <a:solidFill>
-                  <a:srgbClr val="5B6778"/>
+                  <a:srgbClr val="3F4B5B"/>
                 </a:solidFill>
                 <a:latin typeface="Avenir Next"/>
               </a:rPr>
@@ -21098,7 +21558,7 @@
         <p:spPr>
           <a:xfrm>
             <a:off x="365760" y="1234440"/>
-            <a:ext cx="1645920" cy="2377440"/>
+            <a:ext cx="1645920" cy="1920240"/>
           </a:xfrm>
           <a:prstGeom prst="roundRect">
             <a:avLst>
@@ -21170,7 +21630,7 @@
         <p:spPr>
           <a:xfrm>
             <a:off x="493776" y="1709928"/>
-            <a:ext cx="1426464" cy="1865376"/>
+            <a:ext cx="1426464" cy="1408176"/>
           </a:xfrm>
           <a:prstGeom prst="rect">
             <a:avLst/>
@@ -21217,9 +21677,9 @@
               </a:spcAft>
             </a:pPr>
             <a:r>
-              <a:rPr sz="1100" i="0">
-                <a:solidFill>
-                  <a:srgbClr val="5B6778"/>
+              <a:rPr sz="1150" i="0">
+                <a:solidFill>
+                  <a:srgbClr val="3F4B5B"/>
                 </a:solidFill>
                 <a:latin typeface="Avenir Next"/>
               </a:rPr>
@@ -21236,12 +21696,12 @@
         </p:nvSpPr>
         <p:spPr>
           <a:xfrm>
-            <a:off x="365760" y="3886200"/>
-            <a:ext cx="1645920" cy="1033271"/>
+            <a:off x="365760" y="3383280"/>
+            <a:ext cx="1645920" cy="1316735"/>
           </a:xfrm>
           <a:prstGeom prst="roundRect">
             <a:avLst>
-              <a:gd name="adj" fmla="val 6194"/>
+              <a:gd name="adj" fmla="val 4861"/>
             </a:avLst>
           </a:prstGeom>
           <a:solidFill>
@@ -21292,7 +21752,7 @@
         </p:blipFill>
         <p:spPr>
           <a:xfrm>
-            <a:off x="493776" y="4005072"/>
+            <a:off x="493776" y="3502152"/>
             <a:ext cx="218084" cy="274320"/>
           </a:xfrm>
           <a:prstGeom prst="rect">
@@ -21308,8 +21768,8 @@
         </p:nvSpPr>
         <p:spPr>
           <a:xfrm>
-            <a:off x="493776" y="4361688"/>
-            <a:ext cx="1426464" cy="521208"/>
+            <a:off x="493776" y="3858768"/>
+            <a:ext cx="1426464" cy="804671"/>
           </a:xfrm>
           <a:prstGeom prst="rect">
             <a:avLst/>
@@ -21356,9 +21816,9 @@
               </a:spcAft>
             </a:pPr>
             <a:r>
-              <a:rPr sz="1100" i="0">
-                <a:solidFill>
-                  <a:srgbClr val="5B6778"/>
+              <a:rPr sz="1150" i="0">
+                <a:solidFill>
+                  <a:srgbClr val="3F4B5B"/>
                 </a:solidFill>
                 <a:latin typeface="Avenir Next"/>
               </a:rPr>
@@ -21376,11 +21836,11 @@
         <p:spPr>
           <a:xfrm>
             <a:off x="2377440" y="1234440"/>
-            <a:ext cx="2286000" cy="914400"/>
+            <a:ext cx="2286000" cy="868680"/>
           </a:xfrm>
           <a:prstGeom prst="roundRect">
             <a:avLst>
-              <a:gd name="adj" fmla="val 7000"/>
+              <a:gd name="adj" fmla="val 7368"/>
             </a:avLst>
           </a:prstGeom>
           <a:solidFill>
@@ -21448,7 +21908,7 @@
         <p:spPr>
           <a:xfrm>
             <a:off x="2851556" y="1353312"/>
-            <a:ext cx="1720443" cy="758952"/>
+            <a:ext cx="1720443" cy="713231"/>
           </a:xfrm>
           <a:prstGeom prst="rect">
             <a:avLst/>
@@ -21497,7 +21957,7 @@
             <a:r>
               <a:rPr sz="1100" i="0">
                 <a:solidFill>
-                  <a:srgbClr val="5B6778"/>
+                  <a:srgbClr val="3F4B5B"/>
                 </a:solidFill>
                 <a:latin typeface="Avenir Next"/>
               </a:rPr>
@@ -21514,7 +21974,7 @@
         </p:nvSpPr>
         <p:spPr>
           <a:xfrm>
-            <a:off x="2377440" y="2468880"/>
+            <a:off x="2377440" y="2331720"/>
             <a:ext cx="2286000" cy="1280160"/>
           </a:xfrm>
           <a:prstGeom prst="roundRect">
@@ -21568,7 +22028,7 @@
         </p:blipFill>
         <p:spPr>
           <a:xfrm>
-            <a:off x="2505456" y="2596896"/>
+            <a:off x="2505456" y="2459736"/>
             <a:ext cx="303955" cy="274320"/>
           </a:xfrm>
           <a:prstGeom prst="rect">
@@ -21584,8 +22044,8 @@
         </p:nvSpPr>
         <p:spPr>
           <a:xfrm>
-            <a:off x="2937427" y="2587752"/>
-            <a:ext cx="1634572" cy="1124711"/>
+            <a:off x="2937427" y="2450591"/>
+            <a:ext cx="1634572" cy="1124712"/>
           </a:xfrm>
           <a:prstGeom prst="rect">
             <a:avLst/>
@@ -21651,12 +22111,12 @@
         </p:nvSpPr>
         <p:spPr>
           <a:xfrm>
-            <a:off x="2377440" y="3886200"/>
-            <a:ext cx="2286000" cy="1033271"/>
+            <a:off x="2377440" y="3794760"/>
+            <a:ext cx="2286000" cy="905255"/>
           </a:xfrm>
           <a:prstGeom prst="roundRect">
             <a:avLst>
-              <a:gd name="adj" fmla="val 6194"/>
+              <a:gd name="adj" fmla="val 7070"/>
             </a:avLst>
           </a:prstGeom>
           <a:solidFill>
@@ -21697,8 +22157,8 @@
         </p:nvSpPr>
         <p:spPr>
           <a:xfrm>
-            <a:off x="2505456" y="3995928"/>
-            <a:ext cx="2066543" cy="886967"/>
+            <a:off x="2505456" y="3904488"/>
+            <a:ext cx="2066543" cy="758951"/>
           </a:xfrm>
           <a:prstGeom prst="rect">
             <a:avLst/>
@@ -21747,7 +22207,7 @@
             <a:r>
               <a:rPr sz="1100" i="0">
                 <a:solidFill>
-                  <a:srgbClr val="5B6778"/>
+                  <a:srgbClr val="3F4B5B"/>
                 </a:solidFill>
                 <a:latin typeface="Avenir Next"/>
               </a:rPr>
@@ -21765,11 +22225,11 @@
         <p:spPr>
           <a:xfrm>
             <a:off x="5120640" y="1234440"/>
-            <a:ext cx="3657600" cy="914400"/>
+            <a:ext cx="3657600" cy="822960"/>
           </a:xfrm>
           <a:prstGeom prst="roundRect">
             <a:avLst>
-              <a:gd name="adj" fmla="val 7000"/>
+              <a:gd name="adj" fmla="val 7777"/>
             </a:avLst>
           </a:prstGeom>
           <a:solidFill>
@@ -21861,7 +22321,7 @@
         <p:spPr>
           <a:xfrm>
             <a:off x="5980176" y="1353312"/>
-            <a:ext cx="2706623" cy="758952"/>
+            <a:ext cx="2706623" cy="667512"/>
           </a:xfrm>
           <a:prstGeom prst="rect">
             <a:avLst/>
@@ -21910,7 +22370,7 @@
             <a:r>
               <a:rPr sz="1100" i="0">
                 <a:solidFill>
-                  <a:srgbClr val="5B6778"/>
+                  <a:srgbClr val="3F4B5B"/>
                 </a:solidFill>
                 <a:latin typeface="Avenir Next"/>
               </a:rPr>
@@ -21927,12 +22387,12 @@
         </p:nvSpPr>
         <p:spPr>
           <a:xfrm>
-            <a:off x="5120640" y="2258568"/>
-            <a:ext cx="3657600" cy="777240"/>
+            <a:off x="5120640" y="2148840"/>
+            <a:ext cx="3657600" cy="713232"/>
           </a:xfrm>
           <a:prstGeom prst="roundRect">
             <a:avLst>
-              <a:gd name="adj" fmla="val 8235"/>
+              <a:gd name="adj" fmla="val 8974"/>
             </a:avLst>
           </a:prstGeom>
           <a:solidFill>
@@ -21983,7 +22443,7 @@
         </p:blipFill>
         <p:spPr>
           <a:xfrm>
-            <a:off x="5248655" y="2386584"/>
+            <a:off x="5248655" y="2276856"/>
             <a:ext cx="246888" cy="274320"/>
           </a:xfrm>
           <a:prstGeom prst="rect">
@@ -21999,8 +22459,8 @@
         </p:nvSpPr>
         <p:spPr>
           <a:xfrm>
-            <a:off x="5623559" y="2377440"/>
-            <a:ext cx="3063240" cy="621792"/>
+            <a:off x="5623559" y="2267712"/>
+            <a:ext cx="3063240" cy="557783"/>
           </a:xfrm>
           <a:prstGeom prst="rect">
             <a:avLst/>
@@ -22049,7 +22509,7 @@
             <a:r>
               <a:rPr sz="1100" i="0">
                 <a:solidFill>
-                  <a:srgbClr val="5B6778"/>
+                  <a:srgbClr val="3F4B5B"/>
                 </a:solidFill>
                 <a:latin typeface="Avenir Next"/>
               </a:rPr>
@@ -22066,12 +22526,12 @@
         </p:nvSpPr>
         <p:spPr>
           <a:xfrm>
-            <a:off x="5120640" y="3145536"/>
-            <a:ext cx="3657600" cy="841248"/>
+            <a:off x="5120640" y="2953512"/>
+            <a:ext cx="3657600" cy="804672"/>
           </a:xfrm>
           <a:prstGeom prst="roundRect">
             <a:avLst>
-              <a:gd name="adj" fmla="val 7608"/>
+              <a:gd name="adj" fmla="val 7954"/>
             </a:avLst>
           </a:prstGeom>
           <a:solidFill>
@@ -22122,7 +22582,7 @@
         </p:blipFill>
         <p:spPr>
           <a:xfrm>
-            <a:off x="5248655" y="3273552"/>
+            <a:off x="5248655" y="3081528"/>
             <a:ext cx="303955" cy="274320"/>
           </a:xfrm>
           <a:prstGeom prst="rect">
@@ -22138,8 +22598,8 @@
         </p:nvSpPr>
         <p:spPr>
           <a:xfrm>
-            <a:off x="5680626" y="3264408"/>
-            <a:ext cx="3006173" cy="685800"/>
+            <a:off x="5680626" y="3072384"/>
+            <a:ext cx="3006173" cy="649224"/>
           </a:xfrm>
           <a:prstGeom prst="rect">
             <a:avLst/>
@@ -22188,7 +22648,7 @@
             <a:r>
               <a:rPr sz="1100" i="0">
                 <a:solidFill>
-                  <a:srgbClr val="5B6778"/>
+                  <a:srgbClr val="3F4B5B"/>
                 </a:solidFill>
                 <a:latin typeface="Avenir Next"/>
               </a:rPr>
@@ -22205,12 +22665,12 @@
         </p:nvSpPr>
         <p:spPr>
           <a:xfrm>
-            <a:off x="5120640" y="4224528"/>
-            <a:ext cx="1783080" cy="694944"/>
+            <a:off x="5120640" y="3986784"/>
+            <a:ext cx="1783080" cy="713231"/>
           </a:xfrm>
           <a:prstGeom prst="roundRect">
             <a:avLst>
-              <a:gd name="adj" fmla="val 9210"/>
+              <a:gd name="adj" fmla="val 8974"/>
             </a:avLst>
           </a:prstGeom>
           <a:solidFill>
@@ -22253,8 +22713,8 @@
         </p:nvSpPr>
         <p:spPr>
           <a:xfrm>
-            <a:off x="5248655" y="4334256"/>
-            <a:ext cx="1563624" cy="548639"/>
+            <a:off x="5248655" y="4096512"/>
+            <a:ext cx="1563624" cy="566927"/>
           </a:xfrm>
           <a:prstGeom prst="rect">
             <a:avLst/>
@@ -22303,7 +22763,7 @@
             <a:r>
               <a:rPr sz="1050" i="0">
                 <a:solidFill>
-                  <a:srgbClr val="5B6778"/>
+                  <a:srgbClr val="3F4B5B"/>
                 </a:solidFill>
                 <a:latin typeface="Avenir Next"/>
               </a:rPr>
@@ -22320,12 +22780,12 @@
         </p:nvSpPr>
         <p:spPr>
           <a:xfrm>
-            <a:off x="6995159" y="4224528"/>
-            <a:ext cx="1783080" cy="694944"/>
+            <a:off x="6995159" y="3986784"/>
+            <a:ext cx="1783080" cy="713231"/>
           </a:xfrm>
           <a:prstGeom prst="roundRect">
             <a:avLst>
-              <a:gd name="adj" fmla="val 9210"/>
+              <a:gd name="adj" fmla="val 8974"/>
             </a:avLst>
           </a:prstGeom>
           <a:solidFill>
@@ -22366,8 +22826,8 @@
         </p:nvSpPr>
         <p:spPr>
           <a:xfrm>
-            <a:off x="7123175" y="4334256"/>
-            <a:ext cx="1563624" cy="548639"/>
+            <a:off x="7123175" y="4096512"/>
+            <a:ext cx="1563624" cy="566927"/>
           </a:xfrm>
           <a:prstGeom prst="rect">
             <a:avLst/>
@@ -22433,7 +22893,7 @@
         </p:nvCxnSpPr>
         <p:spPr>
           <a:xfrm>
-            <a:off x="2011680" y="1691640"/>
+            <a:off x="2011680" y="1664208"/>
             <a:ext cx="365760" cy="0"/>
           </a:xfrm>
           <a:prstGeom prst="line">
@@ -22469,8 +22929,8 @@
         </p:nvCxnSpPr>
         <p:spPr>
           <a:xfrm>
-            <a:off x="3520440" y="2148840"/>
-            <a:ext cx="0" cy="320040"/>
+            <a:off x="3520440" y="2103120"/>
+            <a:ext cx="0" cy="228600"/>
           </a:xfrm>
           <a:prstGeom prst="line">
             <a:avLst/>
@@ -22505,8 +22965,8 @@
         </p:nvCxnSpPr>
         <p:spPr>
           <a:xfrm>
-            <a:off x="1188720" y="3611880"/>
-            <a:ext cx="0" cy="274320"/>
+            <a:off x="1188720" y="3154680"/>
+            <a:ext cx="0" cy="228600"/>
           </a:xfrm>
           <a:prstGeom prst="line">
             <a:avLst/>
@@ -22541,7 +23001,7 @@
         </p:nvCxnSpPr>
         <p:spPr>
           <a:xfrm>
-            <a:off x="4663440" y="2596896"/>
+            <a:off x="4663440" y="2468880"/>
             <a:ext cx="228600" cy="0"/>
           </a:xfrm>
           <a:prstGeom prst="line">
@@ -22576,8 +23036,8 @@
         </p:nvCxnSpPr>
         <p:spPr>
           <a:xfrm flipV="1">
-            <a:off x="4892040" y="1691640"/>
-            <a:ext cx="0" cy="905256"/>
+            <a:off x="4892040" y="1645920"/>
+            <a:ext cx="0" cy="822960"/>
           </a:xfrm>
           <a:prstGeom prst="line">
             <a:avLst/>
@@ -22611,7 +23071,7 @@
         </p:nvCxnSpPr>
         <p:spPr>
           <a:xfrm>
-            <a:off x="4892040" y="1691640"/>
+            <a:off x="4892040" y="1645920"/>
             <a:ext cx="228600" cy="0"/>
           </a:xfrm>
           <a:prstGeom prst="line">
@@ -22683,7 +23143,7 @@
         </p:nvCxnSpPr>
         <p:spPr>
           <a:xfrm>
-            <a:off x="4663440" y="3474720"/>
+            <a:off x="4663440" y="3200400"/>
             <a:ext cx="457200" cy="0"/>
           </a:xfrm>
           <a:prstGeom prst="line">
@@ -22719,7 +23179,7 @@
         </p:nvCxnSpPr>
         <p:spPr>
           <a:xfrm>
-            <a:off x="4663440" y="3639312"/>
+            <a:off x="4663440" y="3456432"/>
             <a:ext cx="228600" cy="0"/>
           </a:xfrm>
           <a:prstGeom prst="line">
@@ -22754,8 +23214,8 @@
         </p:nvCxnSpPr>
         <p:spPr>
           <a:xfrm>
-            <a:off x="4892040" y="3639312"/>
-            <a:ext cx="0" cy="932688"/>
+            <a:off x="4892040" y="3456432"/>
+            <a:ext cx="0" cy="886968"/>
           </a:xfrm>
           <a:prstGeom prst="line">
             <a:avLst/>
@@ -22789,7 +23249,7 @@
         </p:nvCxnSpPr>
         <p:spPr>
           <a:xfrm>
-            <a:off x="4892040" y="4572000"/>
+            <a:off x="4892040" y="4343400"/>
             <a:ext cx="228600" cy="0"/>
           </a:xfrm>
           <a:prstGeom prst="line">
@@ -22825,8 +23285,8 @@
         </p:nvCxnSpPr>
         <p:spPr>
           <a:xfrm>
-            <a:off x="7863840" y="3986784"/>
-            <a:ext cx="0" cy="237744"/>
+            <a:off x="7863840" y="3758184"/>
+            <a:ext cx="0" cy="228600"/>
           </a:xfrm>
           <a:prstGeom prst="line">
             <a:avLst/>
@@ -22861,8 +23321,8 @@
         </p:nvSpPr>
         <p:spPr>
           <a:xfrm>
-            <a:off x="365760" y="4937760"/>
-            <a:ext cx="8412480" cy="128016"/>
+            <a:off x="365760" y="4773168"/>
+            <a:ext cx="8412480" cy="201168"/>
           </a:xfrm>
           <a:prstGeom prst="rect">
             <a:avLst/>
@@ -22887,9 +23347,9 @@
               </a:spcAft>
             </a:pPr>
             <a:r>
-              <a:rPr sz="750" i="0">
-                <a:solidFill>
-                  <a:srgbClr val="5B6778"/>
+              <a:rPr sz="900" i="0">
+                <a:solidFill>
+                  <a:srgbClr val="3F4B5B"/>
                 </a:solidFill>
                 <a:latin typeface="Avenir Next"/>
               </a:rPr>
@@ -23085,11 +23545,11 @@
         <p:spPr>
           <a:xfrm>
             <a:off x="365760" y="1207008"/>
-            <a:ext cx="3931920" cy="3712463"/>
+            <a:ext cx="3931920" cy="3493007"/>
           </a:xfrm>
           <a:prstGeom prst="roundRect">
             <a:avLst>
-              <a:gd name="adj" fmla="val 2216"/>
+              <a:gd name="adj" fmla="val 2356"/>
             </a:avLst>
           </a:prstGeom>
           <a:solidFill>
@@ -23270,7 +23730,7 @@
         <p:spPr>
           <a:xfrm>
             <a:off x="566928" y="2011680"/>
-            <a:ext cx="3529584" cy="2798063"/>
+            <a:ext cx="3529584" cy="2578607"/>
           </a:xfrm>
           <a:prstGeom prst="rect">
             <a:avLst/>
@@ -23509,11 +23969,11 @@
         <p:spPr>
           <a:xfrm>
             <a:off x="4480560" y="1207008"/>
-            <a:ext cx="4297679" cy="2212848"/>
+            <a:ext cx="4297679" cy="1993392"/>
           </a:xfrm>
           <a:prstGeom prst="roundRect">
             <a:avLst>
-              <a:gd name="adj" fmla="val 2892"/>
+              <a:gd name="adj" fmla="val 3211"/>
             </a:avLst>
           </a:prstGeom>
           <a:solidFill>
@@ -23697,8 +24157,8 @@
         </p:nvSpPr>
         <p:spPr>
           <a:xfrm>
-            <a:off x="4663440" y="2075688"/>
-            <a:ext cx="3931919" cy="1298448"/>
+            <a:off x="4663440" y="2029968"/>
+            <a:ext cx="3931919" cy="1124712"/>
           </a:xfrm>
           <a:prstGeom prst="rect">
             <a:avLst/>
@@ -23743,7 +24203,7 @@
                 </a:solidFill>
                 <a:latin typeface="Avenir Next"/>
               </a:rPr>
-              <a:t>stateless, autoscaling, one warm instance</a:t>
+              <a:t>stateless and autoscaling</a:t>
             </a:r>
           </a:p>
           <a:p>
@@ -23846,7 +24306,7 @@
         </p:nvSpPr>
         <p:spPr>
           <a:xfrm>
-            <a:off x="4480560" y="3529584"/>
+            <a:off x="4480560" y="3310128"/>
             <a:ext cx="4297679" cy="1389887"/>
           </a:xfrm>
           <a:prstGeom prst="roundRect">
@@ -23894,7 +24354,7 @@
         </p:nvSpPr>
         <p:spPr>
           <a:xfrm>
-            <a:off x="4663440" y="3657600"/>
+            <a:off x="4663440" y="3438144"/>
             <a:ext cx="3931919" cy="237744"/>
           </a:xfrm>
           <a:prstGeom prst="rect">
@@ -23939,7 +24399,7 @@
         </p:nvSpPr>
         <p:spPr>
           <a:xfrm>
-            <a:off x="4663440" y="3986784"/>
+            <a:off x="4663440" y="3767328"/>
             <a:ext cx="713564" cy="237744"/>
           </a:xfrm>
           <a:prstGeom prst="roundRect">
@@ -23987,7 +24447,7 @@
         </p:nvSpPr>
         <p:spPr>
           <a:xfrm>
-            <a:off x="4663440" y="3986784"/>
+            <a:off x="4663440" y="3767328"/>
             <a:ext cx="713564" cy="237744"/>
           </a:xfrm>
           <a:prstGeom prst="rect">
@@ -24032,7 +24492,7 @@
         </p:nvSpPr>
         <p:spPr>
           <a:xfrm>
-            <a:off x="5441012" y="3986784"/>
+            <a:off x="5441012" y="3767328"/>
             <a:ext cx="448222" cy="237744"/>
           </a:xfrm>
           <a:prstGeom prst="roundRect">
@@ -24080,7 +24540,7 @@
         </p:nvSpPr>
         <p:spPr>
           <a:xfrm>
-            <a:off x="5441012" y="3986784"/>
+            <a:off x="5441012" y="3767328"/>
             <a:ext cx="448222" cy="237744"/>
           </a:xfrm>
           <a:prstGeom prst="rect">
@@ -24125,7 +24585,7 @@
         </p:nvSpPr>
         <p:spPr>
           <a:xfrm>
-            <a:off x="5953242" y="3986784"/>
+            <a:off x="5953242" y="3767328"/>
             <a:ext cx="713564" cy="237744"/>
           </a:xfrm>
           <a:prstGeom prst="roundRect">
@@ -24173,7 +24633,7 @@
         </p:nvSpPr>
         <p:spPr>
           <a:xfrm>
-            <a:off x="5953242" y="3986784"/>
+            <a:off x="5953242" y="3767328"/>
             <a:ext cx="713564" cy="237744"/>
           </a:xfrm>
           <a:prstGeom prst="rect">
@@ -24218,7 +24678,7 @@
         </p:nvSpPr>
         <p:spPr>
           <a:xfrm>
-            <a:off x="6730815" y="3986784"/>
+            <a:off x="6730815" y="3767328"/>
             <a:ext cx="912571" cy="237744"/>
           </a:xfrm>
           <a:prstGeom prst="roundRect">
@@ -24266,7 +24726,7 @@
         </p:nvSpPr>
         <p:spPr>
           <a:xfrm>
-            <a:off x="6730815" y="3986784"/>
+            <a:off x="6730815" y="3767328"/>
             <a:ext cx="912571" cy="237744"/>
           </a:xfrm>
           <a:prstGeom prst="rect">
@@ -24311,7 +24771,7 @@
         </p:nvSpPr>
         <p:spPr>
           <a:xfrm>
-            <a:off x="7707394" y="3986784"/>
+            <a:off x="7707394" y="3767328"/>
             <a:ext cx="647228" cy="237744"/>
           </a:xfrm>
           <a:prstGeom prst="roundRect">
@@ -24359,7 +24819,7 @@
         </p:nvSpPr>
         <p:spPr>
           <a:xfrm>
-            <a:off x="7707394" y="3986784"/>
+            <a:off x="7707394" y="3767328"/>
             <a:ext cx="647228" cy="237744"/>
           </a:xfrm>
           <a:prstGeom prst="rect">
@@ -24404,7 +24864,7 @@
         </p:nvSpPr>
         <p:spPr>
           <a:xfrm>
-            <a:off x="4663440" y="4288536"/>
+            <a:off x="4663440" y="4069080"/>
             <a:ext cx="846235" cy="237744"/>
           </a:xfrm>
           <a:prstGeom prst="roundRect">
@@ -24452,7 +24912,7 @@
         </p:nvSpPr>
         <p:spPr>
           <a:xfrm>
-            <a:off x="4663440" y="4288536"/>
+            <a:off x="4663440" y="4069080"/>
             <a:ext cx="846235" cy="237744"/>
           </a:xfrm>
           <a:prstGeom prst="rect">
@@ -24497,7 +24957,7 @@
         </p:nvSpPr>
         <p:spPr>
           <a:xfrm>
-            <a:off x="5573683" y="4288536"/>
+            <a:off x="5573683" y="4069080"/>
             <a:ext cx="448222" cy="237744"/>
           </a:xfrm>
           <a:prstGeom prst="roundRect">
@@ -24545,7 +25005,7 @@
         </p:nvSpPr>
         <p:spPr>
           <a:xfrm>
-            <a:off x="5573683" y="4288536"/>
+            <a:off x="5573683" y="4069080"/>
             <a:ext cx="448222" cy="237744"/>
           </a:xfrm>
           <a:prstGeom prst="rect">
@@ -24590,7 +25050,7 @@
         </p:nvSpPr>
         <p:spPr>
           <a:xfrm>
-            <a:off x="6085913" y="4288536"/>
+            <a:off x="6085913" y="4069080"/>
             <a:ext cx="381886" cy="237744"/>
           </a:xfrm>
           <a:prstGeom prst="roundRect">
@@ -24638,7 +25098,7 @@
         </p:nvSpPr>
         <p:spPr>
           <a:xfrm>
-            <a:off x="6085913" y="4288536"/>
+            <a:off x="6085913" y="4069080"/>
             <a:ext cx="381886" cy="237744"/>
           </a:xfrm>
           <a:prstGeom prst="rect">
@@ -24683,7 +25143,7 @@
         </p:nvSpPr>
         <p:spPr>
           <a:xfrm>
-            <a:off x="6531808" y="4288536"/>
+            <a:off x="6531808" y="4069080"/>
             <a:ext cx="846235" cy="237744"/>
           </a:xfrm>
           <a:prstGeom prst="roundRect">
@@ -24731,7 +25191,7 @@
         </p:nvSpPr>
         <p:spPr>
           <a:xfrm>
-            <a:off x="6531808" y="4288536"/>
+            <a:off x="6531808" y="4069080"/>
             <a:ext cx="846235" cy="237744"/>
           </a:xfrm>
           <a:prstGeom prst="rect">
@@ -24776,7 +25236,7 @@
         </p:nvSpPr>
         <p:spPr>
           <a:xfrm>
-            <a:off x="7442052" y="4288536"/>
+            <a:off x="7442052" y="4069080"/>
             <a:ext cx="978906" cy="237744"/>
           </a:xfrm>
           <a:prstGeom prst="roundRect">
@@ -24824,7 +25284,7 @@
         </p:nvSpPr>
         <p:spPr>
           <a:xfrm>
-            <a:off x="7442052" y="4288536"/>
+            <a:off x="7442052" y="4069080"/>
             <a:ext cx="978906" cy="237744"/>
           </a:xfrm>
           <a:prstGeom prst="rect">
@@ -24869,7 +25329,7 @@
         </p:nvSpPr>
         <p:spPr>
           <a:xfrm>
-            <a:off x="4663440" y="4617720"/>
+            <a:off x="4663440" y="4398264"/>
             <a:ext cx="3931919" cy="274320"/>
           </a:xfrm>
           <a:prstGeom prst="rect">
@@ -24923,8 +25383,8 @@
         </p:nvSpPr>
         <p:spPr>
           <a:xfrm>
-            <a:off x="365760" y="4937760"/>
-            <a:ext cx="8412480" cy="128016"/>
+            <a:off x="365760" y="4773168"/>
+            <a:ext cx="8412480" cy="201168"/>
           </a:xfrm>
           <a:prstGeom prst="rect">
             <a:avLst/>
@@ -24949,9 +25409,9 @@
               </a:spcAft>
             </a:pPr>
             <a:r>
-              <a:rPr sz="750" i="0">
-                <a:solidFill>
-                  <a:srgbClr val="5B6778"/>
+              <a:rPr sz="900" i="0">
+                <a:solidFill>
+                  <a:srgbClr val="3F4B5B"/>
                 </a:solidFill>
                 <a:latin typeface="Avenir Next"/>
               </a:rPr>

</xml_diff>

<commit_message>
docs(deck): benchmark slides read combined.md (185 cases, 3 runs); new live URL and QR; notes refreshed
Co-Authored-By: Claude Sonnet 5.5 <noreply@anthropic.com>
</commit_message>
<xml_diff>
--- a/docs/submission/Scam-Shield-deck.pptx
+++ b/docs/submission/Scam-Shield-deck.pptx
@@ -955,7 +955,7 @@
           <a:lstStyle/>
           <a:p>
             <a:r>
-              <a:t>Real screenshots of the production app, captured by scripts/screenshots.ts from live checks (the example buttons run the same API as a typed message). Left to right: a fake KYC SMS with a look-alike bank link; a QR that encodes a payment request while the text says 'receive'; a genuine bank debit alert with 'No scam signs found' (not a guarantee); a Hinglish 'digital arrest' voice note judged in Hindi; the report dialog, which asks for Google sign-in before a report is added to the shared list (to stop fake reports).</a:t>
+              <a:t>Real screenshots of the production app, captured by scripts/screenshots.ts from live checks (the example buttons run the same API as a typed message). Strip under the screens: live benchmark, 185 cases over 3 runs: 98.3% accuracy, 100% scam recall, 3.3% false positives (3 of 90 genuine) (eval/results/combined.md; details on the next slide). Left to right: a fake KYC SMS with a look-alike bank link; a QR that encodes a payment request while the text says 'receive'; a genuine bank debit alert with 'No scam signs found' (not a guarantee); a Hinglish 'digital arrest' voice note judged in Hindi; the report dialog, which asks for Google sign-in before a report is added to the shared list (to stop fake reports).</a:t>
             </a:r>
           </a:p>
         </p:txBody>
@@ -1044,7 +1044,7 @@
           <a:lstStyle/>
           <a:p>
             <a:r>
-              <a:t>English run (2026-10-17): accuracy 100.0%, scam recall 100.0%, false-positive rate 0.0%, scam type correct 100.0%, errors 0 (eval/results/latest.md). Hindi run (2026-10-17): accuracy 100.0%, recall 100.0%, false positives 0.0%, type correct 100.0% (eval/results/run-hindi.md). Both runs were made against the live app with 50 synthetic cases in eval/cases.jsonl (45 text, 4 image, 1 audio; 26 scams over 13 scam types, 24 genuine), concurrency 1. Latency is wall-clock from request to response. The cases are few and were written by the authors, so real traffic will differ. The model for these runs was gemini-3.7-flash: eval/results/latest.md is identical to eval/results/run-gemini-3.7-flash-17oct.md, and gemini-3.7-flash is the API default (api/src/index.ts). Earlier comparison on gemini-3.8-flash (2026-10-16): accuracy 98.0%, false-positive rate 4.2%, image p95 33.8 s; that is why the default is gemini-3.7-flash, with gemini-2.5-flash as fallback. The first benchmark run exposed a real bug (the model did not know today's date and flagged 2026 dates as future); it was fixed and re-measured. This is a small synthetic sanity check, not a guarantee of real-world accuracy.</a:t>
+              <a:t>Benchmark, combined over 3 live runs of the production app (single source: eval/results/combined.md, written by eval/aggregate.ts): 185 synthetic cases over 3 live runs: 98.3% accuracy, 100% scam recall, 3.3% false positives (3 of 90 genuine). Scam type correct 96.7%; errors 0. Accuracy is 177 of 180 scored cases; the 5 ambiguous inputs are not scored as scam or genuine, and none was given a Scam verdict. Per run: v1 50 cases (2026-10-17): accuracy 100%, recall 100%, false positives 0%; v2 35 cases (2026-10-18): accuracy 93.3%, recall 100%, false positives 12.5%; v3 100 cases (2026-10-18): accuracy 99.0%, recall 100%, false positives 2.0%. v1 is the original 50 cases, v2 is 35 adversarial and look-alike cases (14 adversarial scams, 16 benign look-alikes, 5 ambiguous), v3 is 100 realistic cases (50 scams, 50 genuine). Nothing was tuned after v2 and v3 results were seen. The 3 false positives: l03 (scam-awareness forward that quotes a scam link); l08 (delivery update with a tracking link); v3g40 (friend asking for a short loan). Missed scams: none. All misses and false positives are listed in eval/results/combined.md. Latency (successful calls): text p50 4.5 s, p95 18.2 s over 179 cases; image p50 6.9 s, p95 8.6 s; audio 10.3 s (one case). Wall-clock from request to response, concurrency 1. Keyword baseline (eval/baseline.ts, about 30 rules, text only): on v2 94.1% accuracy against Gemini's 94.1% (the same score, with different mistakes; see eval/results/run-v2.md); on v3 84.0% accuracy and 72.0% recall against Gemini's 99.0% and 100% (eval/results/run-v3.md). A keyword filter does well on textbook scams; the harder sets are where the model adds value. History: the first run (2026-10-17, 50 cases, eval/results/latest.md) scored 100% accuracy, 100% recall, 0% false positives; it is a valid earlier run but not the headline, because 50 cases written by the authors could not show the weak spots that v2 and v3 probe. It also exposed a real bug (the model did not know today's date and flagged 2026 dates as future); that was fixed and re-measured. The Hindi run (2026-10-17, eval/results/run-hindi.md) used the same 50 cases with the interface in Hindi: accuracy 100%, recall 100%, false positives 0%, scam type correct 100%. Model choice: an earlier comparison on the first 50 cases with gemini-3.8-flash (2026-10-16) scored accuracy 98.0%, false-positive rate 4.2%, image p95 33.8 s; that is why the default is gemini-3.7-flash, with gemini-2.5-flash as fallback (api/src/index.ts). This is a synthetic sanity check written by the authors, not a guarantee of real-world accuracy.</a:t>
             </a:r>
           </a:p>
         </p:txBody>
@@ -1222,7 +1222,7 @@
           <a:lstStyle/>
           <a:p>
             <a:r>
-              <a:t>GitHub (public): https://github.com/Namans12/scam-shield . Live product: https://project-91260b43-6705-4176-b71.web.app (the QR code points here). The demo video link is a deliberate placeholder, highlighted in amber; before submitting, re-run the build with DECK_VIDEO_URL=https://... (DECK_VIDEO_URL=https://... bash scripts/build-deck.sh) or replace the text '[add the public video link here]' in the PPTX.</a:t>
+              <a:t>GitHub (public): https://github.com/Namans12/scam-shield . Live product: https://scam-shield-check.web.app (the QR code points here). The demo video link is a deliberate placeholder, highlighted in amber; before submitting, re-run the build with DECK_VIDEO_URL=https://... (DECK_VIDEO_URL=https://... bash scripts/build-deck.sh) or replace the text '[add the public video link here]' in the PPTX.</a:t>
             </a:r>
           </a:p>
         </p:txBody>
@@ -1400,7 +1400,7 @@
           <a:lstStyle/>
           <a:p>
             <a:r>
-              <a:t>Thank you. Team Scam Shield: Naman Shrimal. Live app: https://project-91260b43-6705-4176-b71.web.app ; code: https://github.com/Namans12/scam-shield .</a:t>
+              <a:t>Thank you. Team Scam Shield: Naman Shrimal. Live app: https://scam-shield-check.web.app ; code: https://github.com/Namans12/scam-shield .</a:t>
             </a:r>
           </a:p>
         </p:txBody>
@@ -1756,7 +1756,7 @@
           <a:lstStyle/>
           <a:p>
             <a:r>
-              <a:t>All features are live in the production app (https://project-91260b43-6705-4176-b71.web.app). The WebMCP tools check_message and report_scam are registered in web/src/webmcp/registerTools.ts; report_scam needs a person signed in with Google. Verdict names are Scam, Suspicious and No scam signs found.</a:t>
+              <a:t>All features are live in the production app (https://scam-shield-check.web.app). The WebMCP tools check_message and report_scam are registered in web/src/webmcp/registerTools.ts; report_scam needs a person signed in with Google. Verdict names are Scam, Suspicious and No scam signs found.</a:t>
             </a:r>
           </a:p>
         </p:txBody>
@@ -2112,7 +2112,7 @@
           <a:lstStyle/>
           <a:p>
             <a:r>
-              <a:t>Meaningful Gen AI: a single multimodal Gemini call on Vertex AI (api/src/gemini.ts; default model gemini-3.7-flash, automatic fallback gemini-2.5-flash, location global) reads text, image or audio. Output is schema-validated (zod schemas in shared/), every red flag quotes evidence, answers come in English or Hindi. Deterministic checks can only raise the verdict. WebMCP tools: check_message and report_scam (web/src/webmcp/registerTools.ts). Scalability: the API is a stateless Cloud Run service (concurrency 20, min 1, max 5 instances); the link scanner scales to zero (max 3) under its own service account with no roles; Firestore holds the shared scam list; Firebase Hosting, Auth and Storage in front. Test count: on 18 Oct 2026 the suites passed 595 tests (shared 14, web 226, linkscan 94, eval 5, api 256); a further 18 api tests need the Firestore emulator (Java) and were not run. Also used: Cloud Build and Artifact Registry for deploys, Cloud Text-to-Speech to generate the voice example.</a:t>
+              <a:t>Meaningful Gen AI: a single multimodal Gemini call on Vertex AI (api/src/gemini.ts; default model gemini-3.7-flash, automatic fallback gemini-2.5-flash, location global) reads text, image or audio. Output is schema-validated (zod schemas in shared/), every red flag quotes evidence, answers come in English or Hindi. Deterministic checks can only raise the verdict. WebMCP tools: check_message and report_scam (web/src/webmcp/registerTools.ts). Scalability: the API is a stateless Cloud Run service (concurrency 20, min 1, max 5 instances); the link scanner scales to zero (max 3) under its own service account with no roles; Firestore holds the shared scam list; Firebase Hosting, Auth and Storage in front. Test count: on 18 Oct 2026 the suites passed 595 tests (shared 14, web 226, linkscan 94, eval 5, api 256); a further 18 api tests need the Firestore emulator (Java) and were not run. Also used: Cloud Build and Artifact Registry for deploys, Cloud Text-to-Speech to generate the voice example. The live benchmark behind the slide-12 numbers: 185 synthetic cases over 3 live runs (eval/results/combined.md).</a:t>
             </a:r>
           </a:p>
         </p:txBody>
@@ -8616,11 +8616,11 @@
         <p:spPr>
           <a:xfrm>
             <a:off x="365760" y="1207008"/>
-            <a:ext cx="8412480" cy="3090672"/>
+            <a:ext cx="8412480" cy="2743200"/>
           </a:xfrm>
           <a:prstGeom prst="roundRect">
             <a:avLst>
-              <a:gd name="adj" fmla="val 3550"/>
+              <a:gd name="adj" fmla="val 4000"/>
             </a:avLst>
           </a:prstGeom>
           <a:solidFill>
@@ -8669,8 +8669,8 @@
         </p:blipFill>
         <p:spPr>
           <a:xfrm>
-            <a:off x="534402" y="1280160"/>
-            <a:ext cx="1480124" cy="2944368"/>
+            <a:off x="672302" y="1280160"/>
+            <a:ext cx="1314644" cy="2615184"/>
           </a:xfrm>
           <a:prstGeom prst="rect">
             <a:avLst/>
@@ -8693,8 +8693,8 @@
         </p:blipFill>
         <p:spPr>
           <a:xfrm>
-            <a:off x="2183170" y="1280160"/>
-            <a:ext cx="1480124" cy="2944368"/>
+            <a:off x="2293490" y="1280160"/>
+            <a:ext cx="1314644" cy="2615184"/>
           </a:xfrm>
           <a:prstGeom prst="rect">
             <a:avLst/>
@@ -8717,8 +8717,8 @@
         </p:blipFill>
         <p:spPr>
           <a:xfrm>
-            <a:off x="3831937" y="1280160"/>
-            <a:ext cx="1480124" cy="2944368"/>
+            <a:off x="3914677" y="1280160"/>
+            <a:ext cx="1314644" cy="2615184"/>
           </a:xfrm>
           <a:prstGeom prst="rect">
             <a:avLst/>
@@ -8741,8 +8741,8 @@
         </p:blipFill>
         <p:spPr>
           <a:xfrm>
-            <a:off x="5480705" y="1280160"/>
-            <a:ext cx="1480124" cy="2944368"/>
+            <a:off x="5535865" y="1280160"/>
+            <a:ext cx="1314644" cy="2615184"/>
           </a:xfrm>
           <a:prstGeom prst="rect">
             <a:avLst/>
@@ -8765,8 +8765,8 @@
         </p:blipFill>
         <p:spPr>
           <a:xfrm>
-            <a:off x="7129472" y="1280160"/>
-            <a:ext cx="1480124" cy="2944368"/>
+            <a:off x="7157052" y="1280160"/>
+            <a:ext cx="1314644" cy="2615184"/>
           </a:xfrm>
           <a:prstGeom prst="rect">
             <a:avLst/>
@@ -8781,8 +8781,8 @@
         </p:nvSpPr>
         <p:spPr>
           <a:xfrm>
-            <a:off x="486657" y="4407408"/>
-            <a:ext cx="1575615" cy="502920"/>
+            <a:off x="555607" y="4005072"/>
+            <a:ext cx="1548035" cy="502920"/>
           </a:xfrm>
           <a:prstGeom prst="rect">
             <a:avLst/>
@@ -8848,8 +8848,8 @@
         </p:nvSpPr>
         <p:spPr>
           <a:xfrm>
-            <a:off x="2135424" y="4407408"/>
-            <a:ext cx="1575615" cy="502920"/>
+            <a:off x="2176794" y="4005072"/>
+            <a:ext cx="1548035" cy="502920"/>
           </a:xfrm>
           <a:prstGeom prst="rect">
             <a:avLst/>
@@ -8915,8 +8915,8 @@
         </p:nvSpPr>
         <p:spPr>
           <a:xfrm>
-            <a:off x="3784192" y="4407408"/>
-            <a:ext cx="1575615" cy="502920"/>
+            <a:off x="3797982" y="4005072"/>
+            <a:ext cx="1548035" cy="502920"/>
           </a:xfrm>
           <a:prstGeom prst="rect">
             <a:avLst/>
@@ -8982,8 +8982,8 @@
         </p:nvSpPr>
         <p:spPr>
           <a:xfrm>
-            <a:off x="5432959" y="4407408"/>
-            <a:ext cx="1575615" cy="502920"/>
+            <a:off x="5419169" y="4005072"/>
+            <a:ext cx="1548035" cy="502920"/>
           </a:xfrm>
           <a:prstGeom prst="rect">
             <a:avLst/>
@@ -9049,8 +9049,8 @@
         </p:nvSpPr>
         <p:spPr>
           <a:xfrm>
-            <a:off x="7081727" y="4407408"/>
-            <a:ext cx="1575615" cy="502920"/>
+            <a:off x="7040357" y="4005072"/>
+            <a:ext cx="1548035" cy="502920"/>
           </a:xfrm>
           <a:prstGeom prst="rect">
             <a:avLst/>
@@ -9104,6 +9104,106 @@
                 <a:latin typeface="Avenir Next"/>
               </a:rPr>
               <a:t>Adds it to the shared scam list</a:t>
+            </a:r>
+          </a:p>
+        </p:txBody>
+      </p:sp>
+      <p:sp>
+        <p:nvSpPr>
+          <p:cNvPr id="147" name="Rounded Rectangle 146"/>
+          <p:cNvSpPr/>
+          <p:nvPr/>
+        </p:nvSpPr>
+        <p:spPr>
+          <a:xfrm>
+            <a:off x="365760" y="4626864"/>
+            <a:ext cx="8412480" cy="292608"/>
+          </a:xfrm>
+          <a:prstGeom prst="roundRect">
+            <a:avLst>
+              <a:gd name="adj" fmla="val 21874"/>
+            </a:avLst>
+          </a:prstGeom>
+          <a:solidFill>
+            <a:srgbClr val="081B32"/>
+          </a:solidFill>
+          <a:ln>
+            <a:noFill/>
+          </a:ln>
+          <a:effectLst/>
+        </p:spPr>
+        <p:style>
+          <a:lnRef idx="1">
+            <a:schemeClr val="accent1"/>
+          </a:lnRef>
+          <a:fillRef idx="3">
+            <a:schemeClr val="accent1"/>
+          </a:fillRef>
+          <a:effectRef idx="2">
+            <a:schemeClr val="accent1"/>
+          </a:effectRef>
+          <a:fontRef idx="minor">
+            <a:schemeClr val="lt1"/>
+          </a:fontRef>
+        </p:style>
+        <p:txBody>
+          <a:bodyPr rtlCol="0" anchor="ctr"/>
+          <a:lstStyle/>
+          <a:p>
+            <a:pPr algn="ctr"/>
+          </a:p>
+        </p:txBody>
+      </p:sp>
+      <p:sp>
+        <p:nvSpPr>
+          <p:cNvPr id="148" name="TextBox 147"/>
+          <p:cNvSpPr txBox="1"/>
+          <p:nvPr/>
+        </p:nvSpPr>
+        <p:spPr>
+          <a:xfrm>
+            <a:off x="548640" y="4626864"/>
+            <a:ext cx="8046719" cy="292608"/>
+          </a:xfrm>
+          <a:prstGeom prst="rect">
+            <a:avLst/>
+          </a:prstGeom>
+          <a:noFill/>
+        </p:spPr>
+        <p:txBody>
+          <a:bodyPr wrap="square" anchor="ctr" lIns="0" rIns="0" tIns="0" bIns="0">
+            <a:spAutoFit/>
+          </a:bodyPr>
+          <a:lstStyle/>
+          <a:p>
+            <a:pPr algn="ctr">
+              <a:lnSpc>
+                <a:spcPct val="100000"/>
+              </a:lnSpc>
+              <a:spcBef>
+                <a:spcPts val="0"/>
+              </a:spcBef>
+              <a:spcAft>
+                <a:spcPts val="0"/>
+              </a:spcAft>
+            </a:pPr>
+            <a:r>
+              <a:rPr sz="1050" i="0">
+                <a:solidFill>
+                  <a:srgbClr val="34C9E8"/>
+                </a:solidFill>
+                <a:latin typeface="Avenir Next Demi Bold"/>
+              </a:rPr>
+              <a:t>Live benchmark, </a:t>
+            </a:r>
+            <a:r>
+              <a:rPr sz="1050" i="0">
+                <a:solidFill>
+                  <a:srgbClr val="FFFFFF"/>
+                </a:solidFill>
+                <a:latin typeface="Avenir Next"/>
+              </a:rPr>
+              <a:t>185 cases over 3 runs: 98.3% accuracy, 100% scam recall, 3.3% false positives (3 of 90 genuine)</a:t>
             </a:r>
           </a:p>
         </p:txBody>
@@ -9295,11 +9395,11 @@
         <p:spPr>
           <a:xfrm>
             <a:off x="365760" y="1207008"/>
-            <a:ext cx="1965960" cy="768096"/>
+            <a:ext cx="1965960" cy="731520"/>
           </a:xfrm>
           <a:prstGeom prst="roundRect">
             <a:avLst>
-              <a:gd name="adj" fmla="val 8333"/>
+              <a:gd name="adj" fmla="val 8750"/>
             </a:avLst>
           </a:prstGeom>
           <a:solidFill>
@@ -9342,7 +9442,7 @@
         </p:nvSpPr>
         <p:spPr>
           <a:xfrm>
-            <a:off x="365760" y="1271016"/>
+            <a:off x="365760" y="1261872"/>
             <a:ext cx="1965960" cy="384048"/>
           </a:xfrm>
           <a:prstGeom prst="rect">
@@ -9374,7 +9474,7 @@
                 </a:solidFill>
                 <a:latin typeface="Avenir Next Demi Bold"/>
               </a:rPr>
-              <a:t>100.0%</a:t>
+              <a:t>98.3%</a:t>
             </a:r>
           </a:p>
         </p:txBody>
@@ -9387,7 +9487,7 @@
         </p:nvSpPr>
         <p:spPr>
           <a:xfrm>
-            <a:off x="365760" y="1664208"/>
+            <a:off x="365760" y="1645920"/>
             <a:ext cx="1965960" cy="237744"/>
           </a:xfrm>
           <a:prstGeom prst="rect">
@@ -9433,11 +9533,11 @@
         <p:spPr>
           <a:xfrm>
             <a:off x="2514600" y="1207008"/>
-            <a:ext cx="1965960" cy="768096"/>
+            <a:ext cx="1965960" cy="731520"/>
           </a:xfrm>
           <a:prstGeom prst="roundRect">
             <a:avLst>
-              <a:gd name="adj" fmla="val 8333"/>
+              <a:gd name="adj" fmla="val 8750"/>
             </a:avLst>
           </a:prstGeom>
           <a:solidFill>
@@ -9480,7 +9580,7 @@
         </p:nvSpPr>
         <p:spPr>
           <a:xfrm>
-            <a:off x="2514600" y="1271016"/>
+            <a:off x="2514600" y="1261872"/>
             <a:ext cx="1965960" cy="384048"/>
           </a:xfrm>
           <a:prstGeom prst="rect">
@@ -9512,7 +9612,7 @@
                 </a:solidFill>
                 <a:latin typeface="Avenir Next Demi Bold"/>
               </a:rPr>
-              <a:t>100.0%</a:t>
+              <a:t>100%</a:t>
             </a:r>
           </a:p>
         </p:txBody>
@@ -9525,7 +9625,7 @@
         </p:nvSpPr>
         <p:spPr>
           <a:xfrm>
-            <a:off x="2514600" y="1664208"/>
+            <a:off x="2514600" y="1645920"/>
             <a:ext cx="1965960" cy="237744"/>
           </a:xfrm>
           <a:prstGeom prst="rect">
@@ -9571,11 +9671,11 @@
         <p:spPr>
           <a:xfrm>
             <a:off x="4663440" y="1207008"/>
-            <a:ext cx="1965960" cy="768096"/>
+            <a:ext cx="1965960" cy="731520"/>
           </a:xfrm>
           <a:prstGeom prst="roundRect">
             <a:avLst>
-              <a:gd name="adj" fmla="val 8333"/>
+              <a:gd name="adj" fmla="val 8750"/>
             </a:avLst>
           </a:prstGeom>
           <a:solidFill>
@@ -9618,7 +9718,7 @@
         </p:nvSpPr>
         <p:spPr>
           <a:xfrm>
-            <a:off x="4663440" y="1271016"/>
+            <a:off x="4663440" y="1261872"/>
             <a:ext cx="1965960" cy="384048"/>
           </a:xfrm>
           <a:prstGeom prst="rect">
@@ -9650,7 +9750,7 @@
                 </a:solidFill>
                 <a:latin typeface="Avenir Next Demi Bold"/>
               </a:rPr>
-              <a:t>0.0%</a:t>
+              <a:t>3.3%</a:t>
             </a:r>
           </a:p>
         </p:txBody>
@@ -9663,7 +9763,7 @@
         </p:nvSpPr>
         <p:spPr>
           <a:xfrm>
-            <a:off x="4663440" y="1664208"/>
+            <a:off x="4663440" y="1645920"/>
             <a:ext cx="1965960" cy="237744"/>
           </a:xfrm>
           <a:prstGeom prst="rect">
@@ -9709,11 +9809,11 @@
         <p:spPr>
           <a:xfrm>
             <a:off x="6812280" y="1207008"/>
-            <a:ext cx="1965960" cy="768096"/>
+            <a:ext cx="1965960" cy="731520"/>
           </a:xfrm>
           <a:prstGeom prst="roundRect">
             <a:avLst>
-              <a:gd name="adj" fmla="val 8333"/>
+              <a:gd name="adj" fmla="val 8750"/>
             </a:avLst>
           </a:prstGeom>
           <a:solidFill>
@@ -9756,7 +9856,7 @@
         </p:nvSpPr>
         <p:spPr>
           <a:xfrm>
-            <a:off x="6812280" y="1271016"/>
+            <a:off x="6812280" y="1261872"/>
             <a:ext cx="1965960" cy="384048"/>
           </a:xfrm>
           <a:prstGeom prst="rect">
@@ -9788,7 +9888,7 @@
                 </a:solidFill>
                 <a:latin typeface="Avenir Next Demi Bold"/>
               </a:rPr>
-              <a:t>100.0%</a:t>
+              <a:t>96.7%</a:t>
             </a:r>
           </a:p>
         </p:txBody>
@@ -9801,7 +9901,7 @@
         </p:nvSpPr>
         <p:spPr>
           <a:xfrm>
-            <a:off x="6812280" y="1664208"/>
+            <a:off x="6812280" y="1645920"/>
             <a:ext cx="1965960" cy="237744"/>
           </a:xfrm>
           <a:prstGeom prst="rect">
@@ -9846,7 +9946,7 @@
         </p:nvSpPr>
         <p:spPr>
           <a:xfrm>
-            <a:off x="365760" y="2039112"/>
+            <a:off x="365760" y="1993392"/>
             <a:ext cx="8412480" cy="201168"/>
           </a:xfrm>
           <a:prstGeom prst="rect">
@@ -9872,13 +9972,13 @@
               </a:spcAft>
             </a:pPr>
             <a:r>
-              <a:rPr sz="1150" i="0">
+              <a:rPr sz="1100" i="0">
                 <a:solidFill>
                   <a:srgbClr val="3F4B5B"/>
                 </a:solidFill>
                 <a:latin typeface="Avenir Next"/>
               </a:rPr>
-              <a:t>English run, 2026-10-17, 50 synthetic test cases, live app</a:t>
+              <a:t>185 synthetic cases over 3 live runs: 90 scams, 90 genuine, 5 ambiguous (not scored). Accuracy is 177 of 180 scored.</a:t>
             </a:r>
           </a:p>
         </p:txBody>
@@ -9892,8 +9992,8 @@
           <p:nvPr/>
         </p:nvGraphicFramePr>
         <p:xfrm>
-          <a:off x="365760" y="2304288"/>
-          <a:ext cx="5074920" cy="1097280"/>
+          <a:off x="365760" y="2240280"/>
+          <a:ext cx="5074920" cy="1280160"/>
         </p:xfrm>
         <a:graphic>
           <a:graphicData uri="http://schemas.openxmlformats.org/drawingml/2006/table">
@@ -9902,14 +10002,13 @@
                 <a:tableStyleId>{5C22544A-7EE6-4342-B048-85BDC9FD1C3A}</a:tableStyleId>
               </a:tblPr>
               <a:tblGrid>
-                <a:gridCol w="731520"/>
+                <a:gridCol w="1417320"/>
                 <a:gridCol w="548640"/>
-                <a:gridCol w="948690"/>
-                <a:gridCol w="948690"/>
-                <a:gridCol w="948690"/>
-                <a:gridCol w="948690"/>
+                <a:gridCol w="822960"/>
+                <a:gridCol w="960120"/>
+                <a:gridCol w="1325880"/>
               </a:tblGrid>
-              <a:tr h="274320">
+              <a:tr h="256032">
                 <a:tc>
                   <a:txBody>
                     <a:bodyPr/>
@@ -9917,13 +10016,13 @@
                     <a:p>
                       <a:pPr algn="l"/>
                       <a:r>
-                        <a:rPr sz="1150" i="0">
+                        <a:rPr sz="1100" i="0">
                           <a:solidFill>
                             <a:srgbClr val="FFFFFF"/>
                           </a:solidFill>
                           <a:latin typeface="Avenir Next Demi Bold"/>
                         </a:rPr>
-                        <a:t>Input</a:t>
+                        <a:t>Run</a:t>
                       </a:r>
                     </a:p>
                   </a:txBody>
@@ -9940,7 +10039,7 @@
                     <a:p>
                       <a:pPr algn="ctr"/>
                       <a:r>
-                        <a:rPr sz="1150" i="0">
+                        <a:rPr sz="1100" i="0">
                           <a:solidFill>
                             <a:srgbClr val="FFFFFF"/>
                           </a:solidFill>
@@ -9963,13 +10062,13 @@
                     <a:p>
                       <a:pPr algn="ctr"/>
                       <a:r>
-                        <a:rPr sz="1150" i="0">
+                        <a:rPr sz="1100" i="0">
                           <a:solidFill>
                             <a:srgbClr val="FFFFFF"/>
                           </a:solidFill>
                           <a:latin typeface="Avenir Next Demi Bold"/>
                         </a:rPr>
-                        <a:t>English p50</a:t>
+                        <a:t>Accuracy</a:t>
                       </a:r>
                     </a:p>
                   </a:txBody>
@@ -9986,13 +10085,13 @@
                     <a:p>
                       <a:pPr algn="ctr"/>
                       <a:r>
-                        <a:rPr sz="1150" i="0">
+                        <a:rPr sz="1100" i="0">
                           <a:solidFill>
                             <a:srgbClr val="FFFFFF"/>
                           </a:solidFill>
                           <a:latin typeface="Avenir Next Demi Bold"/>
                         </a:rPr>
-                        <a:t>English p95</a:t>
+                        <a:t>Scam recall</a:t>
                       </a:r>
                     </a:p>
                   </a:txBody>
@@ -10009,36 +10108,13 @@
                     <a:p>
                       <a:pPr algn="ctr"/>
                       <a:r>
-                        <a:rPr sz="1150" i="0">
+                        <a:rPr sz="1100" i="0">
                           <a:solidFill>
                             <a:srgbClr val="FFFFFF"/>
                           </a:solidFill>
                           <a:latin typeface="Avenir Next Demi Bold"/>
                         </a:rPr>
-                        <a:t>Hindi p50</a:t>
-                      </a:r>
-                    </a:p>
-                  </a:txBody>
-                  <a:tcPr marL="54864" marR="54864" marT="18288" marB="18288" anchor="ctr">
-                    <a:solidFill>
-                      <a:srgbClr val="081B32"/>
-                    </a:solidFill>
-                  </a:tcPr>
-                </a:tc>
-                <a:tc>
-                  <a:txBody>
-                    <a:bodyPr/>
-                    <a:lstStyle/>
-                    <a:p>
-                      <a:pPr algn="ctr"/>
-                      <a:r>
-                        <a:rPr sz="1150" i="0">
-                          <a:solidFill>
-                            <a:srgbClr val="FFFFFF"/>
-                          </a:solidFill>
-                          <a:latin typeface="Avenir Next Demi Bold"/>
-                        </a:rPr>
-                        <a:t>Hindi p95</a:t>
+                        <a:t>False positives</a:t>
                       </a:r>
                     </a:p>
                   </a:txBody>
@@ -10049,7 +10125,7 @@
                   </a:tcPr>
                 </a:tc>
               </a:tr>
-              <a:tr h="274320">
+              <a:tr h="256032">
                 <a:tc>
                   <a:txBody>
                     <a:bodyPr/>
@@ -10057,13 +10133,13 @@
                     <a:p>
                       <a:pPr algn="l"/>
                       <a:r>
-                        <a:rPr sz="1150" i="0">
+                        <a:rPr sz="1100" i="0">
                           <a:solidFill>
                             <a:srgbClr val="0B1F33"/>
                           </a:solidFill>
                           <a:latin typeface="Avenir Next Demi Bold"/>
                         </a:rPr>
-                        <a:t>Text</a:t>
+                        <a:t>v1  original</a:t>
                       </a:r>
                     </a:p>
                   </a:txBody>
@@ -10080,13 +10156,13 @@
                     <a:p>
                       <a:pPr algn="ctr"/>
                       <a:r>
-                        <a:rPr sz="1150" i="0">
+                        <a:rPr sz="1100" i="0">
                           <a:solidFill>
                             <a:srgbClr val="0B1F33"/>
                           </a:solidFill>
                           <a:latin typeface="Avenir Next"/>
                         </a:rPr>
-                        <a:t>45</a:t>
+                        <a:t>50</a:t>
                       </a:r>
                     </a:p>
                   </a:txBody>
@@ -10103,13 +10179,13 @@
                     <a:p>
                       <a:pPr algn="ctr"/>
                       <a:r>
-                        <a:rPr sz="1150" i="0">
+                        <a:rPr sz="1100" i="0">
                           <a:solidFill>
                             <a:srgbClr val="0B1F33"/>
                           </a:solidFill>
                           <a:latin typeface="Avenir Next"/>
                         </a:rPr>
-                        <a:t>4.5 s</a:t>
+                        <a:t>100%</a:t>
                       </a:r>
                     </a:p>
                   </a:txBody>
@@ -10126,13 +10202,13 @@
                     <a:p>
                       <a:pPr algn="ctr"/>
                       <a:r>
-                        <a:rPr sz="1150" i="0">
+                        <a:rPr sz="1100" i="0">
                           <a:solidFill>
                             <a:srgbClr val="0B1F33"/>
                           </a:solidFill>
                           <a:latin typeface="Avenir Next"/>
                         </a:rPr>
-                        <a:t>20.8 s</a:t>
+                        <a:t>100%</a:t>
                       </a:r>
                     </a:p>
                   </a:txBody>
@@ -10149,13 +10225,155 @@
                     <a:p>
                       <a:pPr algn="ctr"/>
                       <a:r>
-                        <a:rPr sz="1150" i="0">
+                        <a:rPr sz="1100" i="0">
                           <a:solidFill>
                             <a:srgbClr val="0B1F33"/>
                           </a:solidFill>
                           <a:latin typeface="Avenir Next"/>
                         </a:rPr>
-                        <a:t>5.0 s</a:t>
+                        <a:t>0%</a:t>
+                      </a:r>
+                    </a:p>
+                  </a:txBody>
+                  <a:tcPr marL="54864" marR="54864" marT="18288" marB="18288" anchor="ctr">
+                    <a:solidFill>
+                      <a:srgbClr val="F1F5FB"/>
+                    </a:solidFill>
+                  </a:tcPr>
+                </a:tc>
+              </a:tr>
+              <a:tr h="256032">
+                <a:tc>
+                  <a:txBody>
+                    <a:bodyPr/>
+                    <a:lstStyle/>
+                    <a:p>
+                      <a:pPr algn="l"/>
+                      <a:r>
+                        <a:rPr sz="1100" i="0">
+                          <a:solidFill>
+                            <a:srgbClr val="0B1F33"/>
+                          </a:solidFill>
+                          <a:latin typeface="Avenir Next Demi Bold"/>
+                        </a:rPr>
+                        <a:t>v2  harder cases</a:t>
+                      </a:r>
+                    </a:p>
+                  </a:txBody>
+                  <a:tcPr marL="54864" marR="54864" marT="18288" marB="18288" anchor="ctr">
+                    <a:solidFill>
+                      <a:srgbClr val="FFFFFF"/>
+                    </a:solidFill>
+                  </a:tcPr>
+                </a:tc>
+                <a:tc>
+                  <a:txBody>
+                    <a:bodyPr/>
+                    <a:lstStyle/>
+                    <a:p>
+                      <a:pPr algn="ctr"/>
+                      <a:r>
+                        <a:rPr sz="1100" i="0">
+                          <a:solidFill>
+                            <a:srgbClr val="0B1F33"/>
+                          </a:solidFill>
+                          <a:latin typeface="Avenir Next"/>
+                        </a:rPr>
+                        <a:t>35</a:t>
+                      </a:r>
+                    </a:p>
+                  </a:txBody>
+                  <a:tcPr marL="54864" marR="54864" marT="18288" marB="18288" anchor="ctr">
+                    <a:solidFill>
+                      <a:srgbClr val="FFFFFF"/>
+                    </a:solidFill>
+                  </a:tcPr>
+                </a:tc>
+                <a:tc>
+                  <a:txBody>
+                    <a:bodyPr/>
+                    <a:lstStyle/>
+                    <a:p>
+                      <a:pPr algn="ctr"/>
+                      <a:r>
+                        <a:rPr sz="1100" i="0">
+                          <a:solidFill>
+                            <a:srgbClr val="0B1F33"/>
+                          </a:solidFill>
+                          <a:latin typeface="Avenir Next"/>
+                        </a:rPr>
+                        <a:t>93.3%</a:t>
+                      </a:r>
+                    </a:p>
+                  </a:txBody>
+                  <a:tcPr marL="54864" marR="54864" marT="18288" marB="18288" anchor="ctr">
+                    <a:solidFill>
+                      <a:srgbClr val="FFFFFF"/>
+                    </a:solidFill>
+                  </a:tcPr>
+                </a:tc>
+                <a:tc>
+                  <a:txBody>
+                    <a:bodyPr/>
+                    <a:lstStyle/>
+                    <a:p>
+                      <a:pPr algn="ctr"/>
+                      <a:r>
+                        <a:rPr sz="1100" i="0">
+                          <a:solidFill>
+                            <a:srgbClr val="0B1F33"/>
+                          </a:solidFill>
+                          <a:latin typeface="Avenir Next"/>
+                        </a:rPr>
+                        <a:t>100%</a:t>
+                      </a:r>
+                    </a:p>
+                  </a:txBody>
+                  <a:tcPr marL="54864" marR="54864" marT="18288" marB="18288" anchor="ctr">
+                    <a:solidFill>
+                      <a:srgbClr val="FFFFFF"/>
+                    </a:solidFill>
+                  </a:tcPr>
+                </a:tc>
+                <a:tc>
+                  <a:txBody>
+                    <a:bodyPr/>
+                    <a:lstStyle/>
+                    <a:p>
+                      <a:pPr algn="ctr"/>
+                      <a:r>
+                        <a:rPr sz="1100" i="0">
+                          <a:solidFill>
+                            <a:srgbClr val="0B1F33"/>
+                          </a:solidFill>
+                          <a:latin typeface="Avenir Next"/>
+                        </a:rPr>
+                        <a:t>12.5%</a:t>
+                      </a:r>
+                    </a:p>
+                  </a:txBody>
+                  <a:tcPr marL="54864" marR="54864" marT="18288" marB="18288" anchor="ctr">
+                    <a:solidFill>
+                      <a:srgbClr val="FFFFFF"/>
+                    </a:solidFill>
+                  </a:tcPr>
+                </a:tc>
+              </a:tr>
+              <a:tr h="256032">
+                <a:tc>
+                  <a:txBody>
+                    <a:bodyPr/>
+                    <a:lstStyle/>
+                    <a:p>
+                      <a:pPr algn="l"/>
+                      <a:r>
+                        <a:rPr sz="1100" i="0">
+                          <a:solidFill>
+                            <a:srgbClr val="0B1F33"/>
+                          </a:solidFill>
+                          <a:latin typeface="Avenir Next Demi Bold"/>
+                        </a:rPr>
+                        <a:t>v3  realistic</a:t>
                       </a:r>
                     </a:p>
                   </a:txBody>
@@ -10172,178 +10390,13 @@
                     <a:p>
                       <a:pPr algn="ctr"/>
                       <a:r>
-                        <a:rPr sz="1150" i="0">
+                        <a:rPr sz="1100" i="0">
                           <a:solidFill>
                             <a:srgbClr val="0B1F33"/>
                           </a:solidFill>
                           <a:latin typeface="Avenir Next"/>
                         </a:rPr>
-                        <a:t>8.6 s</a:t>
-                      </a:r>
-                    </a:p>
-                  </a:txBody>
-                  <a:tcPr marL="54864" marR="54864" marT="18288" marB="18288" anchor="ctr">
-                    <a:solidFill>
-                      <a:srgbClr val="F1F5FB"/>
-                    </a:solidFill>
-                  </a:tcPr>
-                </a:tc>
-              </a:tr>
-              <a:tr h="274320">
-                <a:tc>
-                  <a:txBody>
-                    <a:bodyPr/>
-                    <a:lstStyle/>
-                    <a:p>
-                      <a:pPr algn="l"/>
-                      <a:r>
-                        <a:rPr sz="1150" i="0">
-                          <a:solidFill>
-                            <a:srgbClr val="0B1F33"/>
-                          </a:solidFill>
-                          <a:latin typeface="Avenir Next Demi Bold"/>
-                        </a:rPr>
-                        <a:t>Image</a:t>
-                      </a:r>
-                    </a:p>
-                  </a:txBody>
-                  <a:tcPr marL="54864" marR="54864" marT="18288" marB="18288" anchor="ctr">
-                    <a:solidFill>
-                      <a:srgbClr val="FFFFFF"/>
-                    </a:solidFill>
-                  </a:tcPr>
-                </a:tc>
-                <a:tc>
-                  <a:txBody>
-                    <a:bodyPr/>
-                    <a:lstStyle/>
-                    <a:p>
-                      <a:pPr algn="ctr"/>
-                      <a:r>
-                        <a:rPr sz="1150" i="0">
-                          <a:solidFill>
-                            <a:srgbClr val="0B1F33"/>
-                          </a:solidFill>
-                          <a:latin typeface="Avenir Next"/>
-                        </a:rPr>
-                        <a:t>4</a:t>
-                      </a:r>
-                    </a:p>
-                  </a:txBody>
-                  <a:tcPr marL="54864" marR="54864" marT="18288" marB="18288" anchor="ctr">
-                    <a:solidFill>
-                      <a:srgbClr val="FFFFFF"/>
-                    </a:solidFill>
-                  </a:tcPr>
-                </a:tc>
-                <a:tc>
-                  <a:txBody>
-                    <a:bodyPr/>
-                    <a:lstStyle/>
-                    <a:p>
-                      <a:pPr algn="ctr"/>
-                      <a:r>
-                        <a:rPr sz="1150" i="0">
-                          <a:solidFill>
-                            <a:srgbClr val="0B1F33"/>
-                          </a:solidFill>
-                          <a:latin typeface="Avenir Next"/>
-                        </a:rPr>
-                        <a:t>7.3 s</a:t>
-                      </a:r>
-                    </a:p>
-                  </a:txBody>
-                  <a:tcPr marL="54864" marR="54864" marT="18288" marB="18288" anchor="ctr">
-                    <a:solidFill>
-                      <a:srgbClr val="FFFFFF"/>
-                    </a:solidFill>
-                  </a:tcPr>
-                </a:tc>
-                <a:tc>
-                  <a:txBody>
-                    <a:bodyPr/>
-                    <a:lstStyle/>
-                    <a:p>
-                      <a:pPr algn="ctr"/>
-                      <a:r>
-                        <a:rPr sz="1150" i="0">
-                          <a:solidFill>
-                            <a:srgbClr val="0B1F33"/>
-                          </a:solidFill>
-                          <a:latin typeface="Avenir Next"/>
-                        </a:rPr>
-                        <a:t>8.7 s</a:t>
-                      </a:r>
-                    </a:p>
-                  </a:txBody>
-                  <a:tcPr marL="54864" marR="54864" marT="18288" marB="18288" anchor="ctr">
-                    <a:solidFill>
-                      <a:srgbClr val="FFFFFF"/>
-                    </a:solidFill>
-                  </a:tcPr>
-                </a:tc>
-                <a:tc>
-                  <a:txBody>
-                    <a:bodyPr/>
-                    <a:lstStyle/>
-                    <a:p>
-                      <a:pPr algn="ctr"/>
-                      <a:r>
-                        <a:rPr sz="1150" i="0">
-                          <a:solidFill>
-                            <a:srgbClr val="0B1F33"/>
-                          </a:solidFill>
-                          <a:latin typeface="Avenir Next"/>
-                        </a:rPr>
-                        <a:t>8.0 s</a:t>
-                      </a:r>
-                    </a:p>
-                  </a:txBody>
-                  <a:tcPr marL="54864" marR="54864" marT="18288" marB="18288" anchor="ctr">
-                    <a:solidFill>
-                      <a:srgbClr val="FFFFFF"/>
-                    </a:solidFill>
-                  </a:tcPr>
-                </a:tc>
-                <a:tc>
-                  <a:txBody>
-                    <a:bodyPr/>
-                    <a:lstStyle/>
-                    <a:p>
-                      <a:pPr algn="ctr"/>
-                      <a:r>
-                        <a:rPr sz="1150" i="0">
-                          <a:solidFill>
-                            <a:srgbClr val="0B1F33"/>
-                          </a:solidFill>
-                          <a:latin typeface="Avenir Next"/>
-                        </a:rPr>
-                        <a:t>9.7 s</a:t>
-                      </a:r>
-                    </a:p>
-                  </a:txBody>
-                  <a:tcPr marL="54864" marR="54864" marT="18288" marB="18288" anchor="ctr">
-                    <a:solidFill>
-                      <a:srgbClr val="FFFFFF"/>
-                    </a:solidFill>
-                  </a:tcPr>
-                </a:tc>
-              </a:tr>
-              <a:tr h="274320">
-                <a:tc>
-                  <a:txBody>
-                    <a:bodyPr/>
-                    <a:lstStyle/>
-                    <a:p>
-                      <a:pPr algn="l"/>
-                      <a:r>
-                        <a:rPr sz="1150" i="0">
-                          <a:solidFill>
-                            <a:srgbClr val="0B1F33"/>
-                          </a:solidFill>
-                          <a:latin typeface="Avenir Next Demi Bold"/>
-                        </a:rPr>
-                        <a:t>Audio</a:t>
+                        <a:t>100</a:t>
                       </a:r>
                     </a:p>
                   </a:txBody>
@@ -10360,13 +10413,13 @@
                     <a:p>
                       <a:pPr algn="ctr"/>
                       <a:r>
-                        <a:rPr sz="1150" i="0">
+                        <a:rPr sz="1100" i="0">
                           <a:solidFill>
                             <a:srgbClr val="0B1F33"/>
                           </a:solidFill>
                           <a:latin typeface="Avenir Next"/>
                         </a:rPr>
-                        <a:t>1</a:t>
+                        <a:t>99.0%</a:t>
                       </a:r>
                     </a:p>
                   </a:txBody>
@@ -10383,13 +10436,13 @@
                     <a:p>
                       <a:pPr algn="ctr"/>
                       <a:r>
-                        <a:rPr sz="1150" i="0">
+                        <a:rPr sz="1100" i="0">
                           <a:solidFill>
                             <a:srgbClr val="0B1F33"/>
                           </a:solidFill>
                           <a:latin typeface="Avenir Next"/>
                         </a:rPr>
-                        <a:t>10.3 s</a:t>
+                        <a:t>100%</a:t>
                       </a:r>
                     </a:p>
                   </a:txBody>
@@ -10406,19 +10459,44 @@
                     <a:p>
                       <a:pPr algn="ctr"/>
                       <a:r>
-                        <a:rPr sz="1150" i="0">
+                        <a:rPr sz="1100" i="0">
                           <a:solidFill>
                             <a:srgbClr val="0B1F33"/>
                           </a:solidFill>
                           <a:latin typeface="Avenir Next"/>
                         </a:rPr>
-                        <a:t>10.3 s</a:t>
+                        <a:t>2.0%</a:t>
                       </a:r>
                     </a:p>
                   </a:txBody>
                   <a:tcPr marL="54864" marR="54864" marT="18288" marB="18288" anchor="ctr">
                     <a:solidFill>
                       <a:srgbClr val="F1F5FB"/>
+                    </a:solidFill>
+                  </a:tcPr>
+                </a:tc>
+              </a:tr>
+              <a:tr h="256032">
+                <a:tc>
+                  <a:txBody>
+                    <a:bodyPr/>
+                    <a:lstStyle/>
+                    <a:p>
+                      <a:pPr algn="l"/>
+                      <a:r>
+                        <a:rPr sz="1100" i="0">
+                          <a:solidFill>
+                            <a:srgbClr val="081B32"/>
+                          </a:solidFill>
+                          <a:latin typeface="Avenir Next Demi Bold"/>
+                        </a:rPr>
+                        <a:t>Combined</a:t>
+                      </a:r>
+                    </a:p>
+                  </a:txBody>
+                  <a:tcPr marL="54864" marR="54864" marT="18288" marB="18288" anchor="ctr">
+                    <a:solidFill>
+                      <a:srgbClr val="E8F0FE"/>
                     </a:solidFill>
                   </a:tcPr>
                 </a:tc>
@@ -10429,19 +10507,19 @@
                     <a:p>
                       <a:pPr algn="ctr"/>
                       <a:r>
-                        <a:rPr sz="1150" i="0">
+                        <a:rPr sz="1100" i="0">
                           <a:solidFill>
-                            <a:srgbClr val="0B1F33"/>
+                            <a:srgbClr val="081B32"/>
                           </a:solidFill>
-                          <a:latin typeface="Avenir Next"/>
+                          <a:latin typeface="Avenir Next Demi Bold"/>
                         </a:rPr>
-                        <a:t>11.6 s</a:t>
+                        <a:t>185</a:t>
                       </a:r>
                     </a:p>
                   </a:txBody>
                   <a:tcPr marL="54864" marR="54864" marT="18288" marB="18288" anchor="ctr">
                     <a:solidFill>
-                      <a:srgbClr val="F1F5FB"/>
+                      <a:srgbClr val="E8F0FE"/>
                     </a:solidFill>
                   </a:tcPr>
                 </a:tc>
@@ -10452,19 +10530,65 @@
                     <a:p>
                       <a:pPr algn="ctr"/>
                       <a:r>
-                        <a:rPr sz="1150" i="0">
+                        <a:rPr sz="1100" i="0">
                           <a:solidFill>
-                            <a:srgbClr val="0B1F33"/>
+                            <a:srgbClr val="081B32"/>
                           </a:solidFill>
-                          <a:latin typeface="Avenir Next"/>
+                          <a:latin typeface="Avenir Next Demi Bold"/>
                         </a:rPr>
-                        <a:t>11.6 s</a:t>
+                        <a:t>98.3%</a:t>
                       </a:r>
                     </a:p>
                   </a:txBody>
                   <a:tcPr marL="54864" marR="54864" marT="18288" marB="18288" anchor="ctr">
                     <a:solidFill>
-                      <a:srgbClr val="F1F5FB"/>
+                      <a:srgbClr val="E8F0FE"/>
+                    </a:solidFill>
+                  </a:tcPr>
+                </a:tc>
+                <a:tc>
+                  <a:txBody>
+                    <a:bodyPr/>
+                    <a:lstStyle/>
+                    <a:p>
+                      <a:pPr algn="ctr"/>
+                      <a:r>
+                        <a:rPr sz="1100" i="0">
+                          <a:solidFill>
+                            <a:srgbClr val="081B32"/>
+                          </a:solidFill>
+                          <a:latin typeface="Avenir Next Demi Bold"/>
+                        </a:rPr>
+                        <a:t>100%</a:t>
+                      </a:r>
+                    </a:p>
+                  </a:txBody>
+                  <a:tcPr marL="54864" marR="54864" marT="18288" marB="18288" anchor="ctr">
+                    <a:solidFill>
+                      <a:srgbClr val="E8F0FE"/>
+                    </a:solidFill>
+                  </a:tcPr>
+                </a:tc>
+                <a:tc>
+                  <a:txBody>
+                    <a:bodyPr/>
+                    <a:lstStyle/>
+                    <a:p>
+                      <a:pPr algn="ctr"/>
+                      <a:r>
+                        <a:rPr sz="1100" i="0">
+                          <a:solidFill>
+                            <a:srgbClr val="081B32"/>
+                          </a:solidFill>
+                          <a:latin typeface="Avenir Next Demi Bold"/>
+                        </a:rPr>
+                        <a:t>3.3%</a:t>
+                      </a:r>
+                    </a:p>
+                  </a:txBody>
+                  <a:tcPr marL="54864" marR="54864" marT="18288" marB="18288" anchor="ctr">
+                    <a:solidFill>
+                      <a:srgbClr val="E8F0FE"/>
                     </a:solidFill>
                   </a:tcPr>
                 </a:tc>
@@ -10475,18 +10599,99 @@
       </p:graphicFrame>
       <p:sp>
         <p:nvSpPr>
-          <p:cNvPr id="158" name="Rounded Rectangle 157"/>
+          <p:cNvPr id="158" name="TextBox 157"/>
+          <p:cNvSpPr txBox="1"/>
+          <p:nvPr/>
+        </p:nvSpPr>
+        <p:spPr>
+          <a:xfrm>
+            <a:off x="365760" y="3593592"/>
+            <a:ext cx="5074920" cy="384048"/>
+          </a:xfrm>
+          <a:prstGeom prst="rect">
+            <a:avLst/>
+          </a:prstGeom>
+          <a:noFill/>
+        </p:spPr>
+        <p:txBody>
+          <a:bodyPr wrap="square" anchor="t" lIns="0" rIns="0" tIns="0" bIns="0">
+            <a:spAutoFit/>
+          </a:bodyPr>
+          <a:lstStyle/>
+          <a:p>
+            <a:pPr algn="l">
+              <a:lnSpc>
+                <a:spcPct val="100000"/>
+              </a:lnSpc>
+              <a:spcBef>
+                <a:spcPts val="0"/>
+              </a:spcBef>
+              <a:spcAft>
+                <a:spcPts val="0"/>
+              </a:spcAft>
+            </a:pPr>
+            <a:r>
+              <a:rPr sz="1100" i="0">
+                <a:solidFill>
+                  <a:srgbClr val="081B32"/>
+                </a:solidFill>
+                <a:latin typeface="Avenir Next Demi Bold"/>
+              </a:rPr>
+              <a:t>Latency: </a:t>
+            </a:r>
+            <a:r>
+              <a:rPr sz="1100" i="0">
+                <a:solidFill>
+                  <a:srgbClr val="0B1F33"/>
+                </a:solidFill>
+                <a:latin typeface="Avenir Next"/>
+              </a:rPr>
+              <a:t>text p50 4.5 s, p95 18.2 s; image p50 6.9 s; voice 10.3 s. </a:t>
+            </a:r>
+            <a:r>
+              <a:rPr sz="1100" i="0">
+                <a:solidFill>
+                  <a:srgbClr val="081B32"/>
+                </a:solidFill>
+                <a:latin typeface="Avenir Next Demi Bold"/>
+              </a:rPr>
+              <a:t>Errors: </a:t>
+            </a:r>
+            <a:r>
+              <a:rPr sz="1100" i="0">
+                <a:solidFill>
+                  <a:srgbClr val="0B1F33"/>
+                </a:solidFill>
+                <a:latin typeface="Avenir Next"/>
+              </a:rPr>
+              <a:t>0. </a:t>
+            </a:r>
+            <a:r>
+              <a:rPr sz="1100" i="0">
+                <a:solidFill>
+                  <a:srgbClr val="3F4B5B"/>
+                </a:solidFill>
+                <a:latin typeface="Avenir Next"/>
+              </a:rPr>
+              <a:t>p50 is the median, p95 the slowest 5%.</a:t>
+            </a:r>
+          </a:p>
+        </p:txBody>
+      </p:sp>
+      <p:sp>
+        <p:nvSpPr>
+          <p:cNvPr id="159" name="Rounded Rectangle 158"/>
           <p:cNvSpPr/>
           <p:nvPr/>
         </p:nvSpPr>
         <p:spPr>
           <a:xfrm>
-            <a:off x="365760" y="3493008"/>
-            <a:ext cx="5074920" cy="457200"/>
+            <a:off x="365760" y="4014216"/>
+            <a:ext cx="5074920" cy="438912"/>
           </a:xfrm>
           <a:prstGeom prst="roundRect">
             <a:avLst>
-              <a:gd name="adj" fmla="val 14000"/>
+              <a:gd name="adj" fmla="val 14583"/>
             </a:avLst>
           </a:prstGeom>
           <a:solidFill>
@@ -10521,14 +10726,14 @@
       </p:sp>
       <p:sp>
         <p:nvSpPr>
-          <p:cNvPr id="159" name="TextBox 158"/>
+          <p:cNvPr id="160" name="TextBox 159"/>
           <p:cNvSpPr txBox="1"/>
           <p:nvPr/>
         </p:nvSpPr>
         <p:spPr>
           <a:xfrm>
-            <a:off x="512064" y="3493008"/>
-            <a:ext cx="4800600" cy="457200"/>
+            <a:off x="512064" y="4014216"/>
+            <a:ext cx="4800600" cy="438912"/>
           </a:xfrm>
           <a:prstGeom prst="rect">
             <a:avLst/>
@@ -10553,36 +10758,82 @@
               </a:spcAft>
             </a:pPr>
             <a:r>
-              <a:rPr sz="1150" i="0">
+              <a:rPr sz="1100" i="0">
                 <a:solidFill>
                   <a:srgbClr val="1764E8"/>
                 </a:solidFill>
                 <a:latin typeface="Avenir Next Demi Bold"/>
               </a:rPr>
-              <a:t>Hindi run: </a:t>
-            </a:r>
-            <a:r>
-              <a:rPr sz="1150" i="0">
+              <a:t>Keyword baseline: </a:t>
+            </a:r>
+            <a:r>
+              <a:rPr sz="1100" i="0">
                 <a:solidFill>
                   <a:srgbClr val="0B1F33"/>
                 </a:solidFill>
                 <a:latin typeface="Avenir Next"/>
               </a:rPr>
-              <a:t>accuracy 100.0%, scam recall 100.0%, false positives 0.0%, scam type correct 100.0%.</a:t>
-            </a:r>
-          </a:p>
-        </p:txBody>
-      </p:sp>
-      <p:sp>
-        <p:nvSpPr>
-          <p:cNvPr id="160" name="TextBox 159"/>
+              <a:t>v2 94.1%, the same as Gemini on text, with different mistakes; v3 84.0% accuracy and 72.0% recall (Gemini 99.0% and 100%).</a:t>
+            </a:r>
+          </a:p>
+        </p:txBody>
+      </p:sp>
+      <p:sp>
+        <p:nvSpPr>
+          <p:cNvPr id="161" name="Rounded Rectangle 160"/>
+          <p:cNvSpPr/>
+          <p:nvPr/>
+        </p:nvSpPr>
+        <p:spPr>
+          <a:xfrm>
+            <a:off x="365760" y="4507992"/>
+            <a:ext cx="5074920" cy="411479"/>
+          </a:xfrm>
+          <a:prstGeom prst="roundRect">
+            <a:avLst>
+              <a:gd name="adj" fmla="val 15555"/>
+            </a:avLst>
+          </a:prstGeom>
+          <a:solidFill>
+            <a:srgbClr val="F1F5FB"/>
+          </a:solidFill>
+          <a:ln>
+            <a:noFill/>
+          </a:ln>
+          <a:effectLst/>
+        </p:spPr>
+        <p:style>
+          <a:lnRef idx="1">
+            <a:schemeClr val="accent1"/>
+          </a:lnRef>
+          <a:fillRef idx="3">
+            <a:schemeClr val="accent1"/>
+          </a:fillRef>
+          <a:effectRef idx="2">
+            <a:schemeClr val="accent1"/>
+          </a:effectRef>
+          <a:fontRef idx="minor">
+            <a:schemeClr val="lt1"/>
+          </a:fontRef>
+        </p:style>
+        <p:txBody>
+          <a:bodyPr rtlCol="0" anchor="ctr"/>
+          <a:lstStyle/>
+          <a:p>
+            <a:pPr algn="ctr"/>
+          </a:p>
+        </p:txBody>
+      </p:sp>
+      <p:sp>
+        <p:nvSpPr>
+          <p:cNvPr id="162" name="TextBox 161"/>
           <p:cNvSpPr txBox="1"/>
           <p:nvPr/>
         </p:nvSpPr>
         <p:spPr>
           <a:xfrm>
-            <a:off x="365760" y="4041648"/>
-            <a:ext cx="5074920" cy="877824"/>
+            <a:off x="512064" y="4507992"/>
+            <a:ext cx="4800600" cy="411479"/>
           </a:xfrm>
           <a:prstGeom prst="rect">
             <a:avLst/>
@@ -10590,7 +10841,7 @@
           <a:noFill/>
         </p:spPr>
         <p:txBody>
-          <a:bodyPr wrap="square" anchor="t" lIns="0" rIns="0" tIns="0" bIns="0">
+          <a:bodyPr wrap="square" anchor="ctr" lIns="0" rIns="0" tIns="0" bIns="0">
             <a:spAutoFit/>
           </a:bodyPr>
           <a:lstStyle/>
@@ -10603,84 +10854,62 @@
                 <a:spcPts val="0"/>
               </a:spcBef>
               <a:spcAft>
-                <a:spcPts val="300"/>
+                <a:spcPts val="0"/>
               </a:spcAft>
             </a:pPr>
             <a:r>
-              <a:rPr sz="1150" i="0">
+              <a:rPr sz="1100" i="0">
                 <a:solidFill>
                   <a:srgbClr val="081B32"/>
                 </a:solidFill>
                 <a:latin typeface="Avenir Next Demi Bold"/>
               </a:rPr>
-              <a:t>Errors: </a:t>
-            </a:r>
-            <a:r>
-              <a:rPr sz="1150" i="0">
+              <a:t>First run, </a:t>
+            </a:r>
+            <a:r>
+              <a:rPr sz="1100" i="0">
                 <a:solidFill>
                   <a:srgbClr val="0B1F33"/>
                 </a:solidFill>
                 <a:latin typeface="Avenir Next"/>
               </a:rPr>
-              <a:t>0. </a:t>
-            </a:r>
-            <a:r>
-              <a:rPr sz="1150" i="0">
+              <a:t>50 cases: 100% accuracy, 100% recall, 0% false positives. </a:t>
+            </a:r>
+            <a:r>
+              <a:rPr sz="1100" i="0">
                 <a:solidFill>
                   <a:srgbClr val="081B32"/>
                 </a:solidFill>
                 <a:latin typeface="Avenir Next Demi Bold"/>
               </a:rPr>
-              <a:t>False positives: </a:t>
-            </a:r>
-            <a:r>
-              <a:rPr sz="1150" i="0">
+              <a:t>Hindi run, </a:t>
+            </a:r>
+            <a:r>
+              <a:rPr sz="1100" i="0">
                 <a:solidFill>
                   <a:srgbClr val="0B1F33"/>
                 </a:solidFill>
                 <a:latin typeface="Avenir Next"/>
               </a:rPr>
-              <a:t>none.</a:t>
-            </a:r>
-          </a:p>
-          <a:p>
-            <a:pPr algn="l">
-              <a:lnSpc>
-                <a:spcPct val="100000"/>
-              </a:lnSpc>
-              <a:spcBef>
-                <a:spcPts val="0"/>
-              </a:spcBef>
-              <a:spcAft>
-                <a:spcPts val="0"/>
-              </a:spcAft>
-            </a:pPr>
-            <a:r>
-              <a:rPr sz="1200" i="0">
-                <a:solidFill>
-                  <a:srgbClr val="3F4B5B"/>
-                </a:solidFill>
-                <a:latin typeface="Avenir Next"/>
-              </a:rPr>
-              <a:t>p50 is the median time, p95 the slowest 5%, in seconds on the live app. The image and voice rows have only 4 and 1 cases.</a:t>
-            </a:r>
-          </a:p>
-        </p:txBody>
-      </p:sp>
-      <p:sp>
-        <p:nvSpPr>
-          <p:cNvPr id="161" name="Rounded Rectangle 160"/>
+              <a:t>same 50 cases: 100%, 100%, 0%.</a:t>
+            </a:r>
+          </a:p>
+        </p:txBody>
+      </p:sp>
+      <p:sp>
+        <p:nvSpPr>
+          <p:cNvPr id="163" name="Rounded Rectangle 162"/>
           <p:cNvSpPr/>
           <p:nvPr/>
         </p:nvSpPr>
         <p:spPr>
           <a:xfrm>
-            <a:off x="5623560" y="2304288"/>
-            <a:ext cx="3154679" cy="2615184"/>
+            <a:off x="5623560" y="2240280"/>
+            <a:ext cx="3154679" cy="2679191"/>
           </a:xfrm>
           <a:prstGeom prst="roundRect">
             <a:avLst>
-              <a:gd name="adj" fmla="val 2447"/>
+              <a:gd name="adj" fmla="val 2389"/>
             </a:avLst>
           </a:prstGeom>
           <a:solidFill>
@@ -10717,13 +10946,13 @@
       </p:sp>
       <p:sp>
         <p:nvSpPr>
-          <p:cNvPr id="162" name="TextBox 161"/>
+          <p:cNvPr id="164" name="TextBox 163"/>
           <p:cNvSpPr txBox="1"/>
           <p:nvPr/>
         </p:nvSpPr>
         <p:spPr>
           <a:xfrm>
-            <a:off x="5788152" y="2414016"/>
+            <a:off x="5788152" y="2350008"/>
             <a:ext cx="2825495" cy="237744"/>
           </a:xfrm>
           <a:prstGeom prst="rect">
@@ -10762,14 +10991,14 @@
       </p:sp>
       <p:sp>
         <p:nvSpPr>
-          <p:cNvPr id="163" name="TextBox 162"/>
+          <p:cNvPr id="165" name="TextBox 164"/>
           <p:cNvSpPr txBox="1"/>
           <p:nvPr/>
         </p:nvSpPr>
         <p:spPr>
           <a:xfrm>
-            <a:off x="5788152" y="2715768"/>
-            <a:ext cx="2825495" cy="2157984"/>
+            <a:off x="5788152" y="2651760"/>
+            <a:ext cx="2825495" cy="2221991"/>
           </a:xfrm>
           <a:prstGeom prst="rect">
             <a:avLst/>
@@ -10799,22 +11028,22 @@
               <a:buChar char="•"/>
             </a:pPr>
             <a:r>
-              <a:rPr sz="1150" i="0">
+              <a:rPr sz="1100" i="0">
                 <a:solidFill>
                   <a:srgbClr val="081B32"/>
                 </a:solidFill>
                 <a:latin typeface="Avenir Next Demi Bold"/>
               </a:rPr>
-              <a:t>50 cases, written by the authors: </a:t>
-            </a:r>
-            <a:r>
-              <a:rPr sz="1150" i="0">
+              <a:t>185 cases, written by the authors: </a:t>
+            </a:r>
+            <a:r>
+              <a:rPr sz="1100" i="0">
                 <a:solidFill>
                   <a:srgbClr val="0B1F33"/>
                 </a:solidFill>
                 <a:latin typeface="Avenir Next"/>
               </a:rPr>
-              <a:t>a small test, not a guarantee; real traffic will differ. 26 scams over 13 types, 24 genuine.</a:t>
+              <a:t>a test, not a guarantee. 90 scams over 13 types, 90 genuine.</a:t>
             </a:r>
           </a:p>
           <a:p>
@@ -10835,22 +11064,22 @@
               <a:buChar char="•"/>
             </a:pPr>
             <a:r>
-              <a:rPr sz="1150" i="0">
+              <a:rPr sz="1100" i="0">
                 <a:solidFill>
                   <a:srgbClr val="081B32"/>
                 </a:solidFill>
                 <a:latin typeface="Avenir Next Demi Bold"/>
               </a:rPr>
-              <a:t>Why gemini-3.7-flash: </a:t>
-            </a:r>
-            <a:r>
-              <a:rPr sz="1150" i="0">
+              <a:t>3 false positives: </a:t>
+            </a:r>
+            <a:r>
+              <a:rPr sz="1100" i="0">
                 <a:solidFill>
                   <a:srgbClr val="0B1F33"/>
                 </a:solidFill>
                 <a:latin typeface="Avenir Next"/>
               </a:rPr>
-              <a:t>an earlier run on gemini-3.8-flash scored 98.0% accuracy with 4.2% false positives and image checks up to 34 s. Fallback: 2.5-flash.</a:t>
+              <a:t>scam-awareness forward that quotes a scam link, delivery update with a tracking link, friend asking for a short loan. All misses and false positives: eval/results/combined.md.</a:t>
             </a:r>
           </a:p>
           <a:p>
@@ -10871,22 +11100,22 @@
               <a:buChar char="•"/>
             </a:pPr>
             <a:r>
-              <a:rPr sz="1150" i="0">
+              <a:rPr sz="1100" i="0">
                 <a:solidFill>
                   <a:srgbClr val="081B32"/>
                 </a:solidFill>
                 <a:latin typeface="Avenir Next Demi Bold"/>
               </a:rPr>
-              <a:t>The first run found a real bug </a:t>
-            </a:r>
-            <a:r>
-              <a:rPr sz="1150" i="0">
+              <a:t>Why gemini-3.7-flash: </a:t>
+            </a:r>
+            <a:r>
+              <a:rPr sz="1100" i="0">
                 <a:solidFill>
                   <a:srgbClr val="0B1F33"/>
                 </a:solidFill>
                 <a:latin typeface="Avenir Next"/>
               </a:rPr>
-              <a:t>(the model did not know today's date); fixed and re-measured.</a:t>
+              <a:t>an earlier 50-case run on gemini-3.8-flash scored 98.0% accuracy with 4.2% false positives, image checks up to 34 s.</a:t>
             </a:r>
           </a:p>
         </p:txBody>
@@ -13240,7 +13469,7 @@
                 </a:solidFill>
                 <a:latin typeface="Avenir Next"/>
               </a:rPr>
-              <a:t>https://project-91260b43-6705-4176-b71.web.app</a:t>
+              <a:t>https://scam-shield-check.web.app</a:t>
             </a:r>
             <a:endParaRPr>
               <a:latin typeface="Google Sans Flex Medium"/>
@@ -14166,7 +14395,7 @@
                 </a:solidFill>
                 <a:latin typeface="Avenir Next"/>
               </a:rPr>
-              <a:t>project-91260b43-6705-4176-b71.web.app</a:t>
+              <a:t>scam-shield-check.web.app</a:t>
             </a:r>
           </a:p>
         </p:txBody>
@@ -25370,7 +25599,7 @@
                 </a:solidFill>
                 <a:latin typeface="Avenir Next"/>
               </a:rPr>
-              <a:t>, plus a 50-case live benchmark</a:t>
+              <a:t>, plus a 185-case live benchmark</a:t>
             </a:r>
           </a:p>
         </p:txBody>

</xml_diff>

<commit_message>
docs(deck): clearer baseline wording and spacing on slide 12
Co-Authored-By: Claude Sonnet 5.5 <noreply@anthropic.com>
</commit_message>
<xml_diff>
--- a/docs/submission/Scam-Shield-deck.pptx
+++ b/docs/submission/Scam-Shield-deck.pptx
@@ -10687,11 +10687,11 @@
         <p:spPr>
           <a:xfrm>
             <a:off x="365760" y="4014216"/>
-            <a:ext cx="5074920" cy="438912"/>
+            <a:ext cx="5074920" cy="530352"/>
           </a:xfrm>
           <a:prstGeom prst="roundRect">
             <a:avLst>
-              <a:gd name="adj" fmla="val 14583"/>
+              <a:gd name="adj" fmla="val 12068"/>
             </a:avLst>
           </a:prstGeom>
           <a:solidFill>
@@ -10733,7 +10733,7 @@
         <p:spPr>
           <a:xfrm>
             <a:off x="512064" y="4014216"/>
-            <a:ext cx="4800600" cy="438912"/>
+            <a:ext cx="4800600" cy="530352"/>
           </a:xfrm>
           <a:prstGeom prst="rect">
             <a:avLst/>
@@ -10773,7 +10773,7 @@
                 </a:solidFill>
                 <a:latin typeface="Avenir Next"/>
               </a:rPr>
-              <a:t>v2 94.1%, the same as Gemini on text, with different mistakes; v3 84.0% accuracy and 72.0% recall (Gemini 99.0% and 100%).</a:t>
+              <a:t>on v2's 34 text cases it scored 94.1%, the same as Gemini, with different mistakes; v3 84.0% accuracy and 72.0% recall (Gemini 99.0% and 100%).</a:t>
             </a:r>
           </a:p>
         </p:txBody>
@@ -10786,12 +10786,12 @@
         </p:nvSpPr>
         <p:spPr>
           <a:xfrm>
-            <a:off x="365760" y="4507992"/>
-            <a:ext cx="5074920" cy="411479"/>
+            <a:off x="365760" y="4599432"/>
+            <a:ext cx="5074920" cy="320039"/>
           </a:xfrm>
           <a:prstGeom prst="roundRect">
             <a:avLst>
-              <a:gd name="adj" fmla="val 15555"/>
+              <a:gd name="adj" fmla="val 20000"/>
             </a:avLst>
           </a:prstGeom>
           <a:solidFill>
@@ -10832,8 +10832,8 @@
         </p:nvSpPr>
         <p:spPr>
           <a:xfrm>
-            <a:off x="512064" y="4507992"/>
-            <a:ext cx="4800600" cy="411479"/>
+            <a:off x="512064" y="4599432"/>
+            <a:ext cx="4800600" cy="320039"/>
           </a:xfrm>
           <a:prstGeom prst="rect">
             <a:avLst/>

</xml_diff>

<commit_message>
docs(deck): primary live URL is now scam-shield-live.web.app (slides, notes, QR, submission docs)
Co-Authored-By: Claude Sonnet 5.5 <noreply@anthropic.com>
</commit_message>
<xml_diff>
--- a/docs/submission/Scam-Shield-deck.pptx
+++ b/docs/submission/Scam-Shield-deck.pptx
@@ -1222,7 +1222,7 @@
           <a:lstStyle/>
           <a:p>
             <a:r>
-              <a:t>GitHub (public): https://github.com/Namans12/scam-shield . Live product: https://scam-shield-check.web.app (the QR code points here). The demo video link is a deliberate placeholder, highlighted in amber; before submitting, re-run the build with DECK_VIDEO_URL=https://... (DECK_VIDEO_URL=https://... bash scripts/build-deck.sh) or replace the text '[add the public video link here]' in the PPTX.</a:t>
+              <a:t>GitHub (public): https://github.com/Namans12/scam-shield . Live product: https://scam-shield-live.web.app (the QR code points here). The demo video link is a deliberate placeholder, highlighted in amber; before submitting, re-run the build with DECK_VIDEO_URL=https://... (DECK_VIDEO_URL=https://... bash scripts/build-deck.sh) or replace the text '[add the public video link here]' in the PPTX.</a:t>
             </a:r>
           </a:p>
         </p:txBody>
@@ -1400,7 +1400,7 @@
           <a:lstStyle/>
           <a:p>
             <a:r>
-              <a:t>Thank you. Team Scam Shield: Naman Shrimal. Live app: https://scam-shield-check.web.app ; code: https://github.com/Namans12/scam-shield .</a:t>
+              <a:t>Thank you. Team Scam Shield: Naman Shrimal. Live app: https://scam-shield-live.web.app ; code: https://github.com/Namans12/scam-shield .</a:t>
             </a:r>
           </a:p>
         </p:txBody>
@@ -1756,7 +1756,7 @@
           <a:lstStyle/>
           <a:p>
             <a:r>
-              <a:t>All features are live in the production app (https://scam-shield-check.web.app). The WebMCP tools check_message and report_scam are registered in web/src/webmcp/registerTools.ts; report_scam needs a person signed in with Google. Verdict names are Scam, Suspicious and No scam signs found.</a:t>
+              <a:t>All features are live in the production app (https://scam-shield-live.web.app). The WebMCP tools check_message and report_scam are registered in web/src/webmcp/registerTools.ts; report_scam needs a person signed in with Google. Verdict names are Scam, Suspicious and No scam signs found.</a:t>
             </a:r>
           </a:p>
         </p:txBody>
@@ -13469,7 +13469,7 @@
                 </a:solidFill>
                 <a:latin typeface="Avenir Next"/>
               </a:rPr>
-              <a:t>https://scam-shield-check.web.app</a:t>
+              <a:t>https://scam-shield-live.web.app</a:t>
             </a:r>
             <a:endParaRPr>
               <a:latin typeface="Google Sans Flex Medium"/>
@@ -14395,7 +14395,7 @@
                 </a:solidFill>
                 <a:latin typeface="Avenir Next"/>
               </a:rPr>
-              <a:t>scam-shield-check.web.app</a:t>
+              <a:t>scam-shield-live.web.app</a:t>
             </a:r>
           </a:p>
         </p:txBody>

</xml_diff>

<commit_message>
docs: demo video link in README, deck slide 14 and docs
Co-Authored-By: Claude Sonnet 5.5 <noreply@anthropic.com>
</commit_message>
<xml_diff>
--- a/docs/submission/Scam-Shield-deck.pptx
+++ b/docs/submission/Scam-Shield-deck.pptx
@@ -1222,7 +1222,7 @@
           <a:lstStyle/>
           <a:p>
             <a:r>
-              <a:t>GitHub (public): https://github.com/Namans12/scam-shield . Live product: https://scam-shield-live.web.app (the QR code points here). The demo video link is a deliberate placeholder, highlighted in amber; before submitting, re-run the build with DECK_VIDEO_URL=https://... (DECK_VIDEO_URL=https://... bash scripts/build-deck.sh) or replace the text '[add the public video link here]' in the PPTX.</a:t>
+              <a:t>GitHub (public): https://github.com/Namans12/scam-shield . Live product: https://scam-shield-live.web.app (the QR code points here). Demo video (3 minutes): https://youtu.be/a678nAYddq0</a:t>
             </a:r>
           </a:p>
         </p:txBody>
@@ -13412,23 +13412,11 @@
             <a:r>
               <a:rPr sz="1400" i="0">
                 <a:solidFill>
-                  <a:srgbClr val="9A5B00"/>
-                </a:solidFill>
-                <a:highlight>
-                  <a:srgbClr val="FFE9A8"/>
-                </a:highlight>
-                <a:latin typeface="Avenir Next Demi Bold"/>
+                  <a:srgbClr val="1764E8"/>
+                </a:solidFill>
+                <a:latin typeface="Avenir Next"/>
               </a:rPr>
-              <a:t>[add the public video link here]</a:t>
-            </a:r>
-            <a:r>
-              <a:rPr sz="1150" i="0">
-                <a:solidFill>
-                  <a:srgbClr val="9A5B00"/>
-                </a:solidFill>
-                <a:latin typeface="Avenir Next Demi Bold"/>
-              </a:rPr>
-              <a:t>  PLACEHOLDER: owner to fill in</a:t>
+              <a:t>https://youtu.be/a678nAYddq0</a:t>
             </a:r>
             <a:endParaRPr>
               <a:latin typeface="Google Sans Flex Medium"/>

</xml_diff>

<commit_message>
docs(deck): team name is Nexustrip (the product stays Scam Shield)
Co-Authored-By: Claude Sonnet 5.5 <noreply@anthropic.com>
</commit_message>
<xml_diff>
--- a/docs/submission/Scam-Shield-deck.pptx
+++ b/docs/submission/Scam-Shield-deck.pptx
@@ -777,7 +777,7 @@
           <a:lstStyle/>
           <a:p>
             <a:r>
-              <a:t>Team: Scam Shield. Team leader: Naman Shrimal. Track: BFSI: Intelligent Risk, Fraud &amp; Financial Experiences. Community benefit: a free, plain-language check for anyone in India, in English or Hindi, and a shared scam list so each report warns the next person. The statement 'lose crores' is backed by slide 4 (about Rs 19,813 crore reported lost to cyber fraud in 2025, I4C data; see docs/submission/sources.md).</a:t>
+              <a:t>Team: Nexustrip (the product is Scam Shield). Team leader: Naman Shrimal. Track: BFSI: Intelligent Risk, Fraud &amp; Financial Experiences. Community benefit: a free, plain-language check for anyone in India, in English or Hindi, and a shared scam list so each report warns the next person. The statement 'lose crores' is backed by slide 4 (about Rs 19,813 crore reported lost to cyber fraud in 2025, I4C data; see docs/submission/sources.md).</a:t>
             </a:r>
           </a:p>
         </p:txBody>
@@ -6896,7 +6896,7 @@
                 </a:solidFill>
                 <a:latin typeface="Avenir Next Demi Bold"/>
               </a:rPr>
-              <a:t>Scam Shield</a:t>
+              <a:t>Nexustrip</a:t>
             </a:r>
             <a:endParaRPr sz="1800">
               <a:latin typeface="Google Sans Flex"/>

</xml_diff>